<commit_message>
Pricing 5 000 first hour + 2 000 each extra hour; deck: product demo, closing slide, transitions
- price rule (server, booking button, operator setup label, README): first started hour at the
  lot's price (5 000 so'm default), each further started hour 2 000 so'm; smoke test checks it
- deck (8 slides): new product demo slide 4 with app screenshots, Technology moves to slide 5
  without the quality check, accuracy card and night / rain lines; business slide with the new
  prices and the 50/50 split, no subscription; closing slide 'Thanks for watching'; Morph
  transition on every slide (Fade fallback); timings and talk plan updated

Co-Authored-By: Claude Opus 5.5 <noreply@anthropic.com>
Claude-Session: https://claude.ai/code/session_012xGpHDRSu2Z8JV7eYDeD26
</commit_message>
<xml_diff>
--- a/docs/ParkDet-defence.pptx
+++ b/docs/ParkDet-defence.pptx
@@ -11,9 +11,11 @@
     <p:sldId id="259" r:id="rId5"/>
     <p:sldId id="260" r:id="rId6"/>
     <p:sldId id="261" r:id="rId7"/>
+    <p:sldId id="262" r:id="rId8"/>
+    <p:sldId id="263" r:id="rId9"/>
   </p:sldIdLst>
   <p:notesMasterIdLst>
-    <p:notesMasterId r:id="rId8"/>
+    <p:notesMasterId r:id="rId10"/>
   </p:notesMasterIdLst>
   <p:sldSz cx="12192000" cy="6858000"/>
   <p:notesSz cx="6858000" cy="12192000"/>
@@ -112,30 +114,36 @@
   <p:extLst>
     <p:ext uri="{521415D9-36F7-43E2-AB2F-B90AF26B5E84}">
       <p14:sectionLst xmlns:p14="http://schemas.microsoft.com/office/powerpoint/2010/main">
-        <p14:section name="Problem and solution (1:00)" id="{ff9c6280-4a21-bcd0-dd80-04c34260d708}">
+        <p14:section name="Problem and solution (1:00)" id="{cda13f6f-1c41-2ae3-be3c-375c313ce19d}">
           <p14:sldIdLst>
             <p14:sldId id="256"/>
             <p14:sldId id="257"/>
           </p14:sldIdLst>
         </p14:section>
-        <p14:section name="Live demo (2:00)" id="{e1bd8d8b-23fa-6c0b-5e59-8253775619ce}">
+        <p14:section name="Demo (2:20)" id="{698f7b15-3bab-7340-404f-4a5be4cdb9b0}">
           <p14:sldIdLst>
             <p14:sldId id="258"/>
-          </p14:sldIdLst>
-        </p14:section>
-        <p14:section name="Technology (1:45)" id="{1babcb3e-334c-e4cc-bb75-c29f7e3cf4b7}">
-          <p14:sldIdLst>
             <p14:sldId id="259"/>
           </p14:sldIdLst>
         </p14:section>
-        <p14:section name="Competitors (0:45)" id="{649c49cf-e51b-4afc-4eda-6c6a662505cf}">
+        <p14:section name="Technology (1:25)" id="{3d4e30f3-40d3-c5ed-d8b2-3ed1eb1fb23e}">
           <p14:sldIdLst>
             <p14:sldId id="260"/>
           </p14:sldIdLst>
         </p14:section>
-        <p14:section name="Business and pilot (1:30)" id="{c06c15a9-1cb1-9e60-eb52-8eec95601998}">
+        <p14:section name="Competitors (0:45)" id="{1c870268-b80f-7375-ca83-7ee296c92b6e}">
           <p14:sldIdLst>
             <p14:sldId id="261"/>
+          </p14:sldIdLst>
+        </p14:section>
+        <p14:section name="Business and pilot (1:20)" id="{52d9f27b-89bd-415d-48a3-246c4a31c975}">
+          <p14:sldIdLst>
+            <p14:sldId id="262"/>
+          </p14:sldIdLst>
+        </p14:section>
+        <p14:section name="Close (0:10)" id="{045d1d10-6e67-05c0-5fd2-ae8d6cda2538}">
+          <p14:sldIdLst>
+            <p14:sldId id="263"/>
           </p14:sldIdLst>
         </p14:section>
       </p14:sectionLst>
@@ -729,7 +737,7 @@
 +0:35 Free spots &amp; booking: tap a green spot → Book → Pay (say: sandbox) → QR ticket → directions "straight 25 m, then right".
 +1:00 JURY INPUT: Vision → upload the jury's photo → "cars, rows and inferred empty spots — nobody drew these spots".
 +1:25 Operator view (PIN): pixelated camera + spot overlay; the one-time spot check; drivers never see the camera.
-+1:45 "One CPU server, no GPU." Hand over to Amirxon.
++1:45 "One CPU server, no GPU."
 IF THE WIUT CAMERA IS OFFLINE: show it honestly — the map says "camera offline" and booking pauses; the system never guesses.
 IF THE SITE IS DOWN: play your own screen recording of this flow (record it once the WIUT lot is live). Never debug on stage.</a:t>
             </a:r>
@@ -819,15 +827,9 @@
           <a:p>
             <a:r>
               <a:rPr lang="en-US" dirty="0"/>
-              <a:t>SPEAKER: Shomurodov Amirxon · 3:00–4:45
-"How it works. A phone at the lot sends a picture every few seconds. A quality check measures light, blur and glare; a dark frame also gets a brightened copy. Two open YOLO11 detectors — one for cameras looking down, one for street-level views — run together on an ordinary CPU. Then our part: the spots are found automatically from the rows of parked cars, the operator confirms them once, and occupancy is cautious — any sign of a car keeps a spot occupied. The result feeds the map, booking and directions.
-Measured: 0.14 seconds per camera frame on a 4-core CPU, no GPU, under 400 MB of memory — one small server handles about 20 cameras; we plan for 8. If a camera goes offline we show 'no data' and pause booking — we never guess. Pictures are never saved and the operator sees them pixelated.
-Accuracy: [real number from our Tashkent photos — or say: 'we are labelling our own Tashkent photos with our built-in tool; the number goes here']."
-NEVER fill [__%] with a guess. Measurement conditions: synthetic 1280×720 frames, both detectors (worst case), 4-core Xeon 2.1 GHz, 2 threads; on the free demo server (0.1 CPU) a frame takes ~2.7 s — say so if a judge notices.
-Q&amp;A: detectors are pretrained (Ultralytics, AGPL-3.0); the top-down model must be retrained on our own data before commercial use (README). Everything after detection was written during the final.
-TEAM-ONLY RUNBOOK (not for presenting)
-10 minutes before: open the site to wake the free server · WIUT camera phone streaming, charging, screen on, one picture every 5–10 s · map shows the lot "Live" · operator PIN at hand · two lot photos on the laptop for the jury input · your own screen recording of the flow ready offline.
-If something fails: slow photo → "free tenth-of-a-CPU server"; camera offline → show it (map says so, booking pauses); site down → play the recording at the same step; wrong detection → name it calmly; never debug on stage.</a:t>
+              <a:t>SPEAKER: Gopurjonov Bobur · 3:00–3:20
+"Here are the screens you just saw: the live map with Navigate; Find me a spot, which picks the nearest free spot; the ticket with its QR code and a countdown of how long the spot is held; the walk-in page from the gate QR, where you pay before leaving; and the entrance screen." Hand over to Amirxon.
+If the live demo failed, walk through these screens instead.</a:t>
             </a:r>
             <a:endParaRPr lang="en-US" dirty="0"/>
           </a:p>
@@ -915,16 +917,14 @@
           <a:p>
             <a:r>
               <a:rPr lang="en-US" dirty="0"/>
-              <a:t>SPEAKER: Shomurodov Amirxon · 4:45–5:30
-"Who else solves parking in Uzbekistan? The city's Poytaxt Parking app takes payment for street parking — but it's street-only and we found no booking. Gate systems with plate recognition, like Tashkent airport's since 2022, know who came in — not which spot is free. Yandex Maps and 2GIS show where lots are — we found no live free spots or booking, so we simply hand navigation over to them. The city traffic centre started a pilot in April to join private lots into one system — a possible partner for us. And per-spot sensors are accurate, but need a device over every spot; we found no installation in Uzbekistan. ParkDet needs one phone per lot. And demand is real: the airport's May tender asks for online booking and free-space boards."
-Say "we found" — these are absences in our search, not proven facts. Open every link once before the defence.
-SOURCES (checked 10 Oct 2026 via search results; open each before the defence)
-Poytaxt Parking: spot.uz/ru/2025/06/23/paid-parking/ (app rating 2.4/5, payment options) · kun.uz/ru/news/2025/05/05/v-tashkente-v-testovom-rejime-zapushcheny-pervyye-pridorojnyye-platnyye-parkovki · afisha.uz/ru/gorod/2025/05/06/parking (operator Streetpark Systems, zones 5,000–12,000 so'm/h)
-Airport gate system: kun.uz/ru/news/2022/11/24/v-aeroportu-tashkenta-zarabotala-pervaya-umnaya-parkovka-v-strane (333 spaces, plate recognition) · anhor.uz/news/smart-parking/ (Amano equipment, installed by K2) · spot.uz/ru/2023/01/09/parking-airport/
-Airport tender: spot.uz/ru/2026/05/04/airport-parking-lease/ · anhor.uz/news/parkovki-2/ (6 lots, 1,543 spaces, 3 years; tenant must add plate recognition, online payment and booking, free-space boards)
-City pilot: kun.uz/ru/news/2026/04/21/v-tashkente-pristupili-k-realizatsii-pilotnogo-proyekta-po-sistemnomu-upravleniyu-parkovkami · uza.uz (private lots near shops joined to one city system; space accounting and occupancy control)
-Maps: yandex.com/maps (Tashkent parking places) · 2gis.uz (Tashkent paid car parks listing)
-Per-spot guidance product: hikvision.com Smart Parking solution brochure (parking guidance systems); no Uzbek installation found in our search.</a:t>
+              <a:t>SPEAKER: Shomurodov Amirxon · 3:20–4:45
+"How it works. A phone at the lot sends a picture every few seconds. Two open YOLO11 detectors — one for cameras looking down, one for street-level views — run together on an ordinary CPU. Then our part: the spots are found automatically from the rows of parked cars, the operator confirms them once, and occupancy is cautious — any sign of a car keeps a spot occupied. The result feeds the map, booking and directions.
+Measured: 0.14 seconds per camera frame on a 4-core CPU, no GPU, under 400 MB of memory — one small server handles about 20 cameras; we plan for 8. If a camera goes offline we show 'no data' and pause booking — we never guess. Pictures are never saved and the operator sees them pixelated."
+Measurement conditions: synthetic 1280×720 frames, both detectors (worst case), 4-core Xeon 2.1 GHz, 2 threads; on the free demo server (0.1 CPU) a frame takes ~2.7 s — say so if a judge notices.
+Q&amp;A: detectors are pretrained (Ultralytics, AGPL-3.0); the top-down model must be retrained on our own data before commercial use (README). Everything after detection was written during the final.
+TEAM-ONLY RUNBOOK (not for presenting)
+10 minutes before: open the site to wake the free server · WIUT camera phone streaming, charging, screen on, one picture every 5–10 s · map shows the lot "Live" · operator PIN at hand · two lot photos on the laptop for the jury input · your own screen recording of the flow ready offline.
+If something fails: slow photo → "free tenth-of-a-CPU server"; camera offline → show it (map says so, booking pauses); site down → play the recording at the same step; wrong detection → name it calmly; never debug on stage.</a:t>
             </a:r>
             <a:endParaRPr lang="en-US" dirty="0"/>
           </a:p>
@@ -1012,12 +1012,16 @@
           <a:p>
             <a:r>
               <a:rPr lang="en-US" dirty="0"/>
-              <a:t>SPEAKER: Bahodurov Bahridin · 5:30–7:00 (finish by 6:55)
-"Who pays? The lot operator — malls, business centres, universities, dealerships, paid city lots. We charge per camera per month, plus a small share of each booking. The operator gets paid bookings, no gate staff for walk-ins, and data on how the lot is used. Per camera, revenue is the subscription plus bookings times the fee; cost is a share of one server, the phone and support.
-To prove it: a three-month pilot in one lot. Month one: one or two phone cameras, the spot check, and labelling photos from that lot. Month two: drivers use the map, booking and walk-in, and the operator gets a weekly accuracy report. Month three: a real local payment provider, an ROI review, go or no-go. The pilot costs [sum] and pays back in [__] months.
-Our ask: one lot to pilot in. Thank you — we're happy to take questions."
-Replace every [bracket] with a sourced number, or say "this is our hypothesis, to be validated in the pilot".
-Q&amp;A owners: CV / model → Amirxon; app, demo, deployment → Bobur; business, pilot, users → Bahridin.</a:t>
+              <a:t>SPEAKER: Shomurodov Amirxon · 4:45–5:30
+"Who else solves parking in Uzbekistan? The city's Poytaxt Parking app takes payment for street parking — but it's street-only and we found no booking. Gate systems with plate recognition, like Tashkent airport's since 2022, know who came in — not which spot is free. Yandex Maps and 2GIS show where lots are — we found no live free spots or booking, so we simply hand navigation over to them. The city traffic centre started a pilot in April to join private lots into one system — a possible partner for us. And per-spot sensors are accurate, but need a device over every spot; we found no installation in Uzbekistan. ParkDet needs one phone per lot. And demand is real: the airport's May tender asks for online booking and free-space boards."
+Say "we found" — these are absences in our search, not proven facts. Open every link once before the defence.
+SOURCES (checked 10 Oct 2026 via search results; open each before the defence)
+Poytaxt Parking: spot.uz/ru/2025/06/23/paid-parking/ (app rating 2.4/5, payment options) · kun.uz/ru/news/2025/05/05/v-tashkente-v-testovom-rejime-zapushcheny-pervyye-pridorojnyye-platnyye-parkovki · afisha.uz/ru/gorod/2025/05/06/parking (operator Streetpark Systems, zones 5,000–12,000 so'm/h)
+Airport gate system: kun.uz/ru/news/2022/11/24/v-aeroportu-tashkenta-zarabotala-pervaya-umnaya-parkovka-v-strane (333 spaces, plate recognition) · anhor.uz/news/smart-parking/ (Amano equipment, installed by K2) · spot.uz/ru/2023/01/09/parking-airport/
+Airport tender: spot.uz/ru/2026/05/04/airport-parking-lease/ · anhor.uz/news/parkovki-2/ (6 lots, 1,543 spaces, 3 years; tenant must add plate recognition, online payment and booking, free-space boards)
+City pilot: kun.uz/ru/news/2026/04/21/v-tashkente-pristupili-k-realizatsii-pilotnogo-proyekta-po-sistemnomu-upravleniyu-parkovkami · uza.uz (private lots near shops joined to one city system; space accounting and occupancy control)
+Maps: yandex.com/maps (Tashkent parking places) · 2gis.uz (Tashkent paid car parks listing)
+Per-spot guidance product: hikvision.com Smart Parking solution brochure (parking guidance systems); no Uzbek installation found in our search.</a:t>
             </a:r>
             <a:endParaRPr lang="en-US" dirty="0"/>
           </a:p>
@@ -1041,6 +1045,188 @@
             <a:fld id="{F7021451-1387-4CA6-816F-3879F97B5CBC}" type="slidenum">
               <a:rPr lang="en-US"/>
               <a:t>6</a:t>
+            </a:fld>
+            <a:endParaRPr lang="en-US"/>
+          </a:p>
+        </p:txBody>
+      </p:sp>
+    </p:spTree>
+    <p:extLst>
+      <p:ext uri="{BB962C8B-B14F-4D97-AF65-F5344CB8AC3E}">
+        <p14:creationId xmlns:p14="http://schemas.microsoft.com/office/powerpoint/2010/main" val="1024086991"/>
+      </p:ext>
+    </p:extLst>
+  </p:cSld>
+  <p:clrMapOvr>
+    <a:masterClrMapping/>
+  </p:clrMapOvr>
+</p:notes>
+</file>
+
+<file path=ppt/notesSlides/notesSlide7.xml><?xml version="1.0" encoding="utf-8"?>
+<p:notes xmlns:a="http://schemas.openxmlformats.org/drawingml/2006/main" xmlns:r="http://schemas.openxmlformats.org/officeDocument/2006/relationships" xmlns:p="http://schemas.openxmlformats.org/presentationml/2006/main">
+  <p:cSld>
+    <p:spTree>
+      <p:nvGrpSpPr>
+        <p:cNvPr id="1" name=""/>
+        <p:cNvGrpSpPr/>
+        <p:nvPr/>
+      </p:nvGrpSpPr>
+      <p:grpSpPr>
+        <a:xfrm>
+          <a:off x="0" y="0"/>
+          <a:ext cx="0" cy="0"/>
+          <a:chOff x="0" y="0"/>
+          <a:chExt cx="0" cy="0"/>
+        </a:xfrm>
+      </p:grpSpPr>
+      <p:sp>
+        <p:nvSpPr>
+          <p:cNvPr id="2" name="Slide Image Placeholder 1"/>
+          <p:cNvSpPr>
+            <a:spLocks noGrp="1" noRot="1" noChangeAspect="1"/>
+          </p:cNvSpPr>
+          <p:nvPr>
+            <p:ph type="sldImg"/>
+          </p:nvPr>
+        </p:nvSpPr>
+        <p:spPr/>
+      </p:sp>
+      <p:sp>
+        <p:nvSpPr>
+          <p:cNvPr id="3" name="Notes Placeholder 2"/>
+          <p:cNvSpPr>
+            <a:spLocks noGrp="1"/>
+          </p:cNvSpPr>
+          <p:nvPr>
+            <p:ph type="body" idx="1"/>
+          </p:nvPr>
+        </p:nvSpPr>
+        <p:spPr/>
+        <p:txBody>
+          <a:bodyPr/>
+          <a:lstStyle/>
+          <a:p>
+            <a:r>
+              <a:rPr lang="en-US" dirty="0"/>
+              <a:t>SPEAKER: Bahodurov Bahridin · 5:30–6:50
+"How we earn: drivers pay 5,000 so'm for the first hour and 2,000 so'm for each extra hour. Half of every payment goes to the parking lot, half is our income. We work with malls, business centres, universities, dealerships and paid city lots. The lot gets paid bookings, no gate staff for walk-ins, and data on how the lot is used. Our cost per camera is a share of one server, the phone and support.
+To prove it: a three-month pilot in one lot. Month one: one or two phone cameras, the spot check, and labelling photos from that lot. Month two: drivers use the map, booking and walk-in, and the operator gets a weekly accuracy report. Month three: a real local payment provider, an ROI review, go or no-go. The pilot costs [sum] and pays back in [__] months.
+Our ask: one lot to pilot in."
+Replace every [bracket] with a sourced number, or say "this is our hypothesis, to be validated in the pilot".</a:t>
+            </a:r>
+            <a:endParaRPr lang="en-US" dirty="0"/>
+          </a:p>
+        </p:txBody>
+      </p:sp>
+      <p:sp>
+        <p:nvSpPr>
+          <p:cNvPr id="4" name="Slide Number Placeholder 3"/>
+          <p:cNvSpPr>
+            <a:spLocks noGrp="1"/>
+          </p:cNvSpPr>
+          <p:nvPr>
+            <p:ph type="sldNum" sz="quarter" idx="10"/>
+          </p:nvPr>
+        </p:nvSpPr>
+        <p:spPr/>
+        <p:txBody>
+          <a:bodyPr/>
+          <a:lstStyle/>
+          <a:p>
+            <a:fld id="{F7021451-1387-4CA6-816F-3879F97B5CBC}" type="slidenum">
+              <a:rPr lang="en-US"/>
+              <a:t>7</a:t>
+            </a:fld>
+            <a:endParaRPr lang="en-US"/>
+          </a:p>
+        </p:txBody>
+      </p:sp>
+    </p:spTree>
+    <p:extLst>
+      <p:ext uri="{BB962C8B-B14F-4D97-AF65-F5344CB8AC3E}">
+        <p14:creationId xmlns:p14="http://schemas.microsoft.com/office/powerpoint/2010/main" val="1024086991"/>
+      </p:ext>
+    </p:extLst>
+  </p:cSld>
+  <p:clrMapOvr>
+    <a:masterClrMapping/>
+  </p:clrMapOvr>
+</p:notes>
+</file>
+
+<file path=ppt/notesSlides/notesSlide8.xml><?xml version="1.0" encoding="utf-8"?>
+<p:notes xmlns:a="http://schemas.openxmlformats.org/drawingml/2006/main" xmlns:r="http://schemas.openxmlformats.org/officeDocument/2006/relationships" xmlns:p="http://schemas.openxmlformats.org/presentationml/2006/main">
+  <p:cSld>
+    <p:spTree>
+      <p:nvGrpSpPr>
+        <p:cNvPr id="1" name=""/>
+        <p:cNvGrpSpPr/>
+        <p:nvPr/>
+      </p:nvGrpSpPr>
+      <p:grpSpPr>
+        <a:xfrm>
+          <a:off x="0" y="0"/>
+          <a:ext cx="0" cy="0"/>
+          <a:chOff x="0" y="0"/>
+          <a:chExt cx="0" cy="0"/>
+        </a:xfrm>
+      </p:grpSpPr>
+      <p:sp>
+        <p:nvSpPr>
+          <p:cNvPr id="2" name="Slide Image Placeholder 1"/>
+          <p:cNvSpPr>
+            <a:spLocks noGrp="1" noRot="1" noChangeAspect="1"/>
+          </p:cNvSpPr>
+          <p:nvPr>
+            <p:ph type="sldImg"/>
+          </p:nvPr>
+        </p:nvSpPr>
+        <p:spPr/>
+      </p:sp>
+      <p:sp>
+        <p:nvSpPr>
+          <p:cNvPr id="3" name="Notes Placeholder 2"/>
+          <p:cNvSpPr>
+            <a:spLocks noGrp="1"/>
+          </p:cNvSpPr>
+          <p:nvPr>
+            <p:ph type="body" idx="1"/>
+          </p:nvPr>
+        </p:nvSpPr>
+        <p:spPr/>
+        <p:txBody>
+          <a:bodyPr/>
+          <a:lstStyle/>
+          <a:p>
+            <a:r>
+              <a:rPr lang="en-US" dirty="0"/>
+              <a:t>SPEAKER: Bahodurov Bahridin · 6:50–7:00
+"Thanks for watching — we're happy to take your questions."
+Q&amp;A owners: CV / model → Amirxon; app, demo, deployment → Bobur; business, pilot, users → Bahridin.</a:t>
+            </a:r>
+            <a:endParaRPr lang="en-US" dirty="0"/>
+          </a:p>
+        </p:txBody>
+      </p:sp>
+      <p:sp>
+        <p:nvSpPr>
+          <p:cNvPr id="4" name="Slide Number Placeholder 3"/>
+          <p:cNvSpPr>
+            <a:spLocks noGrp="1"/>
+          </p:cNvSpPr>
+          <p:nvPr>
+            <p:ph type="sldNum" sz="quarter" idx="10"/>
+          </p:nvPr>
+        </p:nvSpPr>
+        <p:spPr/>
+        <p:txBody>
+          <a:bodyPr/>
+          <a:lstStyle/>
+          <a:p>
+            <a:fld id="{F7021451-1387-4CA6-816F-3879F97B5CBC}" type="slidenum">
+              <a:rPr lang="en-US"/>
+              <a:t>8</a:t>
             </a:fld>
             <a:endParaRPr lang="en-US"/>
           </a:p>
@@ -2433,6 +2619,18 @@
   <p:clrMapOvr>
     <a:masterClrMapping/>
   </p:clrMapOvr>
+  <mc:AlternateContent xmlns:mc="http://schemas.openxmlformats.org/markup-compatibility/2006">
+    <mc:Choice xmlns:p159="http://schemas.microsoft.com/office/powerpoint/2015/09/main" Requires="p159">
+      <p:transition xmlns:p14="http://schemas.microsoft.com/office/powerpoint/2010/main" spd="slow" p14:dur="1000">
+        <p159:morph option="byObject"/>
+      </p:transition>
+    </mc:Choice>
+    <mc:Fallback>
+      <p:transition spd="slow">
+        <p:fade/>
+      </p:transition>
+    </mc:Fallback>
+  </mc:AlternateContent>
 </p:sld>
 </file>
 
@@ -3383,6 +3581,18 @@
   <p:clrMapOvr>
     <a:masterClrMapping/>
   </p:clrMapOvr>
+  <mc:AlternateContent xmlns:mc="http://schemas.openxmlformats.org/markup-compatibility/2006">
+    <mc:Choice xmlns:p159="http://schemas.microsoft.com/office/powerpoint/2015/09/main" Requires="p159">
+      <p:transition xmlns:p14="http://schemas.microsoft.com/office/powerpoint/2010/main" spd="slow" p14:dur="1000">
+        <p159:morph option="byObject"/>
+      </p:transition>
+    </mc:Choice>
+    <mc:Fallback>
+      <p:transition spd="slow">
+        <p:fade/>
+      </p:transition>
+    </mc:Fallback>
+  </mc:AlternateContent>
 </p:sld>
 </file>
 
@@ -4164,6 +4374,18 @@
   <p:clrMapOvr>
     <a:masterClrMapping/>
   </p:clrMapOvr>
+  <mc:AlternateContent xmlns:mc="http://schemas.openxmlformats.org/markup-compatibility/2006">
+    <mc:Choice xmlns:p159="http://schemas.microsoft.com/office/powerpoint/2015/09/main" Requires="p159">
+      <p:transition xmlns:p14="http://schemas.microsoft.com/office/powerpoint/2010/main" spd="slow" p14:dur="1000">
+        <p159:morph option="byObject"/>
+      </p:transition>
+    </mc:Choice>
+    <mc:Fallback>
+      <p:transition spd="slow">
+        <p:fade/>
+      </p:transition>
+    </mc:Fallback>
+  </mc:AlternateContent>
 </p:sld>
 </file>
 
@@ -4216,7 +4438,7 @@
                   <a:schemeClr val="accent1"/>
                 </a:solidFill>
               </a:rPr>
-              <a:t>TECHNOLOGY</a:t>
+              <a:t>PRODUCT DEMO</a:t>
             </a:r>
             <a:endParaRPr lang="en-US" sz="1200" dirty="0"/>
           </a:p>
@@ -4254,7 +4476,7 @@
                   <a:schemeClr val="tx1"/>
                 </a:solidFill>
               </a:rPr>
-              <a:t>How it works — and what we measured</a:t>
+              <a:t>The app, screen by screen</a:t>
             </a:r>
             <a:endParaRPr lang="en-US" sz="3200" dirty="0"/>
           </a:p>
@@ -4262,90 +4484,29 @@
       </p:sp>
       <p:sp>
         <p:nvSpPr>
-          <p:cNvPr id="4" name="HOW IT WORKS label"/>
-          <p:cNvSpPr txBox="1"/>
-          <p:nvPr/>
-        </p:nvSpPr>
-        <p:spPr>
-          <a:xfrm>
-            <a:off x="548640" y="1481328"/>
-            <a:ext cx="3657600" cy="274320"/>
-          </a:xfrm>
-          <a:prstGeom prst="rect">
-            <a:avLst/>
-          </a:prstGeom>
-          <a:noFill/>
-          <a:ln/>
-        </p:spPr>
-        <p:txBody>
-          <a:bodyPr wrap="square" lIns="0" tIns="0" rIns="0" bIns="0" rtlCol="0" anchor="t"/>
-          <a:lstStyle/>
-          <a:p>
-            <a:pPr indent="0" marL="0">
-              <a:buNone/>
-            </a:pPr>
-            <a:r>
-              <a:rPr lang="en-US" sz="1200" b="1" spc="200" kern="0" dirty="0">
-                <a:solidFill>
-                  <a:schemeClr val="accent1"/>
-                </a:solidFill>
-              </a:rPr>
-              <a:t>HOW IT WORKS</a:t>
-            </a:r>
-            <a:endParaRPr lang="en-US" sz="1200" dirty="0"/>
-          </a:p>
-        </p:txBody>
-      </p:sp>
-      <p:sp>
-        <p:nvSpPr>
-          <p:cNvPr id="5" name="Phone camera step"/>
+          <p:cNvPr id="4" name="Map &amp; navigation tile"/>
           <p:cNvSpPr/>
           <p:nvPr/>
         </p:nvSpPr>
         <p:spPr>
           <a:xfrm>
-            <a:off x="548640" y="1810512"/>
-            <a:ext cx="1984797" cy="1371600"/>
+            <a:off x="548640" y="1600200"/>
+            <a:ext cx="2036003" cy="3246120"/>
           </a:xfrm>
           <a:prstGeom prst="roundRect">
             <a:avLst>
-              <a:gd name="adj" fmla="val 8000"/>
+              <a:gd name="adj" fmla="val 4491"/>
             </a:avLst>
           </a:prstGeom>
           <a:solidFill>
-            <a:schemeClr val="bg1"/>
-          </a:solidFill>
-          <a:ln w="12700">
-            <a:solidFill>
-              <a:srgbClr val="E6ECF4"/>
-            </a:solidFill>
-            <a:prstDash val="solid"/>
-          </a:ln>
-        </p:spPr>
-      </p:sp>
-      <p:sp>
-        <p:nvSpPr>
-          <p:cNvPr id="6" name="Phone camera circle"/>
-          <p:cNvSpPr/>
-          <p:nvPr/>
-        </p:nvSpPr>
-        <p:spPr>
-          <a:xfrm>
-            <a:off x="713232" y="1965960"/>
-            <a:ext cx="438912" cy="438912"/>
-          </a:xfrm>
-          <a:prstGeom prst="ellipse">
-            <a:avLst/>
-          </a:prstGeom>
-          <a:solidFill>
-            <a:schemeClr val="accent1"/>
+            <a:schemeClr val="accent6"/>
           </a:solidFill>
           <a:ln/>
         </p:spPr>
       </p:sp>
       <p:pic>
         <p:nvPicPr>
-          <p:cNvPr id="7" name="Phone camera icon" descr="Phone camera">    </p:cNvPr>
+          <p:cNvPr id="5" name="Map &amp; navigation screenshot" descr="Map &amp; navigation screen of the ParkDet app">    </p:cNvPr>
           <p:cNvPicPr>
             <a:picLocks noChangeAspect="1"/>
           </p:cNvPicPr>
@@ -4359,8 +4520,8 @@
         </p:blipFill>
         <p:spPr>
           <a:xfrm>
-            <a:off x="818571" y="2071299"/>
-            <a:ext cx="228234" cy="228234"/>
+            <a:off x="658368" y="2484971"/>
+            <a:ext cx="1816547" cy="1476579"/>
           </a:xfrm>
           <a:prstGeom prst="rect">
             <a:avLst/>
@@ -4369,14 +4530,14 @@
       </p:pic>
       <p:sp>
         <p:nvSpPr>
-          <p:cNvPr id="8" name="Phone camera text"/>
+          <p:cNvPr id="6" name="Map &amp;amp; navigation title"/>
           <p:cNvSpPr txBox="1"/>
           <p:nvPr/>
         </p:nvSpPr>
         <p:spPr>
           <a:xfrm>
-            <a:off x="713232" y="2496312"/>
-            <a:ext cx="1710477" cy="640080"/>
+            <a:off x="548640" y="4983480"/>
+            <a:ext cx="2036003" cy="320040"/>
           </a:xfrm>
           <a:prstGeom prst="rect">
             <a:avLst/>
@@ -4392,101 +4553,78 @@
               <a:buNone/>
             </a:pPr>
             <a:r>
-              <a:rPr lang="en-US" sz="1400" b="1" dirty="0">
+              <a:rPr lang="en-US" sz="1500" b="1" dirty="0">
                 <a:solidFill>
                   <a:schemeClr val="tx1"/>
                 </a:solidFill>
               </a:rPr>
-              <a:t>Phone camera</a:t>
-            </a:r>
-            <a:endParaRPr lang="en-US" sz="1400" dirty="0"/>
-          </a:p>
-          <a:p>
-            <a:pPr indent="0" marL="0">
-              <a:buNone/>
-            </a:pPr>
-            <a:r>
-              <a:rPr lang="en-US" sz="1150" dirty="0">
+              <a:t>Map &amp; navigation</a:t>
+            </a:r>
+            <a:endParaRPr lang="en-US" sz="1500" dirty="0"/>
+          </a:p>
+        </p:txBody>
+      </p:sp>
+      <p:sp>
+        <p:nvSpPr>
+          <p:cNvPr id="7" name="Map &amp;amp; navigation caption"/>
+          <p:cNvSpPr txBox="1"/>
+          <p:nvPr/>
+        </p:nvSpPr>
+        <p:spPr>
+          <a:xfrm>
+            <a:off x="548640" y="5321808"/>
+            <a:ext cx="2036003" cy="777240"/>
+          </a:xfrm>
+          <a:prstGeom prst="rect">
+            <a:avLst/>
+          </a:prstGeom>
+          <a:noFill/>
+          <a:ln/>
+        </p:spPr>
+        <p:txBody>
+          <a:bodyPr wrap="square" lIns="0" tIns="0" rIns="0" bIns="0" rtlCol="0" anchor="t"/>
+          <a:lstStyle/>
+          <a:p>
+            <a:pPr indent="0" marL="0">
+              <a:buNone/>
+            </a:pPr>
+            <a:r>
+              <a:rPr lang="en-US" sz="1200" dirty="0">
                 <a:solidFill>
                   <a:schemeClr val="tx2"/>
                 </a:solidFill>
               </a:rPr>
-              <a:t>one picture every 3–10 s</a:t>
-            </a:r>
-            <a:endParaRPr lang="en-US" sz="1400" dirty="0"/>
-          </a:p>
-        </p:txBody>
-      </p:sp>
-      <p:sp>
-        <p:nvSpPr>
-          <p:cNvPr id="9" name="flow arrow 1"/>
+              <a:t>Live free spots near you; Navigate opens Google Maps or Yandex</a:t>
+            </a:r>
+            <a:endParaRPr lang="en-US" sz="1200" dirty="0"/>
+          </a:p>
+        </p:txBody>
+      </p:sp>
+      <p:sp>
+        <p:nvSpPr>
+          <p:cNvPr id="8" name="Find me a spot tile"/>
           <p:cNvSpPr/>
           <p:nvPr/>
         </p:nvSpPr>
         <p:spPr>
           <a:xfrm>
-            <a:off x="2606589" y="2377440"/>
-            <a:ext cx="146304" cy="237744"/>
-          </a:xfrm>
-          <a:prstGeom prst="chevron">
-            <a:avLst/>
-          </a:prstGeom>
-          <a:solidFill>
-            <a:schemeClr val="accent1"/>
-          </a:solidFill>
-          <a:ln/>
-        </p:spPr>
-      </p:sp>
-      <p:sp>
-        <p:nvSpPr>
-          <p:cNvPr id="10" name="Quality check step"/>
-          <p:cNvSpPr/>
-          <p:nvPr/>
-        </p:nvSpPr>
-        <p:spPr>
-          <a:xfrm>
-            <a:off x="2826045" y="1810512"/>
-            <a:ext cx="1984797" cy="1371600"/>
+            <a:off x="2813243" y="1600200"/>
+            <a:ext cx="2036003" cy="3246120"/>
           </a:xfrm>
           <a:prstGeom prst="roundRect">
             <a:avLst>
-              <a:gd name="adj" fmla="val 8000"/>
+              <a:gd name="adj" fmla="val 4491"/>
             </a:avLst>
           </a:prstGeom>
           <a:solidFill>
-            <a:schemeClr val="bg1"/>
-          </a:solidFill>
-          <a:ln w="12700">
-            <a:solidFill>
-              <a:srgbClr val="E6ECF4"/>
-            </a:solidFill>
-            <a:prstDash val="solid"/>
-          </a:ln>
-        </p:spPr>
-      </p:sp>
-      <p:sp>
-        <p:nvSpPr>
-          <p:cNvPr id="11" name="Quality check circle"/>
-          <p:cNvSpPr/>
-          <p:nvPr/>
-        </p:nvSpPr>
-        <p:spPr>
-          <a:xfrm>
-            <a:off x="2990637" y="1965960"/>
-            <a:ext cx="438912" cy="438912"/>
-          </a:xfrm>
-          <a:prstGeom prst="ellipse">
-            <a:avLst/>
-          </a:prstGeom>
-          <a:solidFill>
-            <a:schemeClr val="accent1"/>
+            <a:schemeClr val="accent6"/>
           </a:solidFill>
           <a:ln/>
         </p:spPr>
       </p:sp>
       <p:pic>
         <p:nvPicPr>
-          <p:cNvPr id="12" name="Quality check icon" descr="Quality check">    </p:cNvPr>
+          <p:cNvPr id="9" name="Find me a spot screenshot" descr="Find me a spot screen of the ParkDet app">    </p:cNvPr>
           <p:cNvPicPr>
             <a:picLocks noChangeAspect="1"/>
           </p:cNvPicPr>
@@ -4500,8 +4638,8 @@
         </p:blipFill>
         <p:spPr>
           <a:xfrm>
-            <a:off x="3095976" y="2071299"/>
-            <a:ext cx="228234" cy="228234"/>
+            <a:off x="3131956" y="1709928"/>
+            <a:ext cx="1398577" cy="3026664"/>
           </a:xfrm>
           <a:prstGeom prst="rect">
             <a:avLst/>
@@ -4510,14 +4648,14 @@
       </p:pic>
       <p:sp>
         <p:nvSpPr>
-          <p:cNvPr id="13" name="Quality check text"/>
+          <p:cNvPr id="10" name="Find me a spot title"/>
           <p:cNvSpPr txBox="1"/>
           <p:nvPr/>
         </p:nvSpPr>
         <p:spPr>
           <a:xfrm>
-            <a:off x="2990637" y="2496312"/>
-            <a:ext cx="1710477" cy="640080"/>
+            <a:off x="2813243" y="4983480"/>
+            <a:ext cx="2036003" cy="320040"/>
           </a:xfrm>
           <a:prstGeom prst="rect">
             <a:avLst/>
@@ -4533,101 +4671,78 @@
               <a:buNone/>
             </a:pPr>
             <a:r>
-              <a:rPr lang="en-US" sz="1400" b="1" dirty="0">
+              <a:rPr lang="en-US" sz="1500" b="1" dirty="0">
                 <a:solidFill>
                   <a:schemeClr val="tx1"/>
                 </a:solidFill>
               </a:rPr>
-              <a:t>Quality check</a:t>
-            </a:r>
-            <a:endParaRPr lang="en-US" sz="1400" dirty="0"/>
-          </a:p>
-          <a:p>
-            <a:pPr indent="0" marL="0">
-              <a:buNone/>
-            </a:pPr>
-            <a:r>
-              <a:rPr lang="en-US" sz="1150" dirty="0">
+              <a:t>Find me a spot</a:t>
+            </a:r>
+            <a:endParaRPr lang="en-US" sz="1500" dirty="0"/>
+          </a:p>
+        </p:txBody>
+      </p:sp>
+      <p:sp>
+        <p:nvSpPr>
+          <p:cNvPr id="11" name="Find me a spot caption"/>
+          <p:cNvSpPr txBox="1"/>
+          <p:nvPr/>
+        </p:nvSpPr>
+        <p:spPr>
+          <a:xfrm>
+            <a:off x="2813243" y="5321808"/>
+            <a:ext cx="2036003" cy="777240"/>
+          </a:xfrm>
+          <a:prstGeom prst="rect">
+            <a:avLst/>
+          </a:prstGeom>
+          <a:noFill/>
+          <a:ln/>
+        </p:spPr>
+        <p:txBody>
+          <a:bodyPr wrap="square" lIns="0" tIns="0" rIns="0" bIns="0" rtlCol="0" anchor="t"/>
+          <a:lstStyle/>
+          <a:p>
+            <a:pPr indent="0" marL="0">
+              <a:buNone/>
+            </a:pPr>
+            <a:r>
+              <a:rPr lang="en-US" sz="1200" dirty="0">
                 <a:solidFill>
                   <a:schemeClr val="tx2"/>
                 </a:solidFill>
               </a:rPr>
-              <a:t>dark frame → a 2nd, brightened view</a:t>
-            </a:r>
-            <a:endParaRPr lang="en-US" sz="1400" dirty="0"/>
-          </a:p>
-        </p:txBody>
-      </p:sp>
-      <p:sp>
-        <p:nvSpPr>
-          <p:cNvPr id="14" name="flow arrow 2"/>
+              <a:t>One tap: the nearest free spot and directions</a:t>
+            </a:r>
+            <a:endParaRPr lang="en-US" sz="1200" dirty="0"/>
+          </a:p>
+        </p:txBody>
+      </p:sp>
+      <p:sp>
+        <p:nvSpPr>
+          <p:cNvPr id="12" name="Booking ticket tile"/>
           <p:cNvSpPr/>
           <p:nvPr/>
         </p:nvSpPr>
         <p:spPr>
           <a:xfrm>
-            <a:off x="4883993" y="2377440"/>
-            <a:ext cx="146304" cy="237744"/>
-          </a:xfrm>
-          <a:prstGeom prst="chevron">
-            <a:avLst/>
-          </a:prstGeom>
-          <a:solidFill>
-            <a:schemeClr val="accent1"/>
-          </a:solidFill>
-          <a:ln/>
-        </p:spPr>
-      </p:sp>
-      <p:sp>
-        <p:nvSpPr>
-          <p:cNvPr id="15" name="2 detectors, CPU step"/>
-          <p:cNvSpPr/>
-          <p:nvPr/>
-        </p:nvSpPr>
-        <p:spPr>
-          <a:xfrm>
-            <a:off x="5103449" y="1810512"/>
-            <a:ext cx="1984797" cy="1371600"/>
+            <a:off x="5077846" y="1600200"/>
+            <a:ext cx="2036003" cy="3246120"/>
           </a:xfrm>
           <a:prstGeom prst="roundRect">
             <a:avLst>
-              <a:gd name="adj" fmla="val 8000"/>
+              <a:gd name="adj" fmla="val 4491"/>
             </a:avLst>
           </a:prstGeom>
           <a:solidFill>
-            <a:schemeClr val="bg1"/>
-          </a:solidFill>
-          <a:ln w="12700">
-            <a:solidFill>
-              <a:srgbClr val="E6ECF4"/>
-            </a:solidFill>
-            <a:prstDash val="solid"/>
-          </a:ln>
-        </p:spPr>
-      </p:sp>
-      <p:sp>
-        <p:nvSpPr>
-          <p:cNvPr id="16" name="2 detectors, CPU circle"/>
-          <p:cNvSpPr/>
-          <p:nvPr/>
-        </p:nvSpPr>
-        <p:spPr>
-          <a:xfrm>
-            <a:off x="5268041" y="1965960"/>
-            <a:ext cx="438912" cy="438912"/>
-          </a:xfrm>
-          <a:prstGeom prst="ellipse">
-            <a:avLst/>
-          </a:prstGeom>
-          <a:solidFill>
-            <a:schemeClr val="accent1"/>
+            <a:schemeClr val="accent6"/>
           </a:solidFill>
           <a:ln/>
         </p:spPr>
       </p:sp>
       <p:pic>
         <p:nvPicPr>
-          <p:cNvPr id="17" name="2 detectors, CPU icon" descr="2 detectors, CPU">    </p:cNvPr>
+          <p:cNvPr id="13" name="Booking ticket screenshot" descr="Booking ticket screen of the ParkDet app">    </p:cNvPr>
           <p:cNvPicPr>
             <a:picLocks noChangeAspect="1"/>
           </p:cNvPicPr>
@@ -4641,8 +4756,8 @@
         </p:blipFill>
         <p:spPr>
           <a:xfrm>
-            <a:off x="5373380" y="2071299"/>
-            <a:ext cx="228234" cy="228234"/>
+            <a:off x="5396559" y="1709928"/>
+            <a:ext cx="1398577" cy="3026664"/>
           </a:xfrm>
           <a:prstGeom prst="rect">
             <a:avLst/>
@@ -4651,14 +4766,14 @@
       </p:pic>
       <p:sp>
         <p:nvSpPr>
-          <p:cNvPr id="18" name="2 detectors, CPU text"/>
+          <p:cNvPr id="14" name="Booking ticket title"/>
           <p:cNvSpPr txBox="1"/>
           <p:nvPr/>
         </p:nvSpPr>
         <p:spPr>
           <a:xfrm>
-            <a:off x="5268041" y="2496312"/>
-            <a:ext cx="1710477" cy="640080"/>
+            <a:off x="5077846" y="4983480"/>
+            <a:ext cx="2036003" cy="320040"/>
           </a:xfrm>
           <a:prstGeom prst="rect">
             <a:avLst/>
@@ -4674,101 +4789,78 @@
               <a:buNone/>
             </a:pPr>
             <a:r>
-              <a:rPr lang="en-US" sz="1400" b="1" dirty="0">
+              <a:rPr lang="en-US" sz="1500" b="1" dirty="0">
                 <a:solidFill>
                   <a:schemeClr val="tx1"/>
                 </a:solidFill>
               </a:rPr>
-              <a:t>2 detectors, CPU</a:t>
-            </a:r>
-            <a:endParaRPr lang="en-US" sz="1400" dirty="0"/>
-          </a:p>
-          <a:p>
-            <a:pPr indent="0" marL="0">
-              <a:buNone/>
-            </a:pPr>
-            <a:r>
-              <a:rPr lang="en-US" sz="1150" dirty="0">
+              <a:t>Booking ticket</a:t>
+            </a:r>
+            <a:endParaRPr lang="en-US" sz="1500" dirty="0"/>
+          </a:p>
+        </p:txBody>
+      </p:sp>
+      <p:sp>
+        <p:nvSpPr>
+          <p:cNvPr id="15" name="Booking ticket caption"/>
+          <p:cNvSpPr txBox="1"/>
+          <p:nvPr/>
+        </p:nvSpPr>
+        <p:spPr>
+          <a:xfrm>
+            <a:off x="5077846" y="5321808"/>
+            <a:ext cx="2036003" cy="777240"/>
+          </a:xfrm>
+          <a:prstGeom prst="rect">
+            <a:avLst/>
+          </a:prstGeom>
+          <a:noFill/>
+          <a:ln/>
+        </p:spPr>
+        <p:txBody>
+          <a:bodyPr wrap="square" lIns="0" tIns="0" rIns="0" bIns="0" rtlCol="0" anchor="t"/>
+          <a:lstStyle/>
+          <a:p>
+            <a:pPr indent="0" marL="0">
+              <a:buNone/>
+            </a:pPr>
+            <a:r>
+              <a:rPr lang="en-US" sz="1200" dirty="0">
                 <a:solidFill>
                   <a:schemeClr val="tx2"/>
                 </a:solidFill>
               </a:rPr>
-              <a:t>top-down + street-level YOLO11</a:t>
-            </a:r>
-            <a:endParaRPr lang="en-US" sz="1400" dirty="0"/>
-          </a:p>
-        </p:txBody>
-      </p:sp>
-      <p:sp>
-        <p:nvSpPr>
-          <p:cNvPr id="19" name="flow arrow 3"/>
+              <a:t>Test payment, QR ticket, countdown of the hold</a:t>
+            </a:r>
+            <a:endParaRPr lang="en-US" sz="1200" dirty="0"/>
+          </a:p>
+        </p:txBody>
+      </p:sp>
+      <p:sp>
+        <p:nvSpPr>
+          <p:cNvPr id="16" name="Walk-in tile"/>
           <p:cNvSpPr/>
           <p:nvPr/>
         </p:nvSpPr>
         <p:spPr>
           <a:xfrm>
-            <a:off x="7161398" y="2377440"/>
-            <a:ext cx="146304" cy="237744"/>
-          </a:xfrm>
-          <a:prstGeom prst="chevron">
-            <a:avLst/>
-          </a:prstGeom>
-          <a:solidFill>
-            <a:schemeClr val="accent1"/>
-          </a:solidFill>
-          <a:ln/>
-        </p:spPr>
-      </p:sp>
-      <p:sp>
-        <p:nvSpPr>
-          <p:cNvPr id="20" name="Spots + occupancy step"/>
-          <p:cNvSpPr/>
-          <p:nvPr/>
-        </p:nvSpPr>
-        <p:spPr>
-          <a:xfrm>
-            <a:off x="7380854" y="1810512"/>
-            <a:ext cx="1984797" cy="1371600"/>
+            <a:off x="7342449" y="1600200"/>
+            <a:ext cx="2036003" cy="3246120"/>
           </a:xfrm>
           <a:prstGeom prst="roundRect">
             <a:avLst>
-              <a:gd name="adj" fmla="val 8000"/>
+              <a:gd name="adj" fmla="val 4491"/>
             </a:avLst>
           </a:prstGeom>
           <a:solidFill>
-            <a:schemeClr val="bg1"/>
-          </a:solidFill>
-          <a:ln w="12700">
-            <a:solidFill>
-              <a:srgbClr val="E6ECF4"/>
-            </a:solidFill>
-            <a:prstDash val="solid"/>
-          </a:ln>
-        </p:spPr>
-      </p:sp>
-      <p:sp>
-        <p:nvSpPr>
-          <p:cNvPr id="21" name="Spots + occupancy circle"/>
-          <p:cNvSpPr/>
-          <p:nvPr/>
-        </p:nvSpPr>
-        <p:spPr>
-          <a:xfrm>
-            <a:off x="7545446" y="1965960"/>
-            <a:ext cx="438912" cy="438912"/>
-          </a:xfrm>
-          <a:prstGeom prst="ellipse">
-            <a:avLst/>
-          </a:prstGeom>
-          <a:solidFill>
-            <a:schemeClr val="accent1"/>
+            <a:schemeClr val="accent6"/>
           </a:solidFill>
           <a:ln/>
         </p:spPr>
       </p:sp>
       <p:pic>
         <p:nvPicPr>
-          <p:cNvPr id="22" name="Spots + occupancy icon" descr="Spots + occupancy">    </p:cNvPr>
+          <p:cNvPr id="17" name="Walk-in screenshot" descr="Walk-in screen of the ParkDet app">    </p:cNvPr>
           <p:cNvPicPr>
             <a:picLocks noChangeAspect="1"/>
           </p:cNvPicPr>
@@ -4782,8 +4874,8 @@
         </p:blipFill>
         <p:spPr>
           <a:xfrm>
-            <a:off x="7650785" y="2071299"/>
-            <a:ext cx="228234" cy="228234"/>
+            <a:off x="7661162" y="1709928"/>
+            <a:ext cx="1398577" cy="3026664"/>
           </a:xfrm>
           <a:prstGeom prst="rect">
             <a:avLst/>
@@ -4792,14 +4884,14 @@
       </p:pic>
       <p:sp>
         <p:nvSpPr>
-          <p:cNvPr id="23" name="Spots + occupancy text"/>
+          <p:cNvPr id="18" name="Walk-in title"/>
           <p:cNvSpPr txBox="1"/>
           <p:nvPr/>
         </p:nvSpPr>
         <p:spPr>
           <a:xfrm>
-            <a:off x="7545446" y="2496312"/>
-            <a:ext cx="1710477" cy="640080"/>
+            <a:off x="7342449" y="4983480"/>
+            <a:ext cx="2036003" cy="320040"/>
           </a:xfrm>
           <a:prstGeom prst="rect">
             <a:avLst/>
@@ -4815,101 +4907,78 @@
               <a:buNone/>
             </a:pPr>
             <a:r>
-              <a:rPr lang="en-US" sz="1400" b="1" dirty="0">
+              <a:rPr lang="en-US" sz="1500" b="1" dirty="0">
                 <a:solidFill>
                   <a:schemeClr val="tx1"/>
                 </a:solidFill>
               </a:rPr>
-              <a:t>Spots + occupancy</a:t>
-            </a:r>
-            <a:endParaRPr lang="en-US" sz="1400" dirty="0"/>
-          </a:p>
-          <a:p>
-            <a:pPr indent="0" marL="0">
-              <a:buNone/>
-            </a:pPr>
-            <a:r>
-              <a:rPr lang="en-US" sz="1150" dirty="0">
+              <a:t>Walk-in</a:t>
+            </a:r>
+            <a:endParaRPr lang="en-US" sz="1500" dirty="0"/>
+          </a:p>
+        </p:txBody>
+      </p:sp>
+      <p:sp>
+        <p:nvSpPr>
+          <p:cNvPr id="19" name="Walk-in caption"/>
+          <p:cNvSpPr txBox="1"/>
+          <p:nvPr/>
+        </p:nvSpPr>
+        <p:spPr>
+          <a:xfrm>
+            <a:off x="7342449" y="5321808"/>
+            <a:ext cx="2036003" cy="777240"/>
+          </a:xfrm>
+          <a:prstGeom prst="rect">
+            <a:avLst/>
+          </a:prstGeom>
+          <a:noFill/>
+          <a:ln/>
+        </p:spPr>
+        <p:txBody>
+          <a:bodyPr wrap="square" lIns="0" tIns="0" rIns="0" bIns="0" rtlCol="0" anchor="t"/>
+          <a:lstStyle/>
+          <a:p>
+            <a:pPr indent="0" marL="0">
+              <a:buNone/>
+            </a:pPr>
+            <a:r>
+              <a:rPr lang="en-US" sz="1200" dirty="0">
                 <a:solidFill>
                   <a:schemeClr val="tx2"/>
                 </a:solidFill>
               </a:rPr>
-              <a:t>found automatically, cautious</a:t>
-            </a:r>
-            <a:endParaRPr lang="en-US" sz="1400" dirty="0"/>
-          </a:p>
-        </p:txBody>
-      </p:sp>
-      <p:sp>
-        <p:nvSpPr>
-          <p:cNvPr id="24" name="flow arrow 4"/>
+              <a:t>Scan the gate QR, get a spot, pay before leaving</a:t>
+            </a:r>
+            <a:endParaRPr lang="en-US" sz="1200" dirty="0"/>
+          </a:p>
+        </p:txBody>
+      </p:sp>
+      <p:sp>
+        <p:nvSpPr>
+          <p:cNvPr id="20" name="Entrance screen tile"/>
           <p:cNvSpPr/>
           <p:nvPr/>
         </p:nvSpPr>
         <p:spPr>
           <a:xfrm>
-            <a:off x="9438803" y="2377440"/>
-            <a:ext cx="146304" cy="237744"/>
-          </a:xfrm>
-          <a:prstGeom prst="chevron">
-            <a:avLst/>
-          </a:prstGeom>
-          <a:solidFill>
-            <a:schemeClr val="accent1"/>
-          </a:solidFill>
-          <a:ln/>
-        </p:spPr>
-      </p:sp>
-      <p:sp>
-        <p:nvSpPr>
-          <p:cNvPr id="25" name="Driver app step"/>
-          <p:cNvSpPr/>
-          <p:nvPr/>
-        </p:nvSpPr>
-        <p:spPr>
-          <a:xfrm>
-            <a:off x="9658259" y="1810512"/>
-            <a:ext cx="1984797" cy="1371600"/>
+            <a:off x="9607052" y="1600200"/>
+            <a:ext cx="2036003" cy="3246120"/>
           </a:xfrm>
           <a:prstGeom prst="roundRect">
             <a:avLst>
-              <a:gd name="adj" fmla="val 8000"/>
+              <a:gd name="adj" fmla="val 4491"/>
             </a:avLst>
           </a:prstGeom>
           <a:solidFill>
-            <a:schemeClr val="bg1"/>
-          </a:solidFill>
-          <a:ln w="12700">
-            <a:solidFill>
-              <a:srgbClr val="E6ECF4"/>
-            </a:solidFill>
-            <a:prstDash val="solid"/>
-          </a:ln>
-        </p:spPr>
-      </p:sp>
-      <p:sp>
-        <p:nvSpPr>
-          <p:cNvPr id="26" name="Driver app circle"/>
-          <p:cNvSpPr/>
-          <p:nvPr/>
-        </p:nvSpPr>
-        <p:spPr>
-          <a:xfrm>
-            <a:off x="9822851" y="1965960"/>
-            <a:ext cx="438912" cy="438912"/>
-          </a:xfrm>
-          <a:prstGeom prst="ellipse">
-            <a:avLst/>
-          </a:prstGeom>
-          <a:solidFill>
-            <a:schemeClr val="accent1"/>
+            <a:schemeClr val="accent6"/>
           </a:solidFill>
           <a:ln/>
         </p:spPr>
       </p:sp>
       <p:pic>
         <p:nvPicPr>
-          <p:cNvPr id="27" name="Driver app icon" descr="Driver app">    </p:cNvPr>
+          <p:cNvPr id="21" name="Entrance screen screenshot" descr="Entrance screen screen of the ParkDet app">    </p:cNvPr>
           <p:cNvPicPr>
             <a:picLocks noChangeAspect="1"/>
           </p:cNvPicPr>
@@ -4923,8 +4992,8 @@
         </p:blipFill>
         <p:spPr>
           <a:xfrm>
-            <a:off x="9928189" y="2071299"/>
-            <a:ext cx="228234" cy="228234"/>
+            <a:off x="9716780" y="2712356"/>
+            <a:ext cx="1816547" cy="1021808"/>
           </a:xfrm>
           <a:prstGeom prst="rect">
             <a:avLst/>
@@ -4933,14 +5002,14 @@
       </p:pic>
       <p:sp>
         <p:nvSpPr>
-          <p:cNvPr id="28" name="Driver app text"/>
+          <p:cNvPr id="22" name="Entrance screen title"/>
           <p:cNvSpPr txBox="1"/>
           <p:nvPr/>
         </p:nvSpPr>
         <p:spPr>
           <a:xfrm>
-            <a:off x="9822851" y="2496312"/>
-            <a:ext cx="1710477" cy="640080"/>
+            <a:off x="9607052" y="4983480"/>
+            <a:ext cx="2036003" cy="320040"/>
           </a:xfrm>
           <a:prstGeom prst="rect">
             <a:avLst/>
@@ -4956,68 +5025,63 @@
               <a:buNone/>
             </a:pPr>
             <a:r>
-              <a:rPr lang="en-US" sz="1400" b="1" dirty="0">
+              <a:rPr lang="en-US" sz="1500" b="1" dirty="0">
                 <a:solidFill>
                   <a:schemeClr val="tx1"/>
                 </a:solidFill>
               </a:rPr>
-              <a:t>Driver app</a:t>
-            </a:r>
-            <a:endParaRPr lang="en-US" sz="1400" dirty="0"/>
-          </a:p>
-          <a:p>
-            <a:pPr indent="0" marL="0">
-              <a:buNone/>
-            </a:pPr>
-            <a:r>
-              <a:rPr lang="en-US" sz="1150" dirty="0">
+              <a:t>Entrance screen</a:t>
+            </a:r>
+            <a:endParaRPr lang="en-US" sz="1500" dirty="0"/>
+          </a:p>
+        </p:txBody>
+      </p:sp>
+      <p:sp>
+        <p:nvSpPr>
+          <p:cNvPr id="23" name="Entrance screen caption"/>
+          <p:cNvSpPr txBox="1"/>
+          <p:nvPr/>
+        </p:nvSpPr>
+        <p:spPr>
+          <a:xfrm>
+            <a:off x="9607052" y="5321808"/>
+            <a:ext cx="2036003" cy="777240"/>
+          </a:xfrm>
+          <a:prstGeom prst="rect">
+            <a:avLst/>
+          </a:prstGeom>
+          <a:noFill/>
+          <a:ln/>
+        </p:spPr>
+        <p:txBody>
+          <a:bodyPr wrap="square" lIns="0" tIns="0" rIns="0" bIns="0" rtlCol="0" anchor="t"/>
+          <a:lstStyle/>
+          <a:p>
+            <a:pPr indent="0" marL="0">
+              <a:buNone/>
+            </a:pPr>
+            <a:r>
+              <a:rPr lang="en-US" sz="1200" dirty="0">
                 <a:solidFill>
                   <a:schemeClr val="tx2"/>
                 </a:solidFill>
               </a:rPr>
-              <a:t>map, booking, directions — live</a:t>
-            </a:r>
-            <a:endParaRPr lang="en-US" sz="1400" dirty="0"/>
-          </a:p>
-        </p:txBody>
-      </p:sp>
-      <p:sp>
-        <p:nvSpPr>
-          <p:cNvPr id="29" name="measured card"/>
-          <p:cNvSpPr/>
-          <p:nvPr/>
-        </p:nvSpPr>
-        <p:spPr>
-          <a:xfrm>
-            <a:off x="548640" y="3456432"/>
-            <a:ext cx="3515258" cy="2103120"/>
-          </a:xfrm>
-          <a:prstGeom prst="roundRect">
-            <a:avLst>
-              <a:gd name="adj" fmla="val 5217"/>
-            </a:avLst>
-          </a:prstGeom>
-          <a:solidFill>
-            <a:schemeClr val="bg1"/>
-          </a:solidFill>
-          <a:ln w="12700">
-            <a:solidFill>
-              <a:srgbClr val="E6ECF4"/>
-            </a:solidFill>
-            <a:prstDash val="solid"/>
-          </a:ln>
-        </p:spPr>
-      </p:sp>
-      <p:sp>
-        <p:nvSpPr>
-          <p:cNvPr id="30" name="MEASURED label"/>
+              <a:t>Free count and the nearest spot, big and simple</a:t>
+            </a:r>
+            <a:endParaRPr lang="en-US" sz="1200" dirty="0"/>
+          </a:p>
+        </p:txBody>
+      </p:sp>
+      <p:sp>
+        <p:nvSpPr>
+          <p:cNvPr id="24" name="screens note"/>
           <p:cNvSpPr txBox="1"/>
           <p:nvPr/>
         </p:nvSpPr>
         <p:spPr>
           <a:xfrm>
-            <a:off x="822960" y="3657600"/>
-            <a:ext cx="2966618" cy="274320"/>
+            <a:off x="4114800" y="6355080"/>
+            <a:ext cx="6949440" cy="274320"/>
           </a:xfrm>
           <a:prstGeom prst="rect">
             <a:avLst/>
@@ -5029,843 +5093,18 @@
           <a:bodyPr wrap="square" lIns="0" tIns="0" rIns="0" bIns="0" rtlCol="0" anchor="t"/>
           <a:lstStyle/>
           <a:p>
-            <a:pPr indent="0" marL="0">
-              <a:buNone/>
-            </a:pPr>
-            <a:r>
-              <a:rPr lang="en-US" sz="1200" b="1" spc="200" kern="0" dirty="0">
-                <a:solidFill>
-                  <a:schemeClr val="accent1"/>
-                </a:solidFill>
-              </a:rPr>
-              <a:t>MEASURED</a:t>
-            </a:r>
-            <a:endParaRPr lang="en-US" sz="1200" dirty="0"/>
-          </a:p>
-        </p:txBody>
-      </p:sp>
-      <p:sp>
-        <p:nvSpPr>
-          <p:cNvPr id="31" name="Text 24"/>
-          <p:cNvSpPr txBox="1"/>
-          <p:nvPr/>
-        </p:nvSpPr>
-        <p:spPr>
-          <a:xfrm>
-            <a:off x="822960" y="4023360"/>
-            <a:ext cx="1325880" cy="411480"/>
-          </a:xfrm>
-          <a:prstGeom prst="rect">
-            <a:avLst/>
-          </a:prstGeom>
-          <a:noFill/>
-          <a:ln/>
-        </p:spPr>
-        <p:txBody>
-          <a:bodyPr wrap="square" lIns="0" tIns="0" rIns="0" bIns="0" rtlCol="0" anchor="ctr"/>
-          <a:lstStyle/>
-          <a:p>
-            <a:pPr indent="0" marL="0">
-              <a:buNone/>
-            </a:pPr>
-            <a:r>
-              <a:rPr lang="en-US" sz="2100" b="1" dirty="0">
-                <a:solidFill>
-                  <a:schemeClr val="accent1"/>
-                </a:solidFill>
-              </a:rPr>
-              <a:t>0.14 s</a:t>
-            </a:r>
-            <a:endParaRPr lang="en-US" sz="2100" dirty="0"/>
-          </a:p>
-        </p:txBody>
-      </p:sp>
-      <p:sp>
-        <p:nvSpPr>
-          <p:cNvPr id="32" name="Text 25"/>
-          <p:cNvSpPr txBox="1"/>
-          <p:nvPr/>
-        </p:nvSpPr>
-        <p:spPr>
-          <a:xfrm>
-            <a:off x="2194560" y="4023360"/>
-            <a:ext cx="1640738" cy="411480"/>
-          </a:xfrm>
-          <a:prstGeom prst="rect">
-            <a:avLst/>
-          </a:prstGeom>
-          <a:noFill/>
-          <a:ln/>
-        </p:spPr>
-        <p:txBody>
-          <a:bodyPr wrap="square" lIns="0" tIns="0" rIns="0" bIns="0" rtlCol="0" anchor="ctr"/>
-          <a:lstStyle/>
-          <a:p>
-            <a:pPr indent="0" marL="0">
-              <a:buNone/>
-            </a:pPr>
-            <a:r>
-              <a:rPr lang="en-US" sz="1200" dirty="0">
+            <a:pPr algn="r" indent="0" marL="0">
+              <a:buNone/>
+            </a:pPr>
+            <a:r>
+              <a:rPr lang="en-US" sz="1000" dirty="0">
                 <a:solidFill>
                   <a:schemeClr val="tx2"/>
                 </a:solidFill>
               </a:rPr>
-              <a:t>per camera frame, 4-core CPU, no GPU</a:t>
-            </a:r>
-            <a:endParaRPr lang="en-US" sz="1200" dirty="0"/>
-          </a:p>
-        </p:txBody>
-      </p:sp>
-      <p:sp>
-        <p:nvSpPr>
-          <p:cNvPr id="33" name="Text 26"/>
-          <p:cNvSpPr txBox="1"/>
-          <p:nvPr/>
-        </p:nvSpPr>
-        <p:spPr>
-          <a:xfrm>
-            <a:off x="822960" y="4507992"/>
-            <a:ext cx="1325880" cy="411480"/>
-          </a:xfrm>
-          <a:prstGeom prst="rect">
-            <a:avLst/>
-          </a:prstGeom>
-          <a:noFill/>
-          <a:ln/>
-        </p:spPr>
-        <p:txBody>
-          <a:bodyPr wrap="square" lIns="0" tIns="0" rIns="0" bIns="0" rtlCol="0" anchor="ctr"/>
-          <a:lstStyle/>
-          <a:p>
-            <a:pPr indent="0" marL="0">
-              <a:buNone/>
-            </a:pPr>
-            <a:r>
-              <a:rPr lang="en-US" sz="2100" b="1" dirty="0">
-                <a:solidFill>
-                  <a:schemeClr val="accent1"/>
-                </a:solidFill>
-              </a:rPr>
-              <a:t>&lt; 400 MB</a:t>
-            </a:r>
-            <a:endParaRPr lang="en-US" sz="2100" dirty="0"/>
-          </a:p>
-        </p:txBody>
-      </p:sp>
-      <p:sp>
-        <p:nvSpPr>
-          <p:cNvPr id="34" name="Text 27"/>
-          <p:cNvSpPr txBox="1"/>
-          <p:nvPr/>
-        </p:nvSpPr>
-        <p:spPr>
-          <a:xfrm>
-            <a:off x="2194560" y="4507992"/>
-            <a:ext cx="1640738" cy="411480"/>
-          </a:xfrm>
-          <a:prstGeom prst="rect">
-            <a:avLst/>
-          </a:prstGeom>
-          <a:noFill/>
-          <a:ln/>
-        </p:spPr>
-        <p:txBody>
-          <a:bodyPr wrap="square" lIns="0" tIns="0" rIns="0" bIns="0" rtlCol="0" anchor="ctr"/>
-          <a:lstStyle/>
-          <a:p>
-            <a:pPr indent="0" marL="0">
-              <a:buNone/>
-            </a:pPr>
-            <a:r>
-              <a:rPr lang="en-US" sz="1200" dirty="0">
-                <a:solidFill>
-                  <a:schemeClr val="tx2"/>
-                </a:solidFill>
-              </a:rPr>
-              <a:t>server memory</a:t>
-            </a:r>
-            <a:endParaRPr lang="en-US" sz="1200" dirty="0"/>
-          </a:p>
-        </p:txBody>
-      </p:sp>
-      <p:sp>
-        <p:nvSpPr>
-          <p:cNvPr id="35" name="Text 28"/>
-          <p:cNvSpPr txBox="1"/>
-          <p:nvPr/>
-        </p:nvSpPr>
-        <p:spPr>
-          <a:xfrm>
-            <a:off x="822960" y="4992624"/>
-            <a:ext cx="1325880" cy="411480"/>
-          </a:xfrm>
-          <a:prstGeom prst="rect">
-            <a:avLst/>
-          </a:prstGeom>
-          <a:noFill/>
-          <a:ln/>
-        </p:spPr>
-        <p:txBody>
-          <a:bodyPr wrap="square" lIns="0" tIns="0" rIns="0" bIns="0" rtlCol="0" anchor="ctr"/>
-          <a:lstStyle/>
-          <a:p>
-            <a:pPr indent="0" marL="0">
-              <a:buNone/>
-            </a:pPr>
-            <a:r>
-              <a:rPr lang="en-US" sz="2100" b="1" dirty="0">
-                <a:solidFill>
-                  <a:schemeClr val="accent1"/>
-                </a:solidFill>
-              </a:rPr>
-              <a:t>~20</a:t>
-            </a:r>
-            <a:endParaRPr lang="en-US" sz="2100" dirty="0"/>
-          </a:p>
-        </p:txBody>
-      </p:sp>
-      <p:sp>
-        <p:nvSpPr>
-          <p:cNvPr id="36" name="Text 29"/>
-          <p:cNvSpPr txBox="1"/>
-          <p:nvPr/>
-        </p:nvSpPr>
-        <p:spPr>
-          <a:xfrm>
-            <a:off x="2194560" y="4992624"/>
-            <a:ext cx="1640738" cy="411480"/>
-          </a:xfrm>
-          <a:prstGeom prst="rect">
-            <a:avLst/>
-          </a:prstGeom>
-          <a:noFill/>
-          <a:ln/>
-        </p:spPr>
-        <p:txBody>
-          <a:bodyPr wrap="square" lIns="0" tIns="0" rIns="0" bIns="0" rtlCol="0" anchor="ctr"/>
-          <a:lstStyle/>
-          <a:p>
-            <a:pPr indent="0" marL="0">
-              <a:buNone/>
-            </a:pPr>
-            <a:r>
-              <a:rPr lang="en-US" sz="1200" dirty="0">
-                <a:solidFill>
-                  <a:schemeClr val="tx2"/>
-                </a:solidFill>
-              </a:rPr>
-              <a:t>cameras per small server (we plan 8)</a:t>
-            </a:r>
-            <a:endParaRPr lang="en-US" sz="1200" dirty="0"/>
-          </a:p>
-        </p:txBody>
-      </p:sp>
-      <p:sp>
-        <p:nvSpPr>
-          <p:cNvPr id="37" name="real conditions card"/>
-          <p:cNvSpPr/>
-          <p:nvPr/>
-        </p:nvSpPr>
-        <p:spPr>
-          <a:xfrm>
-            <a:off x="4338218" y="3456432"/>
-            <a:ext cx="3515258" cy="2103120"/>
-          </a:xfrm>
-          <a:prstGeom prst="roundRect">
-            <a:avLst>
-              <a:gd name="adj" fmla="val 5217"/>
-            </a:avLst>
-          </a:prstGeom>
-          <a:solidFill>
-            <a:schemeClr val="bg1"/>
-          </a:solidFill>
-          <a:ln w="12700">
-            <a:solidFill>
-              <a:srgbClr val="E6ECF4"/>
-            </a:solidFill>
-            <a:prstDash val="solid"/>
-          </a:ln>
-        </p:spPr>
-      </p:sp>
-      <p:sp>
-        <p:nvSpPr>
-          <p:cNvPr id="38" name="REAL CONDITIONS label"/>
-          <p:cNvSpPr txBox="1"/>
-          <p:nvPr/>
-        </p:nvSpPr>
-        <p:spPr>
-          <a:xfrm>
-            <a:off x="4612538" y="3657600"/>
-            <a:ext cx="2966618" cy="274320"/>
-          </a:xfrm>
-          <a:prstGeom prst="rect">
-            <a:avLst/>
-          </a:prstGeom>
-          <a:noFill/>
-          <a:ln/>
-        </p:spPr>
-        <p:txBody>
-          <a:bodyPr wrap="square" lIns="0" tIns="0" rIns="0" bIns="0" rtlCol="0" anchor="t"/>
-          <a:lstStyle/>
-          <a:p>
-            <a:pPr indent="0" marL="0">
-              <a:buNone/>
-            </a:pPr>
-            <a:r>
-              <a:rPr lang="en-US" sz="1200" b="1" spc="200" kern="0" dirty="0">
-                <a:solidFill>
-                  <a:schemeClr val="accent1"/>
-                </a:solidFill>
-              </a:rPr>
-              <a:t>REAL CONDITIONS</a:t>
-            </a:r>
-            <a:endParaRPr lang="en-US" sz="1200" dirty="0"/>
-          </a:p>
-        </p:txBody>
-      </p:sp>
-      <p:sp>
-        <p:nvSpPr>
-          <p:cNvPr id="39" name="Night: a 2nd, brightened view circle"/>
-          <p:cNvSpPr/>
-          <p:nvPr/>
-        </p:nvSpPr>
-        <p:spPr>
-          <a:xfrm>
-            <a:off x="4612538" y="4050792"/>
-            <a:ext cx="274320" cy="274320"/>
-          </a:xfrm>
-          <a:prstGeom prst="ellipse">
-            <a:avLst/>
-          </a:prstGeom>
-          <a:solidFill>
-            <a:schemeClr val="accent2"/>
-          </a:solidFill>
-          <a:ln/>
-        </p:spPr>
-      </p:sp>
-      <p:pic>
-        <p:nvPicPr>
-          <p:cNvPr id="40" name="Night: a 2nd, brightened view icon" descr="Night: a 2nd, brightened view">    </p:cNvPr>
-          <p:cNvPicPr>
-            <a:picLocks noChangeAspect="1"/>
-          </p:cNvPicPr>
-          <p:nvPr/>
-        </p:nvPicPr>
-        <p:blipFill>
-          <a:blip r:embed="rId6"/>
-          <a:stretch>
-            <a:fillRect/>
-          </a:stretch>
-        </p:blipFill>
-        <p:spPr>
-          <a:xfrm>
-            <a:off x="4678375" y="4116629"/>
-            <a:ext cx="142646" cy="142646"/>
-          </a:xfrm>
-          <a:prstGeom prst="rect">
-            <a:avLst/>
-          </a:prstGeom>
-        </p:spPr>
-      </p:pic>
-      <p:sp>
-        <p:nvSpPr>
-          <p:cNvPr id="41" name="Text 33"/>
-          <p:cNvSpPr txBox="1"/>
-          <p:nvPr/>
-        </p:nvSpPr>
-        <p:spPr>
-          <a:xfrm>
-            <a:off x="5024018" y="4023360"/>
-            <a:ext cx="2600858" cy="329184"/>
-          </a:xfrm>
-          <a:prstGeom prst="rect">
-            <a:avLst/>
-          </a:prstGeom>
-          <a:noFill/>
-          <a:ln/>
-        </p:spPr>
-        <p:txBody>
-          <a:bodyPr wrap="square" lIns="0" tIns="0" rIns="0" bIns="0" rtlCol="0" anchor="ctr"/>
-          <a:lstStyle/>
-          <a:p>
-            <a:pPr indent="0" marL="0">
-              <a:buNone/>
-            </a:pPr>
-            <a:r>
-              <a:rPr lang="en-US" sz="1250" dirty="0">
-                <a:solidFill>
-                  <a:schemeClr val="tx2"/>
-                </a:solidFill>
-              </a:rPr>
-              <a:t>Night: a 2nd, brightened view</a:t>
-            </a:r>
-            <a:endParaRPr lang="en-US" sz="1250" dirty="0"/>
-          </a:p>
-        </p:txBody>
-      </p:sp>
-      <p:sp>
-        <p:nvSpPr>
-          <p:cNvPr id="42" name="Rain, fog, blur: warning shown circle"/>
-          <p:cNvSpPr/>
-          <p:nvPr/>
-        </p:nvSpPr>
-        <p:spPr>
-          <a:xfrm>
-            <a:off x="4612538" y="4416552"/>
-            <a:ext cx="274320" cy="274320"/>
-          </a:xfrm>
-          <a:prstGeom prst="ellipse">
-            <a:avLst/>
-          </a:prstGeom>
-          <a:solidFill>
-            <a:schemeClr val="accent2"/>
-          </a:solidFill>
-          <a:ln/>
-        </p:spPr>
-      </p:sp>
-      <p:pic>
-        <p:nvPicPr>
-          <p:cNvPr id="43" name="Rain, fog, blur: warning shown icon" descr="Rain, fog, blur: warning shown">    </p:cNvPr>
-          <p:cNvPicPr>
-            <a:picLocks noChangeAspect="1"/>
-          </p:cNvPicPr>
-          <p:nvPr/>
-        </p:nvPicPr>
-        <p:blipFill>
-          <a:blip r:embed="rId7"/>
-          <a:stretch>
-            <a:fillRect/>
-          </a:stretch>
-        </p:blipFill>
-        <p:spPr>
-          <a:xfrm>
-            <a:off x="4678375" y="4482389"/>
-            <a:ext cx="142646" cy="142646"/>
-          </a:xfrm>
-          <a:prstGeom prst="rect">
-            <a:avLst/>
-          </a:prstGeom>
-        </p:spPr>
-      </p:pic>
-      <p:sp>
-        <p:nvSpPr>
-          <p:cNvPr id="44" name="Text 35"/>
-          <p:cNvSpPr txBox="1"/>
-          <p:nvPr/>
-        </p:nvSpPr>
-        <p:spPr>
-          <a:xfrm>
-            <a:off x="5024018" y="4389120"/>
-            <a:ext cx="2600858" cy="329184"/>
-          </a:xfrm>
-          <a:prstGeom prst="rect">
-            <a:avLst/>
-          </a:prstGeom>
-          <a:noFill/>
-          <a:ln/>
-        </p:spPr>
-        <p:txBody>
-          <a:bodyPr wrap="square" lIns="0" tIns="0" rIns="0" bIns="0" rtlCol="0" anchor="ctr"/>
-          <a:lstStyle/>
-          <a:p>
-            <a:pPr indent="0" marL="0">
-              <a:buNone/>
-            </a:pPr>
-            <a:r>
-              <a:rPr lang="en-US" sz="1250" dirty="0">
-                <a:solidFill>
-                  <a:schemeClr val="tx2"/>
-                </a:solidFill>
-              </a:rPr>
-              <a:t>Rain, fog, blur: warning shown</a:t>
-            </a:r>
-            <a:endParaRPr lang="en-US" sz="1250" dirty="0"/>
-          </a:p>
-        </p:txBody>
-      </p:sp>
-      <p:sp>
-        <p:nvSpPr>
-          <p:cNvPr id="45" name="Offline: “no data”, no booking circle"/>
-          <p:cNvSpPr/>
-          <p:nvPr/>
-        </p:nvSpPr>
-        <p:spPr>
-          <a:xfrm>
-            <a:off x="4612538" y="4782312"/>
-            <a:ext cx="274320" cy="274320"/>
-          </a:xfrm>
-          <a:prstGeom prst="ellipse">
-            <a:avLst/>
-          </a:prstGeom>
-          <a:solidFill>
-            <a:schemeClr val="accent2"/>
-          </a:solidFill>
-          <a:ln/>
-        </p:spPr>
-      </p:sp>
-      <p:pic>
-        <p:nvPicPr>
-          <p:cNvPr id="46" name="Offline: “no data”, no booking icon" descr="Offline: “no data”, no booking">    </p:cNvPr>
-          <p:cNvPicPr>
-            <a:picLocks noChangeAspect="1"/>
-          </p:cNvPicPr>
-          <p:nvPr/>
-        </p:nvPicPr>
-        <p:blipFill>
-          <a:blip r:embed="rId8"/>
-          <a:stretch>
-            <a:fillRect/>
-          </a:stretch>
-        </p:blipFill>
-        <p:spPr>
-          <a:xfrm>
-            <a:off x="4678375" y="4848149"/>
-            <a:ext cx="142646" cy="142646"/>
-          </a:xfrm>
-          <a:prstGeom prst="rect">
-            <a:avLst/>
-          </a:prstGeom>
-        </p:spPr>
-      </p:pic>
-      <p:sp>
-        <p:nvSpPr>
-          <p:cNvPr id="47" name="Text 37"/>
-          <p:cNvSpPr txBox="1"/>
-          <p:nvPr/>
-        </p:nvSpPr>
-        <p:spPr>
-          <a:xfrm>
-            <a:off x="5024018" y="4754880"/>
-            <a:ext cx="2600858" cy="329184"/>
-          </a:xfrm>
-          <a:prstGeom prst="rect">
-            <a:avLst/>
-          </a:prstGeom>
-          <a:noFill/>
-          <a:ln/>
-        </p:spPr>
-        <p:txBody>
-          <a:bodyPr wrap="square" lIns="0" tIns="0" rIns="0" bIns="0" rtlCol="0" anchor="ctr"/>
-          <a:lstStyle/>
-          <a:p>
-            <a:pPr indent="0" marL="0">
-              <a:buNone/>
-            </a:pPr>
-            <a:r>
-              <a:rPr lang="en-US" sz="1250" dirty="0">
-                <a:solidFill>
-                  <a:schemeClr val="tx2"/>
-                </a:solidFill>
-              </a:rPr>
-              <a:t>Offline: “no data”, no booking</a:t>
-            </a:r>
-            <a:endParaRPr lang="en-US" sz="1250" dirty="0"/>
-          </a:p>
-        </p:txBody>
-      </p:sp>
-      <p:sp>
-        <p:nvSpPr>
-          <p:cNvPr id="48" name="Privacy: never saved, pixelated circle"/>
-          <p:cNvSpPr/>
-          <p:nvPr/>
-        </p:nvSpPr>
-        <p:spPr>
-          <a:xfrm>
-            <a:off x="4612538" y="5148072"/>
-            <a:ext cx="274320" cy="274320"/>
-          </a:xfrm>
-          <a:prstGeom prst="ellipse">
-            <a:avLst/>
-          </a:prstGeom>
-          <a:solidFill>
-            <a:schemeClr val="accent2"/>
-          </a:solidFill>
-          <a:ln/>
-        </p:spPr>
-      </p:sp>
-      <p:pic>
-        <p:nvPicPr>
-          <p:cNvPr id="49" name="Privacy: never saved, pixelated icon" descr="Privacy: never saved, pixelated">    </p:cNvPr>
-          <p:cNvPicPr>
-            <a:picLocks noChangeAspect="1"/>
-          </p:cNvPicPr>
-          <p:nvPr/>
-        </p:nvPicPr>
-        <p:blipFill>
-          <a:blip r:embed="rId9"/>
-          <a:stretch>
-            <a:fillRect/>
-          </a:stretch>
-        </p:blipFill>
-        <p:spPr>
-          <a:xfrm>
-            <a:off x="4678375" y="5213909"/>
-            <a:ext cx="142646" cy="142646"/>
-          </a:xfrm>
-          <a:prstGeom prst="rect">
-            <a:avLst/>
-          </a:prstGeom>
-        </p:spPr>
-      </p:pic>
-      <p:sp>
-        <p:nvSpPr>
-          <p:cNvPr id="50" name="Text 39"/>
-          <p:cNvSpPr txBox="1"/>
-          <p:nvPr/>
-        </p:nvSpPr>
-        <p:spPr>
-          <a:xfrm>
-            <a:off x="5024018" y="5120640"/>
-            <a:ext cx="2600858" cy="329184"/>
-          </a:xfrm>
-          <a:prstGeom prst="rect">
-            <a:avLst/>
-          </a:prstGeom>
-          <a:noFill/>
-          <a:ln/>
-        </p:spPr>
-        <p:txBody>
-          <a:bodyPr wrap="square" lIns="0" tIns="0" rIns="0" bIns="0" rtlCol="0" anchor="ctr"/>
-          <a:lstStyle/>
-          <a:p>
-            <a:pPr indent="0" marL="0">
-              <a:buNone/>
-            </a:pPr>
-            <a:r>
-              <a:rPr lang="en-US" sz="1250" dirty="0">
-                <a:solidFill>
-                  <a:schemeClr val="tx2"/>
-                </a:solidFill>
-              </a:rPr>
-              <a:t>Privacy: never saved, pixelated</a:t>
-            </a:r>
-            <a:endParaRPr lang="en-US" sz="1250" dirty="0"/>
-          </a:p>
-        </p:txBody>
-      </p:sp>
-      <p:sp>
-        <p:nvSpPr>
-          <p:cNvPr id="51" name="accuracy card"/>
-          <p:cNvSpPr/>
-          <p:nvPr/>
-        </p:nvSpPr>
-        <p:spPr>
-          <a:xfrm>
-            <a:off x="8127797" y="3456432"/>
-            <a:ext cx="3515258" cy="2103120"/>
-          </a:xfrm>
-          <a:prstGeom prst="roundRect">
-            <a:avLst>
-              <a:gd name="adj" fmla="val 5217"/>
-            </a:avLst>
-          </a:prstGeom>
-          <a:solidFill>
-            <a:schemeClr val="bg1"/>
-          </a:solidFill>
-          <a:ln w="12700">
-            <a:solidFill>
-              <a:srgbClr val="E6ECF4"/>
-            </a:solidFill>
-            <a:prstDash val="solid"/>
-          </a:ln>
-        </p:spPr>
-      </p:sp>
-      <p:sp>
-        <p:nvSpPr>
-          <p:cNvPr id="52" name="ACCURACY label"/>
-          <p:cNvSpPr txBox="1"/>
-          <p:nvPr/>
-        </p:nvSpPr>
-        <p:spPr>
-          <a:xfrm>
-            <a:off x="8402117" y="3657600"/>
-            <a:ext cx="2966618" cy="274320"/>
-          </a:xfrm>
-          <a:prstGeom prst="rect">
-            <a:avLst/>
-          </a:prstGeom>
-          <a:noFill/>
-          <a:ln/>
-        </p:spPr>
-        <p:txBody>
-          <a:bodyPr wrap="square" lIns="0" tIns="0" rIns="0" bIns="0" rtlCol="0" anchor="t"/>
-          <a:lstStyle/>
-          <a:p>
-            <a:pPr indent="0" marL="0">
-              <a:buNone/>
-            </a:pPr>
-            <a:r>
-              <a:rPr lang="en-US" sz="1200" b="1" spc="200" kern="0" dirty="0">
-                <a:solidFill>
-                  <a:schemeClr val="accent1"/>
-                </a:solidFill>
-              </a:rPr>
-              <a:t>ACCURACY</a:t>
-            </a:r>
-            <a:endParaRPr lang="en-US" sz="1200" dirty="0"/>
-          </a:p>
-        </p:txBody>
-      </p:sp>
-      <p:sp>
-        <p:nvSpPr>
-          <p:cNvPr id="53" name="accuracy value"/>
-          <p:cNvSpPr txBox="1"/>
-          <p:nvPr/>
-        </p:nvSpPr>
-        <p:spPr>
-          <a:xfrm>
-            <a:off x="8402117" y="4005072"/>
-            <a:ext cx="2966618" cy="640080"/>
-          </a:xfrm>
-          <a:prstGeom prst="rect">
-            <a:avLst/>
-          </a:prstGeom>
-          <a:noFill/>
-          <a:ln/>
-        </p:spPr>
-        <p:txBody>
-          <a:bodyPr wrap="square" lIns="0" tIns="0" rIns="0" bIns="0" rtlCol="0" anchor="ctr"/>
-          <a:lstStyle/>
-          <a:p>
-            <a:pPr indent="0" marL="0">
-              <a:buNone/>
-            </a:pPr>
-            <a:r>
-              <a:rPr lang="en-US" sz="3600" b="1" dirty="0">
-                <a:solidFill>
-                  <a:schemeClr val="accent1"/>
-                </a:solidFill>
-              </a:rPr>
-              <a:t>[__%]</a:t>
-            </a:r>
-            <a:endParaRPr lang="en-US" sz="3600" dirty="0"/>
-          </a:p>
-        </p:txBody>
-      </p:sp>
-      <p:sp>
-        <p:nvSpPr>
-          <p:cNvPr id="54" name="accuracy note"/>
-          <p:cNvSpPr txBox="1"/>
-          <p:nvPr/>
-        </p:nvSpPr>
-        <p:spPr>
-          <a:xfrm>
-            <a:off x="8402117" y="4690872"/>
-            <a:ext cx="2966618" cy="731520"/>
-          </a:xfrm>
-          <a:prstGeom prst="rect">
-            <a:avLst/>
-          </a:prstGeom>
-          <a:noFill/>
-          <a:ln/>
-        </p:spPr>
-        <p:txBody>
-          <a:bodyPr wrap="square" lIns="0" tIns="0" rIns="0" bIns="0" rtlCol="0" anchor="t"/>
-          <a:lstStyle/>
-          <a:p>
-            <a:pPr indent="0" marL="0">
-              <a:buNone/>
-            </a:pPr>
-            <a:r>
-              <a:rPr lang="en-US" sz="1250" dirty="0">
-                <a:solidFill>
-                  <a:schemeClr val="tx2"/>
-                </a:solidFill>
-              </a:rPr>
-              <a:t>of spots right on our own Tashkent photos — measured with our built-in labelling tool</a:t>
-            </a:r>
-            <a:endParaRPr lang="en-US" sz="1250" dirty="0"/>
-          </a:p>
-        </p:txBody>
-      </p:sp>
-      <p:sp>
-        <p:nvSpPr>
-          <p:cNvPr id="55" name="sources strip"/>
-          <p:cNvSpPr/>
-          <p:nvPr/>
-        </p:nvSpPr>
-        <p:spPr>
-          <a:xfrm>
-            <a:off x="548640" y="5733288"/>
-            <a:ext cx="11094415" cy="457200"/>
-          </a:xfrm>
-          <a:prstGeom prst="roundRect">
-            <a:avLst>
-              <a:gd name="adj" fmla="val 16000"/>
-            </a:avLst>
-          </a:prstGeom>
-          <a:solidFill>
-            <a:schemeClr val="accent6"/>
-          </a:solidFill>
-          <a:ln/>
-        </p:spPr>
-      </p:sp>
-      <p:sp>
-        <p:nvSpPr>
-          <p:cNvPr id="56" name="sources"/>
-          <p:cNvSpPr txBox="1"/>
-          <p:nvPr/>
-        </p:nvSpPr>
-        <p:spPr>
-          <a:xfrm>
-            <a:off x="777240" y="5733288"/>
-            <a:ext cx="10637215" cy="457200"/>
-          </a:xfrm>
-          <a:prstGeom prst="rect">
-            <a:avLst/>
-          </a:prstGeom>
-          <a:noFill/>
-          <a:ln/>
-        </p:spPr>
-        <p:txBody>
-          <a:bodyPr wrap="square" lIns="0" tIns="0" rIns="0" bIns="0" rtlCol="0" anchor="ctr"/>
-          <a:lstStyle/>
-          <a:p>
-            <a:pPr indent="0" marL="0">
-              <a:buNone/>
-            </a:pPr>
-            <a:r>
-              <a:rPr lang="en-US" sz="1200" b="1" dirty="0">
-                <a:solidFill>
-                  <a:schemeClr val="tx1"/>
-                </a:solidFill>
-              </a:rPr>
-              <a:t>Open models: </a:t>
-            </a:r>
-            <a:pPr indent="0" marL="0">
-              <a:buNone/>
-            </a:pPr>
-            <a:r>
-              <a:rPr lang="en-US" sz="1200" dirty="0">
-                <a:solidFill>
-                  <a:schemeClr val="tx2"/>
-                </a:solidFill>
-              </a:rPr>
-              <a:t>YOLO11 (Ultralytics, AGPL-3.0), Leaflet, © OpenStreetMap.     </a:t>
-            </a:r>
-            <a:pPr indent="0" marL="0">
-              <a:buNone/>
-            </a:pPr>
-            <a:r>
-              <a:rPr lang="en-US" sz="1200" b="1" dirty="0">
-                <a:solidFill>
-                  <a:schemeClr val="tx1"/>
-                </a:solidFill>
-              </a:rPr>
-              <a:t>Ours: </a:t>
-            </a:r>
-            <a:pPr indent="0" marL="0">
-              <a:buNone/>
-            </a:pPr>
-            <a:r>
-              <a:rPr lang="en-US" sz="1200" dirty="0">
-                <a:solidFill>
-                  <a:schemeClr val="tx2"/>
-                </a:solidFill>
-              </a:rPr>
-              <a:t>spot discovery, occupancy rules, booking engine, apps.</a:t>
-            </a:r>
-            <a:endParaRPr lang="en-US" sz="1200" dirty="0"/>
+              <a:t>Screens from a test run of the app; payment is in test mode</a:t>
+            </a:r>
+            <a:endParaRPr lang="en-US" sz="1000" dirty="0"/>
           </a:p>
         </p:txBody>
       </p:sp>
@@ -5919,6 +5158,18 @@
   <p:clrMapOvr>
     <a:masterClrMapping/>
   </p:clrMapOvr>
+  <mc:AlternateContent xmlns:mc="http://schemas.openxmlformats.org/markup-compatibility/2006">
+    <mc:Choice xmlns:p159="http://schemas.microsoft.com/office/powerpoint/2015/09/main" Requires="p159">
+      <p:transition xmlns:p14="http://schemas.microsoft.com/office/powerpoint/2010/main" spd="slow" p14:dur="1000">
+        <p159:morph option="byObject"/>
+      </p:transition>
+    </mc:Choice>
+    <mc:Fallback>
+      <p:transition spd="slow">
+        <p:fade/>
+      </p:transition>
+    </mc:Fallback>
+  </mc:AlternateContent>
 </p:sld>
 </file>
 
@@ -5971,7 +5222,7 @@
                   <a:schemeClr val="accent1"/>
                 </a:solidFill>
               </a:rPr>
-              <a:t>COMPETITORS IN UZBEKISTAN</a:t>
+              <a:t>TECHNOLOGY</a:t>
             </a:r>
             <a:endParaRPr lang="en-US" sz="1200" dirty="0"/>
           </a:p>
@@ -6009,6 +5260,1337 @@
                   <a:schemeClr val="tx1"/>
                 </a:solidFill>
               </a:rPr>
+              <a:t>How it works — and what we measured</a:t>
+            </a:r>
+            <a:endParaRPr lang="en-US" sz="3200" dirty="0"/>
+          </a:p>
+        </p:txBody>
+      </p:sp>
+      <p:sp>
+        <p:nvSpPr>
+          <p:cNvPr id="4" name="HOW IT WORKS label"/>
+          <p:cNvSpPr txBox="1"/>
+          <p:nvPr/>
+        </p:nvSpPr>
+        <p:spPr>
+          <a:xfrm>
+            <a:off x="548640" y="1481328"/>
+            <a:ext cx="3657600" cy="274320"/>
+          </a:xfrm>
+          <a:prstGeom prst="rect">
+            <a:avLst/>
+          </a:prstGeom>
+          <a:noFill/>
+          <a:ln/>
+        </p:spPr>
+        <p:txBody>
+          <a:bodyPr wrap="square" lIns="0" tIns="0" rIns="0" bIns="0" rtlCol="0" anchor="t"/>
+          <a:lstStyle/>
+          <a:p>
+            <a:pPr indent="0" marL="0">
+              <a:buNone/>
+            </a:pPr>
+            <a:r>
+              <a:rPr lang="en-US" sz="1200" b="1" spc="200" kern="0" dirty="0">
+                <a:solidFill>
+                  <a:schemeClr val="accent1"/>
+                </a:solidFill>
+              </a:rPr>
+              <a:t>HOW IT WORKS</a:t>
+            </a:r>
+            <a:endParaRPr lang="en-US" sz="1200" dirty="0"/>
+          </a:p>
+        </p:txBody>
+      </p:sp>
+      <p:sp>
+        <p:nvSpPr>
+          <p:cNvPr id="5" name="Phone camera step"/>
+          <p:cNvSpPr/>
+          <p:nvPr/>
+        </p:nvSpPr>
+        <p:spPr>
+          <a:xfrm>
+            <a:off x="548640" y="1810512"/>
+            <a:ext cx="2554148" cy="1371600"/>
+          </a:xfrm>
+          <a:prstGeom prst="roundRect">
+            <a:avLst>
+              <a:gd name="adj" fmla="val 8000"/>
+            </a:avLst>
+          </a:prstGeom>
+          <a:solidFill>
+            <a:schemeClr val="bg1"/>
+          </a:solidFill>
+          <a:ln w="12700">
+            <a:solidFill>
+              <a:srgbClr val="E6ECF4"/>
+            </a:solidFill>
+            <a:prstDash val="solid"/>
+          </a:ln>
+        </p:spPr>
+      </p:sp>
+      <p:sp>
+        <p:nvSpPr>
+          <p:cNvPr id="6" name="Phone camera circle"/>
+          <p:cNvSpPr/>
+          <p:nvPr/>
+        </p:nvSpPr>
+        <p:spPr>
+          <a:xfrm>
+            <a:off x="713232" y="1965960"/>
+            <a:ext cx="438912" cy="438912"/>
+          </a:xfrm>
+          <a:prstGeom prst="ellipse">
+            <a:avLst/>
+          </a:prstGeom>
+          <a:solidFill>
+            <a:schemeClr val="accent1"/>
+          </a:solidFill>
+          <a:ln/>
+        </p:spPr>
+      </p:sp>
+      <p:pic>
+        <p:nvPicPr>
+          <p:cNvPr id="7" name="Phone camera icon" descr="Phone camera">    </p:cNvPr>
+          <p:cNvPicPr>
+            <a:picLocks noChangeAspect="1"/>
+          </p:cNvPicPr>
+          <p:nvPr/>
+        </p:nvPicPr>
+        <p:blipFill>
+          <a:blip r:embed="rId1"/>
+          <a:stretch>
+            <a:fillRect/>
+          </a:stretch>
+        </p:blipFill>
+        <p:spPr>
+          <a:xfrm>
+            <a:off x="818571" y="2071299"/>
+            <a:ext cx="228234" cy="228234"/>
+          </a:xfrm>
+          <a:prstGeom prst="rect">
+            <a:avLst/>
+          </a:prstGeom>
+        </p:spPr>
+      </p:pic>
+      <p:sp>
+        <p:nvSpPr>
+          <p:cNvPr id="8" name="Phone camera text"/>
+          <p:cNvSpPr txBox="1"/>
+          <p:nvPr/>
+        </p:nvSpPr>
+        <p:spPr>
+          <a:xfrm>
+            <a:off x="713232" y="2496312"/>
+            <a:ext cx="2279828" cy="640080"/>
+          </a:xfrm>
+          <a:prstGeom prst="rect">
+            <a:avLst/>
+          </a:prstGeom>
+          <a:noFill/>
+          <a:ln/>
+        </p:spPr>
+        <p:txBody>
+          <a:bodyPr wrap="square" lIns="0" tIns="0" rIns="0" bIns="0" rtlCol="0" anchor="t"/>
+          <a:lstStyle/>
+          <a:p>
+            <a:pPr indent="0" marL="0">
+              <a:buNone/>
+            </a:pPr>
+            <a:r>
+              <a:rPr lang="en-US" sz="1400" b="1" dirty="0">
+                <a:solidFill>
+                  <a:schemeClr val="tx1"/>
+                </a:solidFill>
+              </a:rPr>
+              <a:t>Phone camera</a:t>
+            </a:r>
+            <a:endParaRPr lang="en-US" sz="1400" dirty="0"/>
+          </a:p>
+          <a:p>
+            <a:pPr indent="0" marL="0">
+              <a:buNone/>
+            </a:pPr>
+            <a:r>
+              <a:rPr lang="en-US" sz="1150" dirty="0">
+                <a:solidFill>
+                  <a:schemeClr val="tx2"/>
+                </a:solidFill>
+              </a:rPr>
+              <a:t>one picture every 3–10 s</a:t>
+            </a:r>
+            <a:endParaRPr lang="en-US" sz="1400" dirty="0"/>
+          </a:p>
+        </p:txBody>
+      </p:sp>
+      <p:sp>
+        <p:nvSpPr>
+          <p:cNvPr id="9" name="flow arrow 1"/>
+          <p:cNvSpPr/>
+          <p:nvPr/>
+        </p:nvSpPr>
+        <p:spPr>
+          <a:xfrm>
+            <a:off x="3175940" y="2377440"/>
+            <a:ext cx="146304" cy="237744"/>
+          </a:xfrm>
+          <a:prstGeom prst="chevron">
+            <a:avLst/>
+          </a:prstGeom>
+          <a:solidFill>
+            <a:schemeClr val="accent1"/>
+          </a:solidFill>
+          <a:ln/>
+        </p:spPr>
+      </p:sp>
+      <p:sp>
+        <p:nvSpPr>
+          <p:cNvPr id="10" name="2 detectors, CPU step"/>
+          <p:cNvSpPr/>
+          <p:nvPr/>
+        </p:nvSpPr>
+        <p:spPr>
+          <a:xfrm>
+            <a:off x="3395396" y="1810512"/>
+            <a:ext cx="2554148" cy="1371600"/>
+          </a:xfrm>
+          <a:prstGeom prst="roundRect">
+            <a:avLst>
+              <a:gd name="adj" fmla="val 8000"/>
+            </a:avLst>
+          </a:prstGeom>
+          <a:solidFill>
+            <a:schemeClr val="bg1"/>
+          </a:solidFill>
+          <a:ln w="12700">
+            <a:solidFill>
+              <a:srgbClr val="E6ECF4"/>
+            </a:solidFill>
+            <a:prstDash val="solid"/>
+          </a:ln>
+        </p:spPr>
+      </p:sp>
+      <p:sp>
+        <p:nvSpPr>
+          <p:cNvPr id="11" name="2 detectors, CPU circle"/>
+          <p:cNvSpPr/>
+          <p:nvPr/>
+        </p:nvSpPr>
+        <p:spPr>
+          <a:xfrm>
+            <a:off x="3559988" y="1965960"/>
+            <a:ext cx="438912" cy="438912"/>
+          </a:xfrm>
+          <a:prstGeom prst="ellipse">
+            <a:avLst/>
+          </a:prstGeom>
+          <a:solidFill>
+            <a:schemeClr val="accent1"/>
+          </a:solidFill>
+          <a:ln/>
+        </p:spPr>
+      </p:sp>
+      <p:pic>
+        <p:nvPicPr>
+          <p:cNvPr id="12" name="2 detectors, CPU icon" descr="2 detectors, CPU">    </p:cNvPr>
+          <p:cNvPicPr>
+            <a:picLocks noChangeAspect="1"/>
+          </p:cNvPicPr>
+          <p:nvPr/>
+        </p:nvPicPr>
+        <p:blipFill>
+          <a:blip r:embed="rId2"/>
+          <a:stretch>
+            <a:fillRect/>
+          </a:stretch>
+        </p:blipFill>
+        <p:spPr>
+          <a:xfrm>
+            <a:off x="3665327" y="2071299"/>
+            <a:ext cx="228234" cy="228234"/>
+          </a:xfrm>
+          <a:prstGeom prst="rect">
+            <a:avLst/>
+          </a:prstGeom>
+        </p:spPr>
+      </p:pic>
+      <p:sp>
+        <p:nvSpPr>
+          <p:cNvPr id="13" name="2 detectors, CPU text"/>
+          <p:cNvSpPr txBox="1"/>
+          <p:nvPr/>
+        </p:nvSpPr>
+        <p:spPr>
+          <a:xfrm>
+            <a:off x="3559988" y="2496312"/>
+            <a:ext cx="2279828" cy="640080"/>
+          </a:xfrm>
+          <a:prstGeom prst="rect">
+            <a:avLst/>
+          </a:prstGeom>
+          <a:noFill/>
+          <a:ln/>
+        </p:spPr>
+        <p:txBody>
+          <a:bodyPr wrap="square" lIns="0" tIns="0" rIns="0" bIns="0" rtlCol="0" anchor="t"/>
+          <a:lstStyle/>
+          <a:p>
+            <a:pPr indent="0" marL="0">
+              <a:buNone/>
+            </a:pPr>
+            <a:r>
+              <a:rPr lang="en-US" sz="1400" b="1" dirty="0">
+                <a:solidFill>
+                  <a:schemeClr val="tx1"/>
+                </a:solidFill>
+              </a:rPr>
+              <a:t>2 detectors, CPU</a:t>
+            </a:r>
+            <a:endParaRPr lang="en-US" sz="1400" dirty="0"/>
+          </a:p>
+          <a:p>
+            <a:pPr indent="0" marL="0">
+              <a:buNone/>
+            </a:pPr>
+            <a:r>
+              <a:rPr lang="en-US" sz="1150" dirty="0">
+                <a:solidFill>
+                  <a:schemeClr val="tx2"/>
+                </a:solidFill>
+              </a:rPr>
+              <a:t>top-down + street-level YOLO11</a:t>
+            </a:r>
+            <a:endParaRPr lang="en-US" sz="1400" dirty="0"/>
+          </a:p>
+        </p:txBody>
+      </p:sp>
+      <p:sp>
+        <p:nvSpPr>
+          <p:cNvPr id="14" name="flow arrow 2"/>
+          <p:cNvSpPr/>
+          <p:nvPr/>
+        </p:nvSpPr>
+        <p:spPr>
+          <a:xfrm>
+            <a:off x="6022696" y="2377440"/>
+            <a:ext cx="146304" cy="237744"/>
+          </a:xfrm>
+          <a:prstGeom prst="chevron">
+            <a:avLst/>
+          </a:prstGeom>
+          <a:solidFill>
+            <a:schemeClr val="accent1"/>
+          </a:solidFill>
+          <a:ln/>
+        </p:spPr>
+      </p:sp>
+      <p:sp>
+        <p:nvSpPr>
+          <p:cNvPr id="15" name="Spots + occupancy step"/>
+          <p:cNvSpPr/>
+          <p:nvPr/>
+        </p:nvSpPr>
+        <p:spPr>
+          <a:xfrm>
+            <a:off x="6242152" y="1810512"/>
+            <a:ext cx="2554148" cy="1371600"/>
+          </a:xfrm>
+          <a:prstGeom prst="roundRect">
+            <a:avLst>
+              <a:gd name="adj" fmla="val 8000"/>
+            </a:avLst>
+          </a:prstGeom>
+          <a:solidFill>
+            <a:schemeClr val="bg1"/>
+          </a:solidFill>
+          <a:ln w="12700">
+            <a:solidFill>
+              <a:srgbClr val="E6ECF4"/>
+            </a:solidFill>
+            <a:prstDash val="solid"/>
+          </a:ln>
+        </p:spPr>
+      </p:sp>
+      <p:sp>
+        <p:nvSpPr>
+          <p:cNvPr id="16" name="Spots + occupancy circle"/>
+          <p:cNvSpPr/>
+          <p:nvPr/>
+        </p:nvSpPr>
+        <p:spPr>
+          <a:xfrm>
+            <a:off x="6406744" y="1965960"/>
+            <a:ext cx="438912" cy="438912"/>
+          </a:xfrm>
+          <a:prstGeom prst="ellipse">
+            <a:avLst/>
+          </a:prstGeom>
+          <a:solidFill>
+            <a:schemeClr val="accent1"/>
+          </a:solidFill>
+          <a:ln/>
+        </p:spPr>
+      </p:sp>
+      <p:pic>
+        <p:nvPicPr>
+          <p:cNvPr id="17" name="Spots + occupancy icon" descr="Spots + occupancy">    </p:cNvPr>
+          <p:cNvPicPr>
+            <a:picLocks noChangeAspect="1"/>
+          </p:cNvPicPr>
+          <p:nvPr/>
+        </p:nvPicPr>
+        <p:blipFill>
+          <a:blip r:embed="rId3"/>
+          <a:stretch>
+            <a:fillRect/>
+          </a:stretch>
+        </p:blipFill>
+        <p:spPr>
+          <a:xfrm>
+            <a:off x="6512082" y="2071299"/>
+            <a:ext cx="228234" cy="228234"/>
+          </a:xfrm>
+          <a:prstGeom prst="rect">
+            <a:avLst/>
+          </a:prstGeom>
+        </p:spPr>
+      </p:pic>
+      <p:sp>
+        <p:nvSpPr>
+          <p:cNvPr id="18" name="Spots + occupancy text"/>
+          <p:cNvSpPr txBox="1"/>
+          <p:nvPr/>
+        </p:nvSpPr>
+        <p:spPr>
+          <a:xfrm>
+            <a:off x="6406744" y="2496312"/>
+            <a:ext cx="2279828" cy="640080"/>
+          </a:xfrm>
+          <a:prstGeom prst="rect">
+            <a:avLst/>
+          </a:prstGeom>
+          <a:noFill/>
+          <a:ln/>
+        </p:spPr>
+        <p:txBody>
+          <a:bodyPr wrap="square" lIns="0" tIns="0" rIns="0" bIns="0" rtlCol="0" anchor="t"/>
+          <a:lstStyle/>
+          <a:p>
+            <a:pPr indent="0" marL="0">
+              <a:buNone/>
+            </a:pPr>
+            <a:r>
+              <a:rPr lang="en-US" sz="1400" b="1" dirty="0">
+                <a:solidFill>
+                  <a:schemeClr val="tx1"/>
+                </a:solidFill>
+              </a:rPr>
+              <a:t>Spots + occupancy</a:t>
+            </a:r>
+            <a:endParaRPr lang="en-US" sz="1400" dirty="0"/>
+          </a:p>
+          <a:p>
+            <a:pPr indent="0" marL="0">
+              <a:buNone/>
+            </a:pPr>
+            <a:r>
+              <a:rPr lang="en-US" sz="1150" dirty="0">
+                <a:solidFill>
+                  <a:schemeClr val="tx2"/>
+                </a:solidFill>
+              </a:rPr>
+              <a:t>found automatically, cautious</a:t>
+            </a:r>
+            <a:endParaRPr lang="en-US" sz="1400" dirty="0"/>
+          </a:p>
+        </p:txBody>
+      </p:sp>
+      <p:sp>
+        <p:nvSpPr>
+          <p:cNvPr id="19" name="flow arrow 3"/>
+          <p:cNvSpPr/>
+          <p:nvPr/>
+        </p:nvSpPr>
+        <p:spPr>
+          <a:xfrm>
+            <a:off x="8869451" y="2377440"/>
+            <a:ext cx="146304" cy="237744"/>
+          </a:xfrm>
+          <a:prstGeom prst="chevron">
+            <a:avLst/>
+          </a:prstGeom>
+          <a:solidFill>
+            <a:schemeClr val="accent1"/>
+          </a:solidFill>
+          <a:ln/>
+        </p:spPr>
+      </p:sp>
+      <p:sp>
+        <p:nvSpPr>
+          <p:cNvPr id="20" name="Driver app step"/>
+          <p:cNvSpPr/>
+          <p:nvPr/>
+        </p:nvSpPr>
+        <p:spPr>
+          <a:xfrm>
+            <a:off x="9088907" y="1810512"/>
+            <a:ext cx="2554148" cy="1371600"/>
+          </a:xfrm>
+          <a:prstGeom prst="roundRect">
+            <a:avLst>
+              <a:gd name="adj" fmla="val 8000"/>
+            </a:avLst>
+          </a:prstGeom>
+          <a:solidFill>
+            <a:schemeClr val="bg1"/>
+          </a:solidFill>
+          <a:ln w="12700">
+            <a:solidFill>
+              <a:srgbClr val="E6ECF4"/>
+            </a:solidFill>
+            <a:prstDash val="solid"/>
+          </a:ln>
+        </p:spPr>
+      </p:sp>
+      <p:sp>
+        <p:nvSpPr>
+          <p:cNvPr id="21" name="Driver app circle"/>
+          <p:cNvSpPr/>
+          <p:nvPr/>
+        </p:nvSpPr>
+        <p:spPr>
+          <a:xfrm>
+            <a:off x="9253499" y="1965960"/>
+            <a:ext cx="438912" cy="438912"/>
+          </a:xfrm>
+          <a:prstGeom prst="ellipse">
+            <a:avLst/>
+          </a:prstGeom>
+          <a:solidFill>
+            <a:schemeClr val="accent1"/>
+          </a:solidFill>
+          <a:ln/>
+        </p:spPr>
+      </p:sp>
+      <p:pic>
+        <p:nvPicPr>
+          <p:cNvPr id="22" name="Driver app icon" descr="Driver app">    </p:cNvPr>
+          <p:cNvPicPr>
+            <a:picLocks noChangeAspect="1"/>
+          </p:cNvPicPr>
+          <p:nvPr/>
+        </p:nvPicPr>
+        <p:blipFill>
+          <a:blip r:embed="rId4"/>
+          <a:stretch>
+            <a:fillRect/>
+          </a:stretch>
+        </p:blipFill>
+        <p:spPr>
+          <a:xfrm>
+            <a:off x="9358838" y="2071299"/>
+            <a:ext cx="228234" cy="228234"/>
+          </a:xfrm>
+          <a:prstGeom prst="rect">
+            <a:avLst/>
+          </a:prstGeom>
+        </p:spPr>
+      </p:pic>
+      <p:sp>
+        <p:nvSpPr>
+          <p:cNvPr id="23" name="Driver app text"/>
+          <p:cNvSpPr txBox="1"/>
+          <p:nvPr/>
+        </p:nvSpPr>
+        <p:spPr>
+          <a:xfrm>
+            <a:off x="9253499" y="2496312"/>
+            <a:ext cx="2279828" cy="640080"/>
+          </a:xfrm>
+          <a:prstGeom prst="rect">
+            <a:avLst/>
+          </a:prstGeom>
+          <a:noFill/>
+          <a:ln/>
+        </p:spPr>
+        <p:txBody>
+          <a:bodyPr wrap="square" lIns="0" tIns="0" rIns="0" bIns="0" rtlCol="0" anchor="t"/>
+          <a:lstStyle/>
+          <a:p>
+            <a:pPr indent="0" marL="0">
+              <a:buNone/>
+            </a:pPr>
+            <a:r>
+              <a:rPr lang="en-US" sz="1400" b="1" dirty="0">
+                <a:solidFill>
+                  <a:schemeClr val="tx1"/>
+                </a:solidFill>
+              </a:rPr>
+              <a:t>Driver app</a:t>
+            </a:r>
+            <a:endParaRPr lang="en-US" sz="1400" dirty="0"/>
+          </a:p>
+          <a:p>
+            <a:pPr indent="0" marL="0">
+              <a:buNone/>
+            </a:pPr>
+            <a:r>
+              <a:rPr lang="en-US" sz="1150" dirty="0">
+                <a:solidFill>
+                  <a:schemeClr val="tx2"/>
+                </a:solidFill>
+              </a:rPr>
+              <a:t>map, booking, directions — live</a:t>
+            </a:r>
+            <a:endParaRPr lang="en-US" sz="1400" dirty="0"/>
+          </a:p>
+        </p:txBody>
+      </p:sp>
+      <p:sp>
+        <p:nvSpPr>
+          <p:cNvPr id="24" name="measured card"/>
+          <p:cNvSpPr/>
+          <p:nvPr/>
+        </p:nvSpPr>
+        <p:spPr>
+          <a:xfrm>
+            <a:off x="548640" y="3456432"/>
+            <a:ext cx="5410048" cy="2103120"/>
+          </a:xfrm>
+          <a:prstGeom prst="roundRect">
+            <a:avLst>
+              <a:gd name="adj" fmla="val 5217"/>
+            </a:avLst>
+          </a:prstGeom>
+          <a:solidFill>
+            <a:schemeClr val="bg1"/>
+          </a:solidFill>
+          <a:ln w="12700">
+            <a:solidFill>
+              <a:srgbClr val="E6ECF4"/>
+            </a:solidFill>
+            <a:prstDash val="solid"/>
+          </a:ln>
+        </p:spPr>
+      </p:sp>
+      <p:sp>
+        <p:nvSpPr>
+          <p:cNvPr id="25" name="MEASURED label"/>
+          <p:cNvSpPr txBox="1"/>
+          <p:nvPr/>
+        </p:nvSpPr>
+        <p:spPr>
+          <a:xfrm>
+            <a:off x="822960" y="3657600"/>
+            <a:ext cx="4861408" cy="274320"/>
+          </a:xfrm>
+          <a:prstGeom prst="rect">
+            <a:avLst/>
+          </a:prstGeom>
+          <a:noFill/>
+          <a:ln/>
+        </p:spPr>
+        <p:txBody>
+          <a:bodyPr wrap="square" lIns="0" tIns="0" rIns="0" bIns="0" rtlCol="0" anchor="t"/>
+          <a:lstStyle/>
+          <a:p>
+            <a:pPr indent="0" marL="0">
+              <a:buNone/>
+            </a:pPr>
+            <a:r>
+              <a:rPr lang="en-US" sz="1200" b="1" spc="200" kern="0" dirty="0">
+                <a:solidFill>
+                  <a:schemeClr val="accent1"/>
+                </a:solidFill>
+              </a:rPr>
+              <a:t>MEASURED</a:t>
+            </a:r>
+            <a:endParaRPr lang="en-US" sz="1200" dirty="0"/>
+          </a:p>
+        </p:txBody>
+      </p:sp>
+      <p:sp>
+        <p:nvSpPr>
+          <p:cNvPr id="26" name="Text 20"/>
+          <p:cNvSpPr txBox="1"/>
+          <p:nvPr/>
+        </p:nvSpPr>
+        <p:spPr>
+          <a:xfrm>
+            <a:off x="822960" y="4023360"/>
+            <a:ext cx="1325880" cy="411480"/>
+          </a:xfrm>
+          <a:prstGeom prst="rect">
+            <a:avLst/>
+          </a:prstGeom>
+          <a:noFill/>
+          <a:ln/>
+        </p:spPr>
+        <p:txBody>
+          <a:bodyPr wrap="square" lIns="0" tIns="0" rIns="0" bIns="0" rtlCol="0" anchor="ctr"/>
+          <a:lstStyle/>
+          <a:p>
+            <a:pPr indent="0" marL="0">
+              <a:buNone/>
+            </a:pPr>
+            <a:r>
+              <a:rPr lang="en-US" sz="2100" b="1" dirty="0">
+                <a:solidFill>
+                  <a:schemeClr val="accent1"/>
+                </a:solidFill>
+              </a:rPr>
+              <a:t>0.14 s</a:t>
+            </a:r>
+            <a:endParaRPr lang="en-US" sz="2100" dirty="0"/>
+          </a:p>
+        </p:txBody>
+      </p:sp>
+      <p:sp>
+        <p:nvSpPr>
+          <p:cNvPr id="27" name="Text 21"/>
+          <p:cNvSpPr txBox="1"/>
+          <p:nvPr/>
+        </p:nvSpPr>
+        <p:spPr>
+          <a:xfrm>
+            <a:off x="2194560" y="4023360"/>
+            <a:ext cx="3535528" cy="411480"/>
+          </a:xfrm>
+          <a:prstGeom prst="rect">
+            <a:avLst/>
+          </a:prstGeom>
+          <a:noFill/>
+          <a:ln/>
+        </p:spPr>
+        <p:txBody>
+          <a:bodyPr wrap="square" lIns="0" tIns="0" rIns="0" bIns="0" rtlCol="0" anchor="ctr"/>
+          <a:lstStyle/>
+          <a:p>
+            <a:pPr indent="0" marL="0">
+              <a:buNone/>
+            </a:pPr>
+            <a:r>
+              <a:rPr lang="en-US" sz="1200" dirty="0">
+                <a:solidFill>
+                  <a:schemeClr val="tx2"/>
+                </a:solidFill>
+              </a:rPr>
+              <a:t>per camera frame, 4-core CPU, no GPU</a:t>
+            </a:r>
+            <a:endParaRPr lang="en-US" sz="1200" dirty="0"/>
+          </a:p>
+        </p:txBody>
+      </p:sp>
+      <p:sp>
+        <p:nvSpPr>
+          <p:cNvPr id="28" name="Text 22"/>
+          <p:cNvSpPr txBox="1"/>
+          <p:nvPr/>
+        </p:nvSpPr>
+        <p:spPr>
+          <a:xfrm>
+            <a:off x="822960" y="4507992"/>
+            <a:ext cx="1325880" cy="411480"/>
+          </a:xfrm>
+          <a:prstGeom prst="rect">
+            <a:avLst/>
+          </a:prstGeom>
+          <a:noFill/>
+          <a:ln/>
+        </p:spPr>
+        <p:txBody>
+          <a:bodyPr wrap="square" lIns="0" tIns="0" rIns="0" bIns="0" rtlCol="0" anchor="ctr"/>
+          <a:lstStyle/>
+          <a:p>
+            <a:pPr indent="0" marL="0">
+              <a:buNone/>
+            </a:pPr>
+            <a:r>
+              <a:rPr lang="en-US" sz="2100" b="1" dirty="0">
+                <a:solidFill>
+                  <a:schemeClr val="accent1"/>
+                </a:solidFill>
+              </a:rPr>
+              <a:t>&lt; 400 MB</a:t>
+            </a:r>
+            <a:endParaRPr lang="en-US" sz="2100" dirty="0"/>
+          </a:p>
+        </p:txBody>
+      </p:sp>
+      <p:sp>
+        <p:nvSpPr>
+          <p:cNvPr id="29" name="Text 23"/>
+          <p:cNvSpPr txBox="1"/>
+          <p:nvPr/>
+        </p:nvSpPr>
+        <p:spPr>
+          <a:xfrm>
+            <a:off x="2194560" y="4507992"/>
+            <a:ext cx="3535528" cy="411480"/>
+          </a:xfrm>
+          <a:prstGeom prst="rect">
+            <a:avLst/>
+          </a:prstGeom>
+          <a:noFill/>
+          <a:ln/>
+        </p:spPr>
+        <p:txBody>
+          <a:bodyPr wrap="square" lIns="0" tIns="0" rIns="0" bIns="0" rtlCol="0" anchor="ctr"/>
+          <a:lstStyle/>
+          <a:p>
+            <a:pPr indent="0" marL="0">
+              <a:buNone/>
+            </a:pPr>
+            <a:r>
+              <a:rPr lang="en-US" sz="1200" dirty="0">
+                <a:solidFill>
+                  <a:schemeClr val="tx2"/>
+                </a:solidFill>
+              </a:rPr>
+              <a:t>server memory</a:t>
+            </a:r>
+            <a:endParaRPr lang="en-US" sz="1200" dirty="0"/>
+          </a:p>
+        </p:txBody>
+      </p:sp>
+      <p:sp>
+        <p:nvSpPr>
+          <p:cNvPr id="30" name="Text 24"/>
+          <p:cNvSpPr txBox="1"/>
+          <p:nvPr/>
+        </p:nvSpPr>
+        <p:spPr>
+          <a:xfrm>
+            <a:off x="822960" y="4992624"/>
+            <a:ext cx="1325880" cy="411480"/>
+          </a:xfrm>
+          <a:prstGeom prst="rect">
+            <a:avLst/>
+          </a:prstGeom>
+          <a:noFill/>
+          <a:ln/>
+        </p:spPr>
+        <p:txBody>
+          <a:bodyPr wrap="square" lIns="0" tIns="0" rIns="0" bIns="0" rtlCol="0" anchor="ctr"/>
+          <a:lstStyle/>
+          <a:p>
+            <a:pPr indent="0" marL="0">
+              <a:buNone/>
+            </a:pPr>
+            <a:r>
+              <a:rPr lang="en-US" sz="2100" b="1" dirty="0">
+                <a:solidFill>
+                  <a:schemeClr val="accent1"/>
+                </a:solidFill>
+              </a:rPr>
+              <a:t>~20</a:t>
+            </a:r>
+            <a:endParaRPr lang="en-US" sz="2100" dirty="0"/>
+          </a:p>
+        </p:txBody>
+      </p:sp>
+      <p:sp>
+        <p:nvSpPr>
+          <p:cNvPr id="31" name="Text 25"/>
+          <p:cNvSpPr txBox="1"/>
+          <p:nvPr/>
+        </p:nvSpPr>
+        <p:spPr>
+          <a:xfrm>
+            <a:off x="2194560" y="4992624"/>
+            <a:ext cx="3535528" cy="411480"/>
+          </a:xfrm>
+          <a:prstGeom prst="rect">
+            <a:avLst/>
+          </a:prstGeom>
+          <a:noFill/>
+          <a:ln/>
+        </p:spPr>
+        <p:txBody>
+          <a:bodyPr wrap="square" lIns="0" tIns="0" rIns="0" bIns="0" rtlCol="0" anchor="ctr"/>
+          <a:lstStyle/>
+          <a:p>
+            <a:pPr indent="0" marL="0">
+              <a:buNone/>
+            </a:pPr>
+            <a:r>
+              <a:rPr lang="en-US" sz="1200" dirty="0">
+                <a:solidFill>
+                  <a:schemeClr val="tx2"/>
+                </a:solidFill>
+              </a:rPr>
+              <a:t>cameras per small server (we plan 8)</a:t>
+            </a:r>
+            <a:endParaRPr lang="en-US" sz="1200" dirty="0"/>
+          </a:p>
+        </p:txBody>
+      </p:sp>
+      <p:sp>
+        <p:nvSpPr>
+          <p:cNvPr id="32" name="real conditions card"/>
+          <p:cNvSpPr/>
+          <p:nvPr/>
+        </p:nvSpPr>
+        <p:spPr>
+          <a:xfrm>
+            <a:off x="6233008" y="3456432"/>
+            <a:ext cx="5410048" cy="2103120"/>
+          </a:xfrm>
+          <a:prstGeom prst="roundRect">
+            <a:avLst>
+              <a:gd name="adj" fmla="val 5217"/>
+            </a:avLst>
+          </a:prstGeom>
+          <a:solidFill>
+            <a:schemeClr val="bg1"/>
+          </a:solidFill>
+          <a:ln w="12700">
+            <a:solidFill>
+              <a:srgbClr val="E6ECF4"/>
+            </a:solidFill>
+            <a:prstDash val="solid"/>
+          </a:ln>
+        </p:spPr>
+      </p:sp>
+      <p:sp>
+        <p:nvSpPr>
+          <p:cNvPr id="33" name="REAL CONDITIONS label"/>
+          <p:cNvSpPr txBox="1"/>
+          <p:nvPr/>
+        </p:nvSpPr>
+        <p:spPr>
+          <a:xfrm>
+            <a:off x="6507328" y="3657600"/>
+            <a:ext cx="4861408" cy="274320"/>
+          </a:xfrm>
+          <a:prstGeom prst="rect">
+            <a:avLst/>
+          </a:prstGeom>
+          <a:noFill/>
+          <a:ln/>
+        </p:spPr>
+        <p:txBody>
+          <a:bodyPr wrap="square" lIns="0" tIns="0" rIns="0" bIns="0" rtlCol="0" anchor="t"/>
+          <a:lstStyle/>
+          <a:p>
+            <a:pPr indent="0" marL="0">
+              <a:buNone/>
+            </a:pPr>
+            <a:r>
+              <a:rPr lang="en-US" sz="1200" b="1" spc="200" kern="0" dirty="0">
+                <a:solidFill>
+                  <a:schemeClr val="accent1"/>
+                </a:solidFill>
+              </a:rPr>
+              <a:t>REAL CONDITIONS</a:t>
+            </a:r>
+            <a:endParaRPr lang="en-US" sz="1200" dirty="0"/>
+          </a:p>
+        </p:txBody>
+      </p:sp>
+      <p:sp>
+        <p:nvSpPr>
+          <p:cNvPr id="34" name="Offline: “no data”, no booking circle"/>
+          <p:cNvSpPr/>
+          <p:nvPr/>
+        </p:nvSpPr>
+        <p:spPr>
+          <a:xfrm>
+            <a:off x="6507328" y="4142232"/>
+            <a:ext cx="274320" cy="274320"/>
+          </a:xfrm>
+          <a:prstGeom prst="ellipse">
+            <a:avLst/>
+          </a:prstGeom>
+          <a:solidFill>
+            <a:schemeClr val="accent2"/>
+          </a:solidFill>
+          <a:ln/>
+        </p:spPr>
+      </p:sp>
+      <p:pic>
+        <p:nvPicPr>
+          <p:cNvPr id="35" name="Offline: “no data”, no booking icon" descr="Offline: “no data”, no booking">    </p:cNvPr>
+          <p:cNvPicPr>
+            <a:picLocks noChangeAspect="1"/>
+          </p:cNvPicPr>
+          <p:nvPr/>
+        </p:nvPicPr>
+        <p:blipFill>
+          <a:blip r:embed="rId5"/>
+          <a:stretch>
+            <a:fillRect/>
+          </a:stretch>
+        </p:blipFill>
+        <p:spPr>
+          <a:xfrm>
+            <a:off x="6573164" y="4208069"/>
+            <a:ext cx="142646" cy="142646"/>
+          </a:xfrm>
+          <a:prstGeom prst="rect">
+            <a:avLst/>
+          </a:prstGeom>
+        </p:spPr>
+      </p:pic>
+      <p:sp>
+        <p:nvSpPr>
+          <p:cNvPr id="36" name="Text 29"/>
+          <p:cNvSpPr txBox="1"/>
+          <p:nvPr/>
+        </p:nvSpPr>
+        <p:spPr>
+          <a:xfrm>
+            <a:off x="6918808" y="4114800"/>
+            <a:ext cx="4495648" cy="329184"/>
+          </a:xfrm>
+          <a:prstGeom prst="rect">
+            <a:avLst/>
+          </a:prstGeom>
+          <a:noFill/>
+          <a:ln/>
+        </p:spPr>
+        <p:txBody>
+          <a:bodyPr wrap="square" lIns="0" tIns="0" rIns="0" bIns="0" rtlCol="0" anchor="ctr"/>
+          <a:lstStyle/>
+          <a:p>
+            <a:pPr indent="0" marL="0">
+              <a:buNone/>
+            </a:pPr>
+            <a:r>
+              <a:rPr lang="en-US" sz="1250" dirty="0">
+                <a:solidFill>
+                  <a:schemeClr val="tx2"/>
+                </a:solidFill>
+              </a:rPr>
+              <a:t>Offline: “no data”, no booking</a:t>
+            </a:r>
+            <a:endParaRPr lang="en-US" sz="1250" dirty="0"/>
+          </a:p>
+        </p:txBody>
+      </p:sp>
+      <p:sp>
+        <p:nvSpPr>
+          <p:cNvPr id="37" name="Privacy: never saved, pixelated circle"/>
+          <p:cNvSpPr/>
+          <p:nvPr/>
+        </p:nvSpPr>
+        <p:spPr>
+          <a:xfrm>
+            <a:off x="6507328" y="4690872"/>
+            <a:ext cx="274320" cy="274320"/>
+          </a:xfrm>
+          <a:prstGeom prst="ellipse">
+            <a:avLst/>
+          </a:prstGeom>
+          <a:solidFill>
+            <a:schemeClr val="accent2"/>
+          </a:solidFill>
+          <a:ln/>
+        </p:spPr>
+      </p:sp>
+      <p:pic>
+        <p:nvPicPr>
+          <p:cNvPr id="38" name="Privacy: never saved, pixelated icon" descr="Privacy: never saved, pixelated">    </p:cNvPr>
+          <p:cNvPicPr>
+            <a:picLocks noChangeAspect="1"/>
+          </p:cNvPicPr>
+          <p:nvPr/>
+        </p:nvPicPr>
+        <p:blipFill>
+          <a:blip r:embed="rId6"/>
+          <a:stretch>
+            <a:fillRect/>
+          </a:stretch>
+        </p:blipFill>
+        <p:spPr>
+          <a:xfrm>
+            <a:off x="6573164" y="4756709"/>
+            <a:ext cx="142646" cy="142646"/>
+          </a:xfrm>
+          <a:prstGeom prst="rect">
+            <a:avLst/>
+          </a:prstGeom>
+        </p:spPr>
+      </p:pic>
+      <p:sp>
+        <p:nvSpPr>
+          <p:cNvPr id="39" name="Text 31"/>
+          <p:cNvSpPr txBox="1"/>
+          <p:nvPr/>
+        </p:nvSpPr>
+        <p:spPr>
+          <a:xfrm>
+            <a:off x="6918808" y="4663440"/>
+            <a:ext cx="4495648" cy="329184"/>
+          </a:xfrm>
+          <a:prstGeom prst="rect">
+            <a:avLst/>
+          </a:prstGeom>
+          <a:noFill/>
+          <a:ln/>
+        </p:spPr>
+        <p:txBody>
+          <a:bodyPr wrap="square" lIns="0" tIns="0" rIns="0" bIns="0" rtlCol="0" anchor="ctr"/>
+          <a:lstStyle/>
+          <a:p>
+            <a:pPr indent="0" marL="0">
+              <a:buNone/>
+            </a:pPr>
+            <a:r>
+              <a:rPr lang="en-US" sz="1250" dirty="0">
+                <a:solidFill>
+                  <a:schemeClr val="tx2"/>
+                </a:solidFill>
+              </a:rPr>
+              <a:t>Privacy: never saved, pixelated</a:t>
+            </a:r>
+            <a:endParaRPr lang="en-US" sz="1250" dirty="0"/>
+          </a:p>
+        </p:txBody>
+      </p:sp>
+      <p:sp>
+        <p:nvSpPr>
+          <p:cNvPr id="40" name="sources strip"/>
+          <p:cNvSpPr/>
+          <p:nvPr/>
+        </p:nvSpPr>
+        <p:spPr>
+          <a:xfrm>
+            <a:off x="548640" y="5733288"/>
+            <a:ext cx="11094415" cy="457200"/>
+          </a:xfrm>
+          <a:prstGeom prst="roundRect">
+            <a:avLst>
+              <a:gd name="adj" fmla="val 16000"/>
+            </a:avLst>
+          </a:prstGeom>
+          <a:solidFill>
+            <a:schemeClr val="accent6"/>
+          </a:solidFill>
+          <a:ln/>
+        </p:spPr>
+      </p:sp>
+      <p:sp>
+        <p:nvSpPr>
+          <p:cNvPr id="41" name="sources"/>
+          <p:cNvSpPr txBox="1"/>
+          <p:nvPr/>
+        </p:nvSpPr>
+        <p:spPr>
+          <a:xfrm>
+            <a:off x="777240" y="5733288"/>
+            <a:ext cx="10637215" cy="457200"/>
+          </a:xfrm>
+          <a:prstGeom prst="rect">
+            <a:avLst/>
+          </a:prstGeom>
+          <a:noFill/>
+          <a:ln/>
+        </p:spPr>
+        <p:txBody>
+          <a:bodyPr wrap="square" lIns="0" tIns="0" rIns="0" bIns="0" rtlCol="0" anchor="ctr"/>
+          <a:lstStyle/>
+          <a:p>
+            <a:pPr indent="0" marL="0">
+              <a:buNone/>
+            </a:pPr>
+            <a:r>
+              <a:rPr lang="en-US" sz="1200" b="1" dirty="0">
+                <a:solidFill>
+                  <a:schemeClr val="tx1"/>
+                </a:solidFill>
+              </a:rPr>
+              <a:t>Open models: </a:t>
+            </a:r>
+            <a:pPr indent="0" marL="0">
+              <a:buNone/>
+            </a:pPr>
+            <a:r>
+              <a:rPr lang="en-US" sz="1200" dirty="0">
+                <a:solidFill>
+                  <a:schemeClr val="tx2"/>
+                </a:solidFill>
+              </a:rPr>
+              <a:t>YOLO11 (Ultralytics, AGPL-3.0), Leaflet, © OpenStreetMap.     </a:t>
+            </a:r>
+            <a:pPr indent="0" marL="0">
+              <a:buNone/>
+            </a:pPr>
+            <a:r>
+              <a:rPr lang="en-US" sz="1200" b="1" dirty="0">
+                <a:solidFill>
+                  <a:schemeClr val="tx1"/>
+                </a:solidFill>
+              </a:rPr>
+              <a:t>Ours: </a:t>
+            </a:r>
+            <a:pPr indent="0" marL="0">
+              <a:buNone/>
+            </a:pPr>
+            <a:r>
+              <a:rPr lang="en-US" sz="1200" dirty="0">
+                <a:solidFill>
+                  <a:schemeClr val="tx2"/>
+                </a:solidFill>
+              </a:rPr>
+              <a:t>spot discovery, occupancy rules, booking engine, apps.</a:t>
+            </a:r>
+            <a:endParaRPr lang="en-US" sz="1200" dirty="0"/>
+          </a:p>
+        </p:txBody>
+      </p:sp>
+      <p:sp>
+        <p:nvSpPr>
+          <p:cNvPr id="25" name="Slide Number Placeholder 0"/>
+          <p:cNvSpPr>
+            <a:spLocks noGrp="1"/>
+          </p:cNvSpPr>
+          <p:nvPr>
+            <p:ph type="sldNum" sz="quarter" idx="4294967295"/>
+          </p:nvPr>
+        </p:nvSpPr>
+        <p:spPr>
+          <a:xfrm>
+            <a:off x="11094415" y="6355080"/>
+            <a:ext cx="548640" cy="274320"/>
+          </a:xfrm>
+          <a:prstGeom prst="rect">
+            <a:avLst/>
+          </a:prstGeom>
+          <a:extLst>
+            <a:ext uri="{C572A759-6A51-4108-AA02-DFA0A04FC94B}">
+              <ma14:wrappingTextBoxFlag xmlns:ma14="http://schemas.microsoft.com/office/mac/drawingml/2011/main" val="0"/>
+            </a:ext>
+          </a:extLst>
+        </p:spPr>
+        <p:txBody>
+          <a:bodyPr/>
+          <a:lstStyle>
+            <a:lvl1pPr>
+              <a:defRPr sz="1000">
+                <a:solidFill>
+                  <a:schemeClr val="tx2"/>
+                </a:solidFill>
+              </a:defRPr>
+            </a:lvl1pPr>
+          </a:lstStyle>
+          <a:p>
+            <a:pPr algn="r"/>
+            <a:fld id="{F7021451-1387-4CA6-816F-3879F97B5CBC}" type="slidenum">
+              <a:rPr b="0" lang="en-US"/>
+              <a:t>5</a:t>
+            </a:fld>
+            <a:endParaRPr lang="en-US"/>
+          </a:p>
+        </p:txBody>
+      </p:sp>
+    </p:spTree>
+  </p:cSld>
+  <p:clrMapOvr>
+    <a:masterClrMapping/>
+  </p:clrMapOvr>
+  <mc:AlternateContent xmlns:mc="http://schemas.openxmlformats.org/markup-compatibility/2006">
+    <mc:Choice xmlns:p159="http://schemas.microsoft.com/office/powerpoint/2015/09/main" Requires="p159">
+      <p:transition xmlns:p14="http://schemas.microsoft.com/office/powerpoint/2010/main" spd="slow" p14:dur="1000">
+        <p159:morph option="byObject"/>
+      </p:transition>
+    </mc:Choice>
+    <mc:Fallback>
+      <p:transition spd="slow">
+        <p:fade/>
+      </p:transition>
+    </mc:Fallback>
+  </mc:AlternateContent>
+</p:sld>
+</file>
+
+<file path=ppt/slides/slide6.xml><?xml version="1.0" encoding="utf-8"?>
+<p:sld xmlns:a="http://schemas.openxmlformats.org/drawingml/2006/main" xmlns:r="http://schemas.openxmlformats.org/officeDocument/2006/relationships" xmlns:p="http://schemas.openxmlformats.org/presentationml/2006/main">
+  <p:cSld name="Slide 6">
+    <p:spTree>
+      <p:nvGrpSpPr>
+        <p:cNvPr id="1" name=""/>
+        <p:cNvGrpSpPr/>
+        <p:nvPr/>
+      </p:nvGrpSpPr>
+      <p:grpSpPr>
+        <a:xfrm>
+          <a:off x="0" y="0"/>
+          <a:ext cx="0" cy="0"/>
+          <a:chOff x="0" y="0"/>
+          <a:chExt cx="0" cy="0"/>
+        </a:xfrm>
+      </p:grpSpPr>
+      <p:sp>
+        <p:nvSpPr>
+          <p:cNvPr id="2" name="Text 0"/>
+          <p:cNvSpPr/>
+          <p:nvPr>
+            <p:ph idx="100" type="body" hasCustomPrompt="1"/>
+          </p:nvPr>
+        </p:nvSpPr>
+        <p:spPr>
+          <a:xfrm>
+            <a:off x="548640" y="384048"/>
+            <a:ext cx="8229600" cy="274320"/>
+          </a:xfrm>
+          <a:prstGeom prst="rect">
+            <a:avLst/>
+          </a:prstGeom>
+          <a:noFill/>
+          <a:ln/>
+        </p:spPr>
+        <p:txBody>
+          <a:bodyPr wrap="square" lIns="0" tIns="0" rIns="0" bIns="0" rtlCol="0" anchor="t"/>
+          <a:lstStyle/>
+          <a:p>
+            <a:pPr indent="0" marL="0">
+              <a:buNone/>
+            </a:pPr>
+            <a:r>
+              <a:rPr lang="en-US" sz="1200" b="1" spc="200" kern="0" dirty="0">
+                <a:solidFill>
+                  <a:schemeClr val="accent1"/>
+                </a:solidFill>
+              </a:rPr>
+              <a:t>COMPETITORS IN UZBEKISTAN</a:t>
+            </a:r>
+            <a:endParaRPr lang="en-US" sz="1200" dirty="0"/>
+          </a:p>
+        </p:txBody>
+      </p:sp>
+      <p:sp>
+        <p:nvSpPr>
+          <p:cNvPr id="3" name="Text 0"/>
+          <p:cNvSpPr/>
+          <p:nvPr>
+            <p:ph idx="101" type="title" hasCustomPrompt="1"/>
+          </p:nvPr>
+        </p:nvSpPr>
+        <p:spPr>
+          <a:xfrm>
+            <a:off x="548640" y="685800"/>
+            <a:ext cx="11094415" cy="731520"/>
+          </a:xfrm>
+          <a:prstGeom prst="rect">
+            <a:avLst/>
+          </a:prstGeom>
+          <a:noFill/>
+          <a:ln/>
+        </p:spPr>
+        <p:txBody>
+          <a:bodyPr wrap="square" lIns="0" tIns="0" rIns="0" bIns="0" rtlCol="0" anchor="t"/>
+          <a:lstStyle/>
+          <a:p>
+            <a:pPr algn="l" indent="0" marL="0">
+              <a:buNone/>
+            </a:pPr>
+            <a:r>
+              <a:rPr lang="en-US" sz="3200" b="1" dirty="0">
+                <a:solidFill>
+                  <a:schemeClr val="tx1"/>
+                </a:solidFill>
+              </a:rPr>
               <a:t>Who else solves parking — and what they miss</a:t>
             </a:r>
             <a:endParaRPr lang="en-US" sz="3200" dirty="0"/>
@@ -6017,7 +6599,7 @@
       </p:sp>
       <p:graphicFrame>
         <p:nvGraphicFramePr>
-          <p:cNvPr id="6" name="Table 0"/>
+          <p:cNvPr id="7" name="Table 0"/>
           <p:cNvGraphicFramePr>
             <a:graphicFrameLocks noGrp="1"/>
           </p:cNvGraphicFramePr>
@@ -8214,7 +8796,7 @@
             <a:pPr algn="r"/>
             <a:fld id="{F7021451-1387-4CA6-816F-3879F97B5CBC}" type="slidenum">
               <a:rPr b="0" lang="en-US"/>
-              <a:t>5</a:t>
+              <a:t>6</a:t>
             </a:fld>
             <a:endParaRPr lang="en-US"/>
           </a:p>
@@ -8225,12 +8807,24 @@
   <p:clrMapOvr>
     <a:masterClrMapping/>
   </p:clrMapOvr>
+  <mc:AlternateContent xmlns:mc="http://schemas.openxmlformats.org/markup-compatibility/2006">
+    <mc:Choice xmlns:p159="http://schemas.microsoft.com/office/powerpoint/2015/09/main" Requires="p159">
+      <p:transition xmlns:p14="http://schemas.microsoft.com/office/powerpoint/2010/main" spd="slow" p14:dur="1000">
+        <p159:morph option="byObject"/>
+      </p:transition>
+    </mc:Choice>
+    <mc:Fallback>
+      <p:transition spd="slow">
+        <p:fade/>
+      </p:transition>
+    </mc:Fallback>
+  </mc:AlternateContent>
 </p:sld>
 </file>
 
-<file path=ppt/slides/slide6.xml><?xml version="1.0" encoding="utf-8"?>
+<file path=ppt/slides/slide7.xml><?xml version="1.0" encoding="utf-8"?>
 <p:sld xmlns:a="http://schemas.openxmlformats.org/drawingml/2006/main" xmlns:r="http://schemas.openxmlformats.org/officeDocument/2006/relationships" xmlns:p="http://schemas.openxmlformats.org/presentationml/2006/main">
-  <p:cSld name="Slide 6">
+  <p:cSld name="Slide 7">
     <p:spTree>
       <p:nvGrpSpPr>
         <p:cNvPr id="1" name=""/>
@@ -8315,7 +8909,7 @@
                   <a:schemeClr val="tx1"/>
                 </a:solidFill>
               </a:rPr>
-              <a:t>The lot operator pays — a 3-month pilot proves it</a:t>
+              <a:t>Drivers pay per hour, split 50/50 with the lot</a:t>
             </a:r>
             <a:endParaRPr lang="en-US" sz="3200" dirty="0"/>
           </a:p>
@@ -8533,7 +9127,7 @@
                   <a:schemeClr val="tx2"/>
                 </a:solidFill>
               </a:rPr>
-              <a:t>[price] per camera per month + [__%] of each booking (to validate)</a:t>
+              <a:t>drivers pay 5 000 so'm for the first hour and 2 000 so'm for each extra hour; 50% goes to the parking lot, 50% is our income</a:t>
             </a:r>
             <a:endParaRPr lang="en-US" sz="1450" dirty="0"/>
           </a:p>
@@ -8660,8 +9254,8 @@
         </p:nvSpPr>
         <p:spPr>
           <a:xfrm>
-            <a:off x="822960" y="4206240"/>
-            <a:ext cx="5074920" cy="1417320"/>
+            <a:off x="777240" y="4206240"/>
+            <a:ext cx="5166360" cy="1417320"/>
           </a:xfrm>
           <a:prstGeom prst="rect">
             <a:avLst/>
@@ -8682,14 +9276,11 @@
             <a:r>
               <a:rPr lang="en-US" sz="1300" b="1" dirty="0">
                 <a:solidFill>
-                  <a:schemeClr val="bg1"/>
-                </a:solidFill>
-              </a:rPr>
-              <a:t>Per camera, per month</a:t>
-            </a:r>
-            <a:endParaRPr lang="en-US" sz="1450" dirty="0"/>
-          </a:p>
-          <a:p>
+                  <a:schemeClr val="accent2"/>
+                </a:solidFill>
+              </a:rPr>
+              <a:t>Price per driver</a:t>
+            </a:r>
             <a:pPr indent="0" marL="0">
               <a:spcAft>
                 <a:spcPts val="400"/>
@@ -8697,13 +9288,16 @@
               <a:buNone/>
             </a:pPr>
             <a:r>
-              <a:rPr lang="en-US" sz="1450" b="1" dirty="0">
-                <a:solidFill>
-                  <a:schemeClr val="accent2"/>
-                </a:solidFill>
-              </a:rPr>
-              <a:t>Revenue</a:t>
-            </a:r>
+              <a:rPr lang="en-US" sz="1300" dirty="0">
+                <a:solidFill>
+                  <a:schemeClr val="bg1"/>
+                </a:solidFill>
+              </a:rPr>
+              <a:t> = 5 000 so'm (first hour) + 2 000 so'm × extra hours</a:t>
+            </a:r>
+            <a:endParaRPr lang="en-US" sz="1300" dirty="0"/>
+          </a:p>
+          <a:p>
             <a:pPr indent="0" marL="0">
               <a:spcAft>
                 <a:spcPts val="400"/>
@@ -8711,16 +9305,13 @@
               <a:buNone/>
             </a:pPr>
             <a:r>
-              <a:rPr lang="en-US" sz="1450" dirty="0">
-                <a:solidFill>
-                  <a:schemeClr val="bg1"/>
-                </a:solidFill>
-              </a:rPr>
-              <a:t> = [subscription] + [bookings/day] × [fee] × 30</a:t>
-            </a:r>
-            <a:endParaRPr lang="en-US" sz="1450" dirty="0"/>
-          </a:p>
-          <a:p>
+              <a:rPr lang="en-US" sz="1300" b="1" dirty="0">
+                <a:solidFill>
+                  <a:schemeClr val="accent2"/>
+                </a:solidFill>
+              </a:rPr>
+              <a:t>Split</a:t>
+            </a:r>
             <a:pPr indent="0" marL="0">
               <a:spcAft>
                 <a:spcPts val="400"/>
@@ -8728,13 +9319,16 @@
               <a:buNone/>
             </a:pPr>
             <a:r>
-              <a:rPr lang="en-US" sz="1450" b="1" dirty="0">
-                <a:solidFill>
-                  <a:schemeClr val="accent2"/>
-                </a:solidFill>
-              </a:rPr>
-              <a:t>Cost</a:t>
-            </a:r>
+              <a:rPr lang="en-US" sz="1300" dirty="0">
+                <a:solidFill>
+                  <a:schemeClr val="bg1"/>
+                </a:solidFill>
+              </a:rPr>
+              <a:t> = 50% parking lot · 50% ParkDet</a:t>
+            </a:r>
+            <a:endParaRPr lang="en-US" sz="1300" dirty="0"/>
+          </a:p>
+          <a:p>
             <a:pPr indent="0" marL="0">
               <a:spcAft>
                 <a:spcPts val="400"/>
@@ -8742,14 +9336,28 @@
               <a:buNone/>
             </a:pPr>
             <a:r>
-              <a:rPr lang="en-US" sz="1450" dirty="0">
+              <a:rPr lang="en-US" sz="1300" b="1" dirty="0">
+                <a:solidFill>
+                  <a:schemeClr val="accent2"/>
+                </a:solidFill>
+              </a:rPr>
+              <a:t>Our cost per camera / month</a:t>
+            </a:r>
+            <a:pPr indent="0" marL="0">
+              <a:spcAft>
+                <a:spcPts val="400"/>
+              </a:spcAft>
+              <a:buNone/>
+            </a:pPr>
+            <a:r>
+              <a:rPr lang="en-US" sz="1300" dirty="0">
                 <a:solidFill>
                   <a:schemeClr val="bg1"/>
                 </a:solidFill>
               </a:rPr>
               <a:t> = [server $] ÷ 8 + [phone] ÷ [months] + [support]</a:t>
             </a:r>
-            <a:endParaRPr lang="en-US" sz="1450" dirty="0"/>
+            <a:endParaRPr lang="en-US" sz="1300" dirty="0"/>
           </a:p>
         </p:txBody>
       </p:sp>
@@ -9386,7 +9994,7 @@
             <a:pPr algn="r"/>
             <a:fld id="{F7021451-1387-4CA6-816F-3879F97B5CBC}" type="slidenum">
               <a:rPr b="0" lang="en-US"/>
-              <a:t>6</a:t>
+              <a:t>7</a:t>
             </a:fld>
             <a:endParaRPr lang="en-US"/>
           </a:p>
@@ -9397,6 +10005,91 @@
   <p:clrMapOvr>
     <a:masterClrMapping/>
   </p:clrMapOvr>
+  <mc:AlternateContent xmlns:mc="http://schemas.openxmlformats.org/markup-compatibility/2006">
+    <mc:Choice xmlns:p159="http://schemas.microsoft.com/office/powerpoint/2015/09/main" Requires="p159">
+      <p:transition xmlns:p14="http://schemas.microsoft.com/office/powerpoint/2010/main" spd="slow" p14:dur="1000">
+        <p159:morph option="byObject"/>
+      </p:transition>
+    </mc:Choice>
+    <mc:Fallback>
+      <p:transition spd="slow">
+        <p:fade/>
+      </p:transition>
+    </mc:Fallback>
+  </mc:AlternateContent>
+</p:sld>
+</file>
+
+<file path=ppt/slides/slide8.xml><?xml version="1.0" encoding="utf-8"?>
+<p:sld xmlns:a="http://schemas.openxmlformats.org/drawingml/2006/main" xmlns:r="http://schemas.openxmlformats.org/officeDocument/2006/relationships" xmlns:p="http://schemas.openxmlformats.org/presentationml/2006/main">
+  <p:cSld name="Slide 8">
+    <p:spTree>
+      <p:nvGrpSpPr>
+        <p:cNvPr id="1" name=""/>
+        <p:cNvGrpSpPr/>
+        <p:nvPr/>
+      </p:nvGrpSpPr>
+      <p:grpSpPr>
+        <a:xfrm>
+          <a:off x="0" y="0"/>
+          <a:ext cx="0" cy="0"/>
+          <a:chOff x="0" y="0"/>
+          <a:chExt cx="0" cy="0"/>
+        </a:xfrm>
+      </p:grpSpPr>
+      <p:sp>
+        <p:nvSpPr>
+          <p:cNvPr id="2" name="thanks"/>
+          <p:cNvSpPr txBox="1"/>
+          <p:nvPr/>
+        </p:nvSpPr>
+        <p:spPr>
+          <a:xfrm>
+            <a:off x="548640" y="2651760"/>
+            <a:ext cx="11094415" cy="1371600"/>
+          </a:xfrm>
+          <a:prstGeom prst="rect">
+            <a:avLst/>
+          </a:prstGeom>
+          <a:noFill/>
+          <a:ln/>
+        </p:spPr>
+        <p:txBody>
+          <a:bodyPr wrap="square" lIns="0" tIns="0" rIns="0" bIns="0" rtlCol="0" anchor="ctr"/>
+          <a:lstStyle/>
+          <a:p>
+            <a:pPr algn="ctr" indent="0" marL="0">
+              <a:buNone/>
+            </a:pPr>
+            <a:r>
+              <a:rPr lang="en-US" sz="6000" b="1" dirty="0">
+                <a:solidFill>
+                  <a:schemeClr val="bg1"/>
+                </a:solidFill>
+              </a:rPr>
+              <a:t>Thanks for watching</a:t>
+            </a:r>
+            <a:endParaRPr lang="en-US" sz="6000" dirty="0"/>
+          </a:p>
+        </p:txBody>
+      </p:sp>
+    </p:spTree>
+  </p:cSld>
+  <p:clrMapOvr>
+    <a:masterClrMapping/>
+  </p:clrMapOvr>
+  <mc:AlternateContent xmlns:mc="http://schemas.openxmlformats.org/markup-compatibility/2006">
+    <mc:Choice xmlns:p159="http://schemas.microsoft.com/office/powerpoint/2015/09/main" Requires="p159">
+      <p:transition xmlns:p14="http://schemas.microsoft.com/office/powerpoint/2010/main" spd="slow" p14:dur="1000">
+        <p159:morph option="byObject"/>
+      </p:transition>
+    </mc:Choice>
+    <mc:Fallback>
+      <p:transition spd="slow">
+        <p:fade/>
+      </p:transition>
+    </mc:Fallback>
+  </mc:AlternateContent>
 </p:sld>
 </file>
 

</xml_diff>

<commit_message>
Deck slide 4: captions match the screenshots, full lot card screenshot
- "Map & navigation" tile is now "Nearby lots" (the picture shows the lot card, not the map)
- Booking ticket caption no longer mentions the test payment (the picture is the paid ticket)
- Lot card re-captured without the bottom menu covering its end; alt text typo fixed

Co-Authored-By: Claude Opus 5.5 <noreply@anthropic.com>
Claude-Session: https://claude.ai/code/session_012xGpHDRSu2Z8JV7eYDeD26
</commit_message>
<xml_diff>
--- a/docs/ParkDet-defence.pptx
+++ b/docs/ParkDet-defence.pptx
@@ -114,34 +114,34 @@
   <p:extLst>
     <p:ext uri="{521415D9-36F7-43E2-AB2F-B90AF26B5E84}">
       <p14:sectionLst xmlns:p14="http://schemas.microsoft.com/office/powerpoint/2010/main">
-        <p14:section name="Problem and solution (1:00)" id="{cda13f6f-1c41-2ae3-be3c-375c313ce19d}">
+        <p14:section name="Problem and solution (1:00)" id="{e2ae9f03-73e3-d3a3-dfe1-698774dcf60a}">
           <p14:sldIdLst>
             <p14:sldId id="256"/>
             <p14:sldId id="257"/>
           </p14:sldIdLst>
         </p14:section>
-        <p14:section name="Demo (2:20)" id="{698f7b15-3bab-7340-404f-4a5be4cdb9b0}">
+        <p14:section name="Demo (2:20)" id="{259d2c49-8989-beb7-8125-9e77c34e5167}">
           <p14:sldIdLst>
             <p14:sldId id="258"/>
             <p14:sldId id="259"/>
           </p14:sldIdLst>
         </p14:section>
-        <p14:section name="Technology (1:25)" id="{3d4e30f3-40d3-c5ed-d8b2-3ed1eb1fb23e}">
+        <p14:section name="Technology (1:25)" id="{adb9eed9-dbe4-07e3-6996-256eb14f092d}">
           <p14:sldIdLst>
             <p14:sldId id="260"/>
           </p14:sldIdLst>
         </p14:section>
-        <p14:section name="Competitors (0:45)" id="{1c870268-b80f-7375-ca83-7ee296c92b6e}">
+        <p14:section name="Competitors (0:45)" id="{65819350-0fc6-b01b-d56a-1a7876cfbbbf}">
           <p14:sldIdLst>
             <p14:sldId id="261"/>
           </p14:sldIdLst>
         </p14:section>
-        <p14:section name="Business and pilot (1:20)" id="{52d9f27b-89bd-415d-48a3-246c4a31c975}">
+        <p14:section name="Business and pilot (1:20)" id="{018eade5-ae22-90cd-5b34-0069394e9516}">
           <p14:sldIdLst>
             <p14:sldId id="262"/>
           </p14:sldIdLst>
         </p14:section>
-        <p14:section name="Close (0:10)" id="{045d1d10-6e67-05c0-5fd2-ae8d6cda2538}">
+        <p14:section name="Close (0:10)" id="{738dff73-3b4a-71b8-03d3-c8a448121b45}">
           <p14:sldIdLst>
             <p14:sldId id="263"/>
           </p14:sldIdLst>
@@ -828,7 +828,7 @@
             <a:r>
               <a:rPr lang="en-US" dirty="0"/>
               <a:t>SPEAKER: Gopurjonov Bobur · 3:00–3:20
-"Here are the screens you just saw: the live map with Navigate; Find me a spot, which picks the nearest free spot; the ticket with its QR code and a countdown of how long the spot is held; the walk-in page from the gate QR, where you pay before leaving; and the entrance screen." Hand over to Amirxon.
+"Here are the screens you just saw: nearby lots with live free spots and Navigate; Find me a spot, which picks the nearest free spot; the ticket with its QR code and a countdown of how long the spot is held; the walk-in page from the gate QR, where you pay before leaving; and the entrance screen." Hand over to Amirxon.
 If the live demo failed, walk through these screens instead.</a:t>
             </a:r>
             <a:endParaRPr lang="en-US" dirty="0"/>
@@ -4484,7 +4484,7 @@
       </p:sp>
       <p:sp>
         <p:nvSpPr>
-          <p:cNvPr id="4" name="Map &amp; navigation tile"/>
+          <p:cNvPr id="4" name="Nearby lots tile"/>
           <p:cNvSpPr/>
           <p:nvPr/>
         </p:nvSpPr>
@@ -4506,7 +4506,7 @@
       </p:sp>
       <p:pic>
         <p:nvPicPr>
-          <p:cNvPr id="5" name="Map &amp; navigation screenshot" descr="Map &amp; navigation screen of the ParkDet app">    </p:cNvPr>
+          <p:cNvPr id="5" name="Nearby lots screenshot" descr="Nearby lots screen of the ParkDet app">    </p:cNvPr>
           <p:cNvPicPr>
             <a:picLocks noChangeAspect="1"/>
           </p:cNvPicPr>
@@ -4530,7 +4530,7 @@
       </p:pic>
       <p:sp>
         <p:nvSpPr>
-          <p:cNvPr id="6" name="Map &amp;amp; navigation title"/>
+          <p:cNvPr id="6" name="Nearby lots title"/>
           <p:cNvSpPr txBox="1"/>
           <p:nvPr/>
         </p:nvSpPr>
@@ -4558,7 +4558,7 @@
                   <a:schemeClr val="tx1"/>
                 </a:solidFill>
               </a:rPr>
-              <a:t>Map &amp; navigation</a:t>
+              <a:t>Nearby lots</a:t>
             </a:r>
             <a:endParaRPr lang="en-US" sz="1500" dirty="0"/>
           </a:p>
@@ -4566,7 +4566,7 @@
       </p:sp>
       <p:sp>
         <p:nvSpPr>
-          <p:cNvPr id="7" name="Map &amp;amp; navigation caption"/>
+          <p:cNvPr id="7" name="Nearby lots caption"/>
           <p:cNvSpPr txBox="1"/>
           <p:nvPr/>
         </p:nvSpPr>
@@ -4594,7 +4594,7 @@
                   <a:schemeClr val="tx2"/>
                 </a:solidFill>
               </a:rPr>
-              <a:t>Live free spots near you; Navigate opens Google Maps or Yandex</a:t>
+              <a:t>Live free spots, distance and price; Navigate opens Google Maps or Yandex</a:t>
             </a:r>
             <a:endParaRPr lang="en-US" sz="1200" dirty="0"/>
           </a:p>
@@ -4830,7 +4830,7 @@
                   <a:schemeClr val="tx2"/>
                 </a:solidFill>
               </a:rPr>
-              <a:t>Test payment, QR ticket, countdown of the hold</a:t>
+              <a:t>QR ticket and a countdown of the hold</a:t>
             </a:r>
             <a:endParaRPr lang="en-US" sz="1200" dirty="0"/>
           </a:p>
@@ -4978,7 +4978,7 @@
       </p:sp>
       <p:pic>
         <p:nvPicPr>
-          <p:cNvPr id="21" name="Entrance screen screenshot" descr="Entrance screen screen of the ParkDet app">    </p:cNvPr>
+          <p:cNvPr id="21" name="Entrance screen screenshot" descr="Entrance screen of the ParkDet app">    </p:cNvPr>
           <p:cNvPicPr>
             <a:picLocks noChangeAspect="1"/>
           </p:cNvPicPr>

</xml_diff>

<commit_message>
Deck slide 4: phone screenshots end cleanly; notes no longer claim the screens were in the live demo
- Booking ticket and Walk-in screenshots cropped at a gap instead of a half-hidden button
- Slide 4 notes: "the app's main screens" (3 of them are not in the live demo); extra fallback line removed
- Slide 8 notes keep the original "finish by 6:55"

Co-Authored-By: Claude Opus 5.5 <noreply@anthropic.com>
Claude-Session: https://claude.ai/code/session_012xGpHDRSu2Z8JV7eYDeD26
</commit_message>
<xml_diff>
--- a/docs/ParkDet-defence.pptx
+++ b/docs/ParkDet-defence.pptx
@@ -114,34 +114,34 @@
   <p:extLst>
     <p:ext uri="{521415D9-36F7-43E2-AB2F-B90AF26B5E84}">
       <p14:sectionLst xmlns:p14="http://schemas.microsoft.com/office/powerpoint/2010/main">
-        <p14:section name="Problem and solution (1:00)" id="{e2ae9f03-73e3-d3a3-dfe1-698774dcf60a}">
+        <p14:section name="Problem and solution (1:00)" id="{633ce2b5-28bd-7519-6e57-f77c2b952d39}">
           <p14:sldIdLst>
             <p14:sldId id="256"/>
             <p14:sldId id="257"/>
           </p14:sldIdLst>
         </p14:section>
-        <p14:section name="Demo (2:20)" id="{259d2c49-8989-beb7-8125-9e77c34e5167}">
+        <p14:section name="Demo (2:20)" id="{ab05b014-df79-b7ef-8580-a1f407b76abd}">
           <p14:sldIdLst>
             <p14:sldId id="258"/>
             <p14:sldId id="259"/>
           </p14:sldIdLst>
         </p14:section>
-        <p14:section name="Technology (1:25)" id="{adb9eed9-dbe4-07e3-6996-256eb14f092d}">
+        <p14:section name="Technology (1:25)" id="{15c9f991-9b9d-15a0-3e43-be01fbb67140}">
           <p14:sldIdLst>
             <p14:sldId id="260"/>
           </p14:sldIdLst>
         </p14:section>
-        <p14:section name="Competitors (0:45)" id="{65819350-0fc6-b01b-d56a-1a7876cfbbbf}">
+        <p14:section name="Competitors (0:45)" id="{1353f6e8-5acf-32a9-00a2-c828440f22cb}">
           <p14:sldIdLst>
             <p14:sldId id="261"/>
           </p14:sldIdLst>
         </p14:section>
-        <p14:section name="Business and pilot (1:20)" id="{018eade5-ae22-90cd-5b34-0069394e9516}">
+        <p14:section name="Business and pilot (1:20)" id="{0cc0624d-27ac-65f5-90f5-afb9b76fb0c7}">
           <p14:sldIdLst>
             <p14:sldId id="262"/>
           </p14:sldIdLst>
         </p14:section>
-        <p14:section name="Close (0:10)" id="{738dff73-3b4a-71b8-03d3-c8a448121b45}">
+        <p14:section name="Close (0:10)" id="{ef7735b7-8e27-354d-8c14-43b953d77216}">
           <p14:sldIdLst>
             <p14:sldId id="263"/>
           </p14:sldIdLst>
@@ -828,8 +828,7 @@
             <a:r>
               <a:rPr lang="en-US" dirty="0"/>
               <a:t>SPEAKER: Gopurjonov Bobur · 3:00–3:20
-"Here are the screens you just saw: nearby lots with live free spots and Navigate; Find me a spot, which picks the nearest free spot; the ticket with its QR code and a countdown of how long the spot is held; the walk-in page from the gate QR, where you pay before leaving; and the entrance screen." Hand over to Amirxon.
-If the live demo failed, walk through these screens instead.</a:t>
+"Here are the app's main screens: nearby lots with live free spots and Navigate; Find me a spot, which picks the nearest free spot; the ticket with its QR code and a countdown of how long the spot is held; the walk-in page from the gate QR, where you pay before leaving; and the entrance screen." Hand over to Amirxon.</a:t>
             </a:r>
             <a:endParaRPr lang="en-US" dirty="0"/>
           </a:p>
@@ -1201,7 +1200,7 @@
           <a:p>
             <a:r>
               <a:rPr lang="en-US" dirty="0"/>
-              <a:t>SPEAKER: Bahodurov Bahridin · 6:50–7:00
+              <a:t>SPEAKER: Bahodurov Bahridin · 6:50–7:00 (finish by 6:55)
 "Thanks for watching — we're happy to take your questions."
 Q&amp;A owners: CV / model → Amirxon; app, demo, deployment → Bobur; business, pilot, users → Bahridin.</a:t>
             </a:r>
@@ -4756,8 +4755,8 @@
         </p:blipFill>
         <p:spPr>
           <a:xfrm>
-            <a:off x="5396559" y="1709928"/>
-            <a:ext cx="1398577" cy="3026664"/>
+            <a:off x="5278397" y="1709928"/>
+            <a:ext cx="1634902" cy="3026664"/>
           </a:xfrm>
           <a:prstGeom prst="rect">
             <a:avLst/>
@@ -4874,8 +4873,8 @@
         </p:blipFill>
         <p:spPr>
           <a:xfrm>
-            <a:off x="7661162" y="1709928"/>
-            <a:ext cx="1398577" cy="3026664"/>
+            <a:off x="7567172" y="1709928"/>
+            <a:ext cx="1586558" cy="3026664"/>
           </a:xfrm>
           <a:prstGeom prst="rect">
             <a:avLst/>

</xml_diff>

<commit_message>
Deck: all three speaker photos on the cover; branded closing slide
- Cover: photos of Gopurjonov Bobur and Shomurodov Amirxon added next to Bahodurov Bahridin
- Slide 8: ParkDet logo and wordmark, Parking Detector line, brand blue glow and a top-down
  parking-row background with the logo's amber dot marking a free spot

Co-Authored-By: Claude Opus 5.5 <noreply@anthropic.com>
Claude-Session: https://claude.ai/code/session_012xGpHDRSu2Z8JV7eYDeD26
</commit_message>
<xml_diff>
--- a/docs/ParkDet-defence.pptx
+++ b/docs/ParkDet-defence.pptx
@@ -114,34 +114,34 @@
   <p:extLst>
     <p:ext uri="{521415D9-36F7-43E2-AB2F-B90AF26B5E84}">
       <p14:sectionLst xmlns:p14="http://schemas.microsoft.com/office/powerpoint/2010/main">
-        <p14:section name="Problem and solution (1:00)" id="{633ce2b5-28bd-7519-6e57-f77c2b952d39}">
+        <p14:section name="Problem and solution (1:00)" id="{3df3bd15-68ea-8c9f-159d-5500fa953081}">
           <p14:sldIdLst>
             <p14:sldId id="256"/>
             <p14:sldId id="257"/>
           </p14:sldIdLst>
         </p14:section>
-        <p14:section name="Demo (2:20)" id="{ab05b014-df79-b7ef-8580-a1f407b76abd}">
+        <p14:section name="Demo (2:20)" id="{4231b319-ee86-0582-9d06-63a094c5ba85}">
           <p14:sldIdLst>
             <p14:sldId id="258"/>
             <p14:sldId id="259"/>
           </p14:sldIdLst>
         </p14:section>
-        <p14:section name="Technology (1:25)" id="{15c9f991-9b9d-15a0-3e43-be01fbb67140}">
+        <p14:section name="Technology (1:25)" id="{8fcc1300-b30a-7c6b-e2e9-2cdb8f8360ef}">
           <p14:sldIdLst>
             <p14:sldId id="260"/>
           </p14:sldIdLst>
         </p14:section>
-        <p14:section name="Competitors (0:45)" id="{1353f6e8-5acf-32a9-00a2-c828440f22cb}">
+        <p14:section name="Competitors (0:45)" id="{f6673b8c-b509-9644-80c9-8f97ccc7e2f4}">
           <p14:sldIdLst>
             <p14:sldId id="261"/>
           </p14:sldIdLst>
         </p14:section>
-        <p14:section name="Business and pilot (1:20)" id="{0cc0624d-27ac-65f5-90f5-afb9b76fb0c7}">
+        <p14:section name="Business and pilot (1:20)" id="{ac7c6137-42cc-1285-3508-59690157f01f}">
           <p14:sldIdLst>
             <p14:sldId id="262"/>
           </p14:sldIdLst>
         </p14:section>
-        <p14:section name="Close (0:10)" id="{ef7735b7-8e27-354d-8c14-43b953d77216}">
+        <p14:section name="Close (0:10)" id="{e318916c-8724-c0c3-8c01-2e89c583a783}">
           <p14:sldIdLst>
             <p14:sldId id="263"/>
           </p14:sldIdLst>
@@ -552,7 +552,7 @@
               <a:rPr lang="en-US" dirty="0"/>
               <a:t>SPEAKER: Bahodurov Bahridin · 0:00–0:15
 "Good afternoon. We are team ALL-IN-ONE and this is ParkDet — short for Parking Detector — a Startup-mode product for the Computer Vision track. ParkDet shows free parking spots, live."
-(Replace the three circles with the speakers' photos. The phone shows our app's live spot map from a test run: green = free, orange = booked, grey = occupied — swap in a WIUT screenshot once your lot is live.)</a:t>
+(The phone shows our app's live spot map from a test run: green = free, orange = booked, grey = occupied — swap in a WIUT screenshot once your lot is live.)</a:t>
             </a:r>
             <a:endParaRPr lang="en-US" dirty="0"/>
           </a:p>
@@ -2325,187 +2325,9 @@
           </a:p>
         </p:txBody>
       </p:sp>
-      <p:sp>
-        <p:nvSpPr>
-          <p:cNvPr id="10" name="photo 2 (replace)"/>
-          <p:cNvSpPr/>
-          <p:nvPr/>
-        </p:nvSpPr>
-        <p:spPr>
-          <a:xfrm>
-            <a:off x="3063240" y="4434840"/>
-            <a:ext cx="777240" cy="777240"/>
-          </a:xfrm>
-          <a:prstGeom prst="ellipse">
-            <a:avLst/>
-          </a:prstGeom>
-          <a:solidFill>
-            <a:schemeClr val="bg1">
-              <a:alpha val="15000"/>
-            </a:schemeClr>
-          </a:solidFill>
-          <a:ln w="25400">
-            <a:solidFill>
-              <a:srgbClr val="F2A93B"/>
-            </a:solidFill>
-            <a:prstDash val="solid"/>
-          </a:ln>
-        </p:spPr>
-      </p:sp>
-      <p:sp>
-        <p:nvSpPr>
-          <p:cNvPr id="11" name="speaker 2"/>
-          <p:cNvSpPr txBox="1"/>
-          <p:nvPr/>
-        </p:nvSpPr>
-        <p:spPr>
-          <a:xfrm>
-            <a:off x="3977640" y="4434840"/>
-            <a:ext cx="1554480" cy="777240"/>
-          </a:xfrm>
-          <a:prstGeom prst="rect">
-            <a:avLst/>
-          </a:prstGeom>
-          <a:noFill/>
-          <a:ln/>
-        </p:spPr>
-        <p:txBody>
-          <a:bodyPr wrap="square" lIns="0" tIns="0" rIns="0" bIns="0" rtlCol="0" anchor="ctr"/>
-          <a:lstStyle/>
-          <a:p>
-            <a:pPr indent="0" marL="0">
-              <a:buNone/>
-            </a:pPr>
-            <a:r>
-              <a:rPr lang="en-US" sz="1500" dirty="0">
-                <a:solidFill>
-                  <a:schemeClr val="bg1"/>
-                </a:solidFill>
-              </a:rPr>
-              <a:t>Gopurjonov</a:t>
-            </a:r>
-            <a:endParaRPr lang="en-US" sz="1500" dirty="0"/>
-          </a:p>
-          <a:p>
-            <a:pPr indent="0" marL="0">
-              <a:buNone/>
-            </a:pPr>
-            <a:r>
-              <a:rPr lang="en-US" sz="1500" dirty="0">
-                <a:solidFill>
-                  <a:schemeClr val="bg1"/>
-                </a:solidFill>
-              </a:rPr>
-              <a:t>Bobur</a:t>
-            </a:r>
-            <a:endParaRPr lang="en-US" sz="1500" dirty="0"/>
-          </a:p>
-        </p:txBody>
-      </p:sp>
-      <p:sp>
-        <p:nvSpPr>
-          <p:cNvPr id="12" name="photo 3 (replace)"/>
-          <p:cNvSpPr/>
-          <p:nvPr/>
-        </p:nvSpPr>
-        <p:spPr>
-          <a:xfrm>
-            <a:off x="5577840" y="4434840"/>
-            <a:ext cx="777240" cy="777240"/>
-          </a:xfrm>
-          <a:prstGeom prst="ellipse">
-            <a:avLst/>
-          </a:prstGeom>
-          <a:solidFill>
-            <a:schemeClr val="bg1">
-              <a:alpha val="15000"/>
-            </a:schemeClr>
-          </a:solidFill>
-          <a:ln w="25400">
-            <a:solidFill>
-              <a:srgbClr val="F2A93B"/>
-            </a:solidFill>
-            <a:prstDash val="solid"/>
-          </a:ln>
-        </p:spPr>
-      </p:sp>
-      <p:sp>
-        <p:nvSpPr>
-          <p:cNvPr id="13" name="speaker 3"/>
-          <p:cNvSpPr txBox="1"/>
-          <p:nvPr/>
-        </p:nvSpPr>
-        <p:spPr>
-          <a:xfrm>
-            <a:off x="6492240" y="4434840"/>
-            <a:ext cx="1554480" cy="777240"/>
-          </a:xfrm>
-          <a:prstGeom prst="rect">
-            <a:avLst/>
-          </a:prstGeom>
-          <a:noFill/>
-          <a:ln/>
-        </p:spPr>
-        <p:txBody>
-          <a:bodyPr wrap="square" lIns="0" tIns="0" rIns="0" bIns="0" rtlCol="0" anchor="ctr"/>
-          <a:lstStyle/>
-          <a:p>
-            <a:pPr indent="0" marL="0">
-              <a:buNone/>
-            </a:pPr>
-            <a:r>
-              <a:rPr lang="en-US" sz="1500" dirty="0">
-                <a:solidFill>
-                  <a:schemeClr val="bg1"/>
-                </a:solidFill>
-              </a:rPr>
-              <a:t>Shomurodov</a:t>
-            </a:r>
-            <a:endParaRPr lang="en-US" sz="1500" dirty="0"/>
-          </a:p>
-          <a:p>
-            <a:pPr indent="0" marL="0">
-              <a:buNone/>
-            </a:pPr>
-            <a:r>
-              <a:rPr lang="en-US" sz="1500" dirty="0">
-                <a:solidFill>
-                  <a:schemeClr val="bg1"/>
-                </a:solidFill>
-              </a:rPr>
-              <a:t>Amirxon</a:t>
-            </a:r>
-            <a:endParaRPr lang="en-US" sz="1500" dirty="0"/>
-          </a:p>
-        </p:txBody>
-      </p:sp>
-      <p:sp>
-        <p:nvSpPr>
-          <p:cNvPr id="14" name="phone frame"/>
-          <p:cNvSpPr/>
-          <p:nvPr/>
-        </p:nvSpPr>
-        <p:spPr>
-          <a:xfrm>
-            <a:off x="9361033" y="548640"/>
-            <a:ext cx="2297567" cy="5760720"/>
-          </a:xfrm>
-          <a:prstGeom prst="roundRect">
-            <a:avLst>
-              <a:gd name="adj" fmla="val 9950"/>
-            </a:avLst>
-          </a:prstGeom>
-          <a:solidFill>
-            <a:schemeClr val="bg1">
-              <a:alpha val="12000"/>
-            </a:schemeClr>
-          </a:solidFill>
-          <a:ln/>
-        </p:spPr>
-      </p:sp>
       <p:pic>
         <p:nvPicPr>
-          <p:cNvPr id="15" name="app screenshot" descr="ParkDet driver app: a lot's live spot map with free (green), booked (orange) and occupied (grey) spots">    </p:cNvPr>
+          <p:cNvPr id="10" name="photo Gopurjonov Bobur" descr="Gopurjonov Bobur">    </p:cNvPr>
           <p:cNvPicPr>
             <a:picLocks noChangeAspect="1"/>
           </p:cNvPicPr>
@@ -2519,6 +2341,222 @@
         </p:blipFill>
         <p:spPr>
           <a:xfrm>
+            <a:off x="3063240" y="4434840"/>
+            <a:ext cx="777240" cy="777240"/>
+          </a:xfrm>
+          <a:prstGeom prst="ellipse">
+            <a:avLst/>
+          </a:prstGeom>
+        </p:spPr>
+      </p:pic>
+      <p:sp>
+        <p:nvSpPr>
+          <p:cNvPr id="11" name="photo ring 2"/>
+          <p:cNvSpPr/>
+          <p:nvPr/>
+        </p:nvSpPr>
+        <p:spPr>
+          <a:xfrm>
+            <a:off x="3063240" y="4434840"/>
+            <a:ext cx="777240" cy="777240"/>
+          </a:xfrm>
+          <a:prstGeom prst="ellipse">
+            <a:avLst/>
+          </a:prstGeom>
+          <a:ln w="25400">
+            <a:solidFill>
+              <a:srgbClr val="F2A93B"/>
+            </a:solidFill>
+            <a:prstDash val="solid"/>
+          </a:ln>
+        </p:spPr>
+      </p:sp>
+      <p:sp>
+        <p:nvSpPr>
+          <p:cNvPr id="12" name="speaker 2"/>
+          <p:cNvSpPr txBox="1"/>
+          <p:nvPr/>
+        </p:nvSpPr>
+        <p:spPr>
+          <a:xfrm>
+            <a:off x="3977640" y="4434840"/>
+            <a:ext cx="1554480" cy="777240"/>
+          </a:xfrm>
+          <a:prstGeom prst="rect">
+            <a:avLst/>
+          </a:prstGeom>
+          <a:noFill/>
+          <a:ln/>
+        </p:spPr>
+        <p:txBody>
+          <a:bodyPr wrap="square" lIns="0" tIns="0" rIns="0" bIns="0" rtlCol="0" anchor="ctr"/>
+          <a:lstStyle/>
+          <a:p>
+            <a:pPr indent="0" marL="0">
+              <a:buNone/>
+            </a:pPr>
+            <a:r>
+              <a:rPr lang="en-US" sz="1500" dirty="0">
+                <a:solidFill>
+                  <a:schemeClr val="bg1"/>
+                </a:solidFill>
+              </a:rPr>
+              <a:t>Gopurjonov</a:t>
+            </a:r>
+            <a:endParaRPr lang="en-US" sz="1500" dirty="0"/>
+          </a:p>
+          <a:p>
+            <a:pPr indent="0" marL="0">
+              <a:buNone/>
+            </a:pPr>
+            <a:r>
+              <a:rPr lang="en-US" sz="1500" dirty="0">
+                <a:solidFill>
+                  <a:schemeClr val="bg1"/>
+                </a:solidFill>
+              </a:rPr>
+              <a:t>Bobur</a:t>
+            </a:r>
+            <a:endParaRPr lang="en-US" sz="1500" dirty="0"/>
+          </a:p>
+        </p:txBody>
+      </p:sp>
+      <p:pic>
+        <p:nvPicPr>
+          <p:cNvPr id="13" name="photo Shomurodov Amirxon" descr="Shomurodov Amirxon">    </p:cNvPr>
+          <p:cNvPicPr>
+            <a:picLocks noChangeAspect="1"/>
+          </p:cNvPicPr>
+          <p:nvPr/>
+        </p:nvPicPr>
+        <p:blipFill>
+          <a:blip r:embed="rId3"/>
+          <a:stretch>
+            <a:fillRect/>
+          </a:stretch>
+        </p:blipFill>
+        <p:spPr>
+          <a:xfrm>
+            <a:off x="5577840" y="4434840"/>
+            <a:ext cx="777240" cy="777240"/>
+          </a:xfrm>
+          <a:prstGeom prst="ellipse">
+            <a:avLst/>
+          </a:prstGeom>
+        </p:spPr>
+      </p:pic>
+      <p:sp>
+        <p:nvSpPr>
+          <p:cNvPr id="14" name="photo ring 3"/>
+          <p:cNvSpPr/>
+          <p:nvPr/>
+        </p:nvSpPr>
+        <p:spPr>
+          <a:xfrm>
+            <a:off x="5577840" y="4434840"/>
+            <a:ext cx="777240" cy="777240"/>
+          </a:xfrm>
+          <a:prstGeom prst="ellipse">
+            <a:avLst/>
+          </a:prstGeom>
+          <a:ln w="25400">
+            <a:solidFill>
+              <a:srgbClr val="F2A93B"/>
+            </a:solidFill>
+            <a:prstDash val="solid"/>
+          </a:ln>
+        </p:spPr>
+      </p:sp>
+      <p:sp>
+        <p:nvSpPr>
+          <p:cNvPr id="15" name="speaker 3"/>
+          <p:cNvSpPr txBox="1"/>
+          <p:nvPr/>
+        </p:nvSpPr>
+        <p:spPr>
+          <a:xfrm>
+            <a:off x="6492240" y="4434840"/>
+            <a:ext cx="1554480" cy="777240"/>
+          </a:xfrm>
+          <a:prstGeom prst="rect">
+            <a:avLst/>
+          </a:prstGeom>
+          <a:noFill/>
+          <a:ln/>
+        </p:spPr>
+        <p:txBody>
+          <a:bodyPr wrap="square" lIns="0" tIns="0" rIns="0" bIns="0" rtlCol="0" anchor="ctr"/>
+          <a:lstStyle/>
+          <a:p>
+            <a:pPr indent="0" marL="0">
+              <a:buNone/>
+            </a:pPr>
+            <a:r>
+              <a:rPr lang="en-US" sz="1500" dirty="0">
+                <a:solidFill>
+                  <a:schemeClr val="bg1"/>
+                </a:solidFill>
+              </a:rPr>
+              <a:t>Shomurodov</a:t>
+            </a:r>
+            <a:endParaRPr lang="en-US" sz="1500" dirty="0"/>
+          </a:p>
+          <a:p>
+            <a:pPr indent="0" marL="0">
+              <a:buNone/>
+            </a:pPr>
+            <a:r>
+              <a:rPr lang="en-US" sz="1500" dirty="0">
+                <a:solidFill>
+                  <a:schemeClr val="bg1"/>
+                </a:solidFill>
+              </a:rPr>
+              <a:t>Amirxon</a:t>
+            </a:r>
+            <a:endParaRPr lang="en-US" sz="1500" dirty="0"/>
+          </a:p>
+        </p:txBody>
+      </p:sp>
+      <p:sp>
+        <p:nvSpPr>
+          <p:cNvPr id="16" name="phone frame"/>
+          <p:cNvSpPr/>
+          <p:nvPr/>
+        </p:nvSpPr>
+        <p:spPr>
+          <a:xfrm>
+            <a:off x="9361033" y="548640"/>
+            <a:ext cx="2297567" cy="5760720"/>
+          </a:xfrm>
+          <a:prstGeom prst="roundRect">
+            <a:avLst>
+              <a:gd name="adj" fmla="val 9950"/>
+            </a:avLst>
+          </a:prstGeom>
+          <a:solidFill>
+            <a:schemeClr val="bg1">
+              <a:alpha val="12000"/>
+            </a:schemeClr>
+          </a:solidFill>
+          <a:ln/>
+        </p:spPr>
+      </p:sp>
+      <p:pic>
+        <p:nvPicPr>
+          <p:cNvPr id="17" name="app screenshot" descr="ParkDet driver app: a lot's live spot map with free (green), booked (orange) and occupied (grey) spots">    </p:cNvPr>
+          <p:cNvPicPr>
+            <a:picLocks noChangeAspect="1"/>
+          </p:cNvPicPr>
+          <p:nvPr/>
+        </p:nvPicPr>
+        <p:blipFill>
+          <a:blip r:embed="rId4"/>
+          <a:stretch>
+            <a:fillRect/>
+          </a:stretch>
+        </p:blipFill>
+        <p:spPr>
+          <a:xfrm>
             <a:off x="9507337" y="694944"/>
             <a:ext cx="2004959" cy="5029200"/>
           </a:xfrm>
@@ -2529,7 +2567,7 @@
       </p:pic>
       <p:sp>
         <p:nvSpPr>
-          <p:cNvPr id="16" name="screenshot caption"/>
+          <p:cNvPr id="18" name="screenshot caption"/>
           <p:cNvSpPr txBox="1"/>
           <p:nvPr/>
         </p:nvSpPr>
@@ -2579,7 +2617,7 @@
       </p:sp>
       <p:sp>
         <p:nvSpPr>
-          <p:cNvPr id="17" name="cover footer"/>
+          <p:cNvPr id="19" name="cover footer"/>
           <p:cNvSpPr txBox="1"/>
           <p:nvPr/>
         </p:nvSpPr>
@@ -10036,16 +10074,1283 @@
           <a:chExt cx="0" cy="0"/>
         </a:xfrm>
       </p:grpSpPr>
-      <p:sp>
-        <p:nvSpPr>
-          <p:cNvPr id="2" name="thanks"/>
+      <p:pic>
+        <p:nvPicPr>
+          <p:cNvPr id="2" name="background glow" descr="preencoded.png">    </p:cNvPr>
+          <p:cNvPicPr>
+            <a:picLocks noChangeAspect="1"/>
+          </p:cNvPicPr>
+          <p:nvPr/>
+        </p:nvPicPr>
+        <p:blipFill>
+          <a:blip r:embed="rId1"/>
+          <a:stretch>
+            <a:fillRect/>
+          </a:stretch>
+        </p:blipFill>
+        <p:spPr>
+          <a:xfrm>
+            <a:off x="0" y="0"/>
+            <a:ext cx="12191695" cy="6858000"/>
+          </a:xfrm>
+          <a:prstGeom prst="rect">
+            <a:avLst/>
+          </a:prstGeom>
+        </p:spPr>
+      </p:pic>
+      <p:sp>
+        <p:nvSpPr>
+          <p:cNvPr id="3" name="bay line 1-1"/>
+          <p:cNvSpPr/>
+          <p:nvPr/>
+        </p:nvSpPr>
+        <p:spPr>
+          <a:xfrm>
+            <a:off x="335128" y="0"/>
+            <a:ext cx="0" cy="914400"/>
+          </a:xfrm>
+          <a:prstGeom prst="line">
+            <a:avLst/>
+          </a:prstGeom>
+          <a:noFill/>
+          <a:ln w="19050">
+            <a:solidFill>
+              <a:srgbClr val="FFFFFF">
+                <a:alpha val="18000"/>
+              </a:srgbClr>
+            </a:solidFill>
+            <a:prstDash val="solid"/>
+          </a:ln>
+        </p:spPr>
+      </p:sp>
+      <p:sp>
+        <p:nvSpPr>
+          <p:cNvPr id="4" name="bay line 1-2"/>
+          <p:cNvSpPr/>
+          <p:nvPr/>
+        </p:nvSpPr>
+        <p:spPr>
+          <a:xfrm>
+            <a:off x="1295248" y="0"/>
+            <a:ext cx="0" cy="914400"/>
+          </a:xfrm>
+          <a:prstGeom prst="line">
+            <a:avLst/>
+          </a:prstGeom>
+          <a:noFill/>
+          <a:ln w="19050">
+            <a:solidFill>
+              <a:srgbClr val="FFFFFF">
+                <a:alpha val="18000"/>
+              </a:srgbClr>
+            </a:solidFill>
+            <a:prstDash val="solid"/>
+          </a:ln>
+        </p:spPr>
+      </p:sp>
+      <p:sp>
+        <p:nvSpPr>
+          <p:cNvPr id="5" name="bay line 1-3"/>
+          <p:cNvSpPr/>
+          <p:nvPr/>
+        </p:nvSpPr>
+        <p:spPr>
+          <a:xfrm>
+            <a:off x="2255368" y="0"/>
+            <a:ext cx="0" cy="914400"/>
+          </a:xfrm>
+          <a:prstGeom prst="line">
+            <a:avLst/>
+          </a:prstGeom>
+          <a:noFill/>
+          <a:ln w="19050">
+            <a:solidFill>
+              <a:srgbClr val="FFFFFF">
+                <a:alpha val="18000"/>
+              </a:srgbClr>
+            </a:solidFill>
+            <a:prstDash val="solid"/>
+          </a:ln>
+        </p:spPr>
+      </p:sp>
+      <p:sp>
+        <p:nvSpPr>
+          <p:cNvPr id="6" name="bay line 1-4"/>
+          <p:cNvSpPr/>
+          <p:nvPr/>
+        </p:nvSpPr>
+        <p:spPr>
+          <a:xfrm>
+            <a:off x="3215488" y="0"/>
+            <a:ext cx="0" cy="914400"/>
+          </a:xfrm>
+          <a:prstGeom prst="line">
+            <a:avLst/>
+          </a:prstGeom>
+          <a:noFill/>
+          <a:ln w="19050">
+            <a:solidFill>
+              <a:srgbClr val="FFFFFF">
+                <a:alpha val="18000"/>
+              </a:srgbClr>
+            </a:solidFill>
+            <a:prstDash val="solid"/>
+          </a:ln>
+        </p:spPr>
+      </p:sp>
+      <p:sp>
+        <p:nvSpPr>
+          <p:cNvPr id="7" name="bay line 1-5"/>
+          <p:cNvSpPr/>
+          <p:nvPr/>
+        </p:nvSpPr>
+        <p:spPr>
+          <a:xfrm>
+            <a:off x="4175608" y="0"/>
+            <a:ext cx="0" cy="914400"/>
+          </a:xfrm>
+          <a:prstGeom prst="line">
+            <a:avLst/>
+          </a:prstGeom>
+          <a:noFill/>
+          <a:ln w="19050">
+            <a:solidFill>
+              <a:srgbClr val="FFFFFF">
+                <a:alpha val="18000"/>
+              </a:srgbClr>
+            </a:solidFill>
+            <a:prstDash val="solid"/>
+          </a:ln>
+        </p:spPr>
+      </p:sp>
+      <p:sp>
+        <p:nvSpPr>
+          <p:cNvPr id="8" name="bay line 1-6"/>
+          <p:cNvSpPr/>
+          <p:nvPr/>
+        </p:nvSpPr>
+        <p:spPr>
+          <a:xfrm>
+            <a:off x="5135728" y="0"/>
+            <a:ext cx="0" cy="914400"/>
+          </a:xfrm>
+          <a:prstGeom prst="line">
+            <a:avLst/>
+          </a:prstGeom>
+          <a:noFill/>
+          <a:ln w="19050">
+            <a:solidFill>
+              <a:srgbClr val="FFFFFF">
+                <a:alpha val="18000"/>
+              </a:srgbClr>
+            </a:solidFill>
+            <a:prstDash val="solid"/>
+          </a:ln>
+        </p:spPr>
+      </p:sp>
+      <p:sp>
+        <p:nvSpPr>
+          <p:cNvPr id="9" name="bay line 1-7"/>
+          <p:cNvSpPr/>
+          <p:nvPr/>
+        </p:nvSpPr>
+        <p:spPr>
+          <a:xfrm>
+            <a:off x="6095848" y="0"/>
+            <a:ext cx="0" cy="914400"/>
+          </a:xfrm>
+          <a:prstGeom prst="line">
+            <a:avLst/>
+          </a:prstGeom>
+          <a:noFill/>
+          <a:ln w="19050">
+            <a:solidFill>
+              <a:srgbClr val="FFFFFF">
+                <a:alpha val="18000"/>
+              </a:srgbClr>
+            </a:solidFill>
+            <a:prstDash val="solid"/>
+          </a:ln>
+        </p:spPr>
+      </p:sp>
+      <p:sp>
+        <p:nvSpPr>
+          <p:cNvPr id="10" name="bay line 1-8"/>
+          <p:cNvSpPr/>
+          <p:nvPr/>
+        </p:nvSpPr>
+        <p:spPr>
+          <a:xfrm>
+            <a:off x="7055968" y="0"/>
+            <a:ext cx="0" cy="914400"/>
+          </a:xfrm>
+          <a:prstGeom prst="line">
+            <a:avLst/>
+          </a:prstGeom>
+          <a:noFill/>
+          <a:ln w="19050">
+            <a:solidFill>
+              <a:srgbClr val="FFFFFF">
+                <a:alpha val="18000"/>
+              </a:srgbClr>
+            </a:solidFill>
+            <a:prstDash val="solid"/>
+          </a:ln>
+        </p:spPr>
+      </p:sp>
+      <p:sp>
+        <p:nvSpPr>
+          <p:cNvPr id="11" name="bay line 1-9"/>
+          <p:cNvSpPr/>
+          <p:nvPr/>
+        </p:nvSpPr>
+        <p:spPr>
+          <a:xfrm>
+            <a:off x="8016088" y="0"/>
+            <a:ext cx="0" cy="914400"/>
+          </a:xfrm>
+          <a:prstGeom prst="line">
+            <a:avLst/>
+          </a:prstGeom>
+          <a:noFill/>
+          <a:ln w="19050">
+            <a:solidFill>
+              <a:srgbClr val="FFFFFF">
+                <a:alpha val="18000"/>
+              </a:srgbClr>
+            </a:solidFill>
+            <a:prstDash val="solid"/>
+          </a:ln>
+        </p:spPr>
+      </p:sp>
+      <p:sp>
+        <p:nvSpPr>
+          <p:cNvPr id="12" name="bay line 1-10"/>
+          <p:cNvSpPr/>
+          <p:nvPr/>
+        </p:nvSpPr>
+        <p:spPr>
+          <a:xfrm>
+            <a:off x="8976208" y="0"/>
+            <a:ext cx="0" cy="914400"/>
+          </a:xfrm>
+          <a:prstGeom prst="line">
+            <a:avLst/>
+          </a:prstGeom>
+          <a:noFill/>
+          <a:ln w="19050">
+            <a:solidFill>
+              <a:srgbClr val="FFFFFF">
+                <a:alpha val="18000"/>
+              </a:srgbClr>
+            </a:solidFill>
+            <a:prstDash val="solid"/>
+          </a:ln>
+        </p:spPr>
+      </p:sp>
+      <p:sp>
+        <p:nvSpPr>
+          <p:cNvPr id="13" name="bay line 1-11"/>
+          <p:cNvSpPr/>
+          <p:nvPr/>
+        </p:nvSpPr>
+        <p:spPr>
+          <a:xfrm>
+            <a:off x="9936328" y="0"/>
+            <a:ext cx="0" cy="914400"/>
+          </a:xfrm>
+          <a:prstGeom prst="line">
+            <a:avLst/>
+          </a:prstGeom>
+          <a:noFill/>
+          <a:ln w="19050">
+            <a:solidFill>
+              <a:srgbClr val="FFFFFF">
+                <a:alpha val="18000"/>
+              </a:srgbClr>
+            </a:solidFill>
+            <a:prstDash val="solid"/>
+          </a:ln>
+        </p:spPr>
+      </p:sp>
+      <p:sp>
+        <p:nvSpPr>
+          <p:cNvPr id="14" name="bay line 1-12"/>
+          <p:cNvSpPr/>
+          <p:nvPr/>
+        </p:nvSpPr>
+        <p:spPr>
+          <a:xfrm>
+            <a:off x="10896448" y="0"/>
+            <a:ext cx="0" cy="914400"/>
+          </a:xfrm>
+          <a:prstGeom prst="line">
+            <a:avLst/>
+          </a:prstGeom>
+          <a:noFill/>
+          <a:ln w="19050">
+            <a:solidFill>
+              <a:srgbClr val="FFFFFF">
+                <a:alpha val="18000"/>
+              </a:srgbClr>
+            </a:solidFill>
+            <a:prstDash val="solid"/>
+          </a:ln>
+        </p:spPr>
+      </p:sp>
+      <p:sp>
+        <p:nvSpPr>
+          <p:cNvPr id="15" name="bay line 1-13"/>
+          <p:cNvSpPr/>
+          <p:nvPr/>
+        </p:nvSpPr>
+        <p:spPr>
+          <a:xfrm>
+            <a:off x="11856568" y="0"/>
+            <a:ext cx="0" cy="914400"/>
+          </a:xfrm>
+          <a:prstGeom prst="line">
+            <a:avLst/>
+          </a:prstGeom>
+          <a:noFill/>
+          <a:ln w="19050">
+            <a:solidFill>
+              <a:srgbClr val="FFFFFF">
+                <a:alpha val="18000"/>
+              </a:srgbClr>
+            </a:solidFill>
+            <a:prstDash val="solid"/>
+          </a:ln>
+        </p:spPr>
+      </p:sp>
+      <p:pic>
+        <p:nvPicPr>
+          <p:cNvPr id="16" name="parked car 1-1" descr="preencoded.png">    </p:cNvPr>
+          <p:cNvPicPr>
+            <a:picLocks noChangeAspect="1"/>
+          </p:cNvPicPr>
+          <p:nvPr/>
+        </p:nvPicPr>
+        <p:blipFill>
+          <a:blip r:embed="rId2">
+            <a:alphaModFix amt="12000"/>
+          </a:blip>
+          <a:stretch>
+            <a:fillRect/>
+          </a:stretch>
+        </p:blipFill>
+        <p:spPr>
+          <a:xfrm>
+            <a:off x="586588" y="91440"/>
+            <a:ext cx="457200" cy="731520"/>
+          </a:xfrm>
+          <a:prstGeom prst="rect">
+            <a:avLst/>
+          </a:prstGeom>
+        </p:spPr>
+      </p:pic>
+      <p:pic>
+        <p:nvPicPr>
+          <p:cNvPr id="17" name="parked car 1-2" descr="preencoded.png">    </p:cNvPr>
+          <p:cNvPicPr>
+            <a:picLocks noChangeAspect="1"/>
+          </p:cNvPicPr>
+          <p:nvPr/>
+        </p:nvPicPr>
+        <p:blipFill>
+          <a:blip r:embed="rId3">
+            <a:alphaModFix amt="12000"/>
+          </a:blip>
+          <a:stretch>
+            <a:fillRect/>
+          </a:stretch>
+        </p:blipFill>
+        <p:spPr>
+          <a:xfrm>
+            <a:off x="1546708" y="91440"/>
+            <a:ext cx="457200" cy="731520"/>
+          </a:xfrm>
+          <a:prstGeom prst="rect">
+            <a:avLst/>
+          </a:prstGeom>
+        </p:spPr>
+      </p:pic>
+      <p:pic>
+        <p:nvPicPr>
+          <p:cNvPr id="18" name="parked car 1-4" descr="preencoded.png">    </p:cNvPr>
+          <p:cNvPicPr>
+            <a:picLocks noChangeAspect="1"/>
+          </p:cNvPicPr>
+          <p:nvPr/>
+        </p:nvPicPr>
+        <p:blipFill>
+          <a:blip r:embed="rId4">
+            <a:alphaModFix amt="12000"/>
+          </a:blip>
+          <a:stretch>
+            <a:fillRect/>
+          </a:stretch>
+        </p:blipFill>
+        <p:spPr>
+          <a:xfrm>
+            <a:off x="3466948" y="91440"/>
+            <a:ext cx="457200" cy="731520"/>
+          </a:xfrm>
+          <a:prstGeom prst="rect">
+            <a:avLst/>
+          </a:prstGeom>
+        </p:spPr>
+      </p:pic>
+      <p:pic>
+        <p:nvPicPr>
+          <p:cNvPr id="19" name="parked car 1-5" descr="preencoded.png">    </p:cNvPr>
+          <p:cNvPicPr>
+            <a:picLocks noChangeAspect="1"/>
+          </p:cNvPicPr>
+          <p:nvPr/>
+        </p:nvPicPr>
+        <p:blipFill>
+          <a:blip r:embed="rId5">
+            <a:alphaModFix amt="12000"/>
+          </a:blip>
+          <a:stretch>
+            <a:fillRect/>
+          </a:stretch>
+        </p:blipFill>
+        <p:spPr>
+          <a:xfrm>
+            <a:off x="4427068" y="91440"/>
+            <a:ext cx="457200" cy="731520"/>
+          </a:xfrm>
+          <a:prstGeom prst="rect">
+            <a:avLst/>
+          </a:prstGeom>
+        </p:spPr>
+      </p:pic>
+      <p:pic>
+        <p:nvPicPr>
+          <p:cNvPr id="20" name="parked car 1-6" descr="preencoded.png">    </p:cNvPr>
+          <p:cNvPicPr>
+            <a:picLocks noChangeAspect="1"/>
+          </p:cNvPicPr>
+          <p:nvPr/>
+        </p:nvPicPr>
+        <p:blipFill>
+          <a:blip r:embed="rId6">
+            <a:alphaModFix amt="12000"/>
+          </a:blip>
+          <a:stretch>
+            <a:fillRect/>
+          </a:stretch>
+        </p:blipFill>
+        <p:spPr>
+          <a:xfrm>
+            <a:off x="5387188" y="91440"/>
+            <a:ext cx="457200" cy="731520"/>
+          </a:xfrm>
+          <a:prstGeom prst="rect">
+            <a:avLst/>
+          </a:prstGeom>
+        </p:spPr>
+      </p:pic>
+      <p:pic>
+        <p:nvPicPr>
+          <p:cNvPr id="21" name="parked car 1-7" descr="preencoded.png">    </p:cNvPr>
+          <p:cNvPicPr>
+            <a:picLocks noChangeAspect="1"/>
+          </p:cNvPicPr>
+          <p:nvPr/>
+        </p:nvPicPr>
+        <p:blipFill>
+          <a:blip r:embed="rId7">
+            <a:alphaModFix amt="12000"/>
+          </a:blip>
+          <a:stretch>
+            <a:fillRect/>
+          </a:stretch>
+        </p:blipFill>
+        <p:spPr>
+          <a:xfrm>
+            <a:off x="6347308" y="91440"/>
+            <a:ext cx="457200" cy="731520"/>
+          </a:xfrm>
+          <a:prstGeom prst="rect">
+            <a:avLst/>
+          </a:prstGeom>
+        </p:spPr>
+      </p:pic>
+      <p:pic>
+        <p:nvPicPr>
+          <p:cNvPr id="22" name="parked car 1-8" descr="preencoded.png">    </p:cNvPr>
+          <p:cNvPicPr>
+            <a:picLocks noChangeAspect="1"/>
+          </p:cNvPicPr>
+          <p:nvPr/>
+        </p:nvPicPr>
+        <p:blipFill>
+          <a:blip r:embed="rId8">
+            <a:alphaModFix amt="12000"/>
+          </a:blip>
+          <a:stretch>
+            <a:fillRect/>
+          </a:stretch>
+        </p:blipFill>
+        <p:spPr>
+          <a:xfrm>
+            <a:off x="7307428" y="91440"/>
+            <a:ext cx="457200" cy="731520"/>
+          </a:xfrm>
+          <a:prstGeom prst="rect">
+            <a:avLst/>
+          </a:prstGeom>
+        </p:spPr>
+      </p:pic>
+      <p:pic>
+        <p:nvPicPr>
+          <p:cNvPr id="23" name="parked car 1-10" descr="preencoded.png">    </p:cNvPr>
+          <p:cNvPicPr>
+            <a:picLocks noChangeAspect="1"/>
+          </p:cNvPicPr>
+          <p:nvPr/>
+        </p:nvPicPr>
+        <p:blipFill>
+          <a:blip r:embed="rId9">
+            <a:alphaModFix amt="12000"/>
+          </a:blip>
+          <a:stretch>
+            <a:fillRect/>
+          </a:stretch>
+        </p:blipFill>
+        <p:spPr>
+          <a:xfrm>
+            <a:off x="9227668" y="91440"/>
+            <a:ext cx="457200" cy="731520"/>
+          </a:xfrm>
+          <a:prstGeom prst="rect">
+            <a:avLst/>
+          </a:prstGeom>
+        </p:spPr>
+      </p:pic>
+      <p:pic>
+        <p:nvPicPr>
+          <p:cNvPr id="24" name="parked car 1-11" descr="preencoded.png">    </p:cNvPr>
+          <p:cNvPicPr>
+            <a:picLocks noChangeAspect="1"/>
+          </p:cNvPicPr>
+          <p:nvPr/>
+        </p:nvPicPr>
+        <p:blipFill>
+          <a:blip r:embed="rId10">
+            <a:alphaModFix amt="12000"/>
+          </a:blip>
+          <a:stretch>
+            <a:fillRect/>
+          </a:stretch>
+        </p:blipFill>
+        <p:spPr>
+          <a:xfrm>
+            <a:off x="10187788" y="91440"/>
+            <a:ext cx="457200" cy="731520"/>
+          </a:xfrm>
+          <a:prstGeom prst="rect">
+            <a:avLst/>
+          </a:prstGeom>
+        </p:spPr>
+      </p:pic>
+      <p:pic>
+        <p:nvPicPr>
+          <p:cNvPr id="25" name="parked car 1-12" descr="preencoded.png">    </p:cNvPr>
+          <p:cNvPicPr>
+            <a:picLocks noChangeAspect="1"/>
+          </p:cNvPicPr>
+          <p:nvPr/>
+        </p:nvPicPr>
+        <p:blipFill>
+          <a:blip r:embed="rId11">
+            <a:alphaModFix amt="12000"/>
+          </a:blip>
+          <a:stretch>
+            <a:fillRect/>
+          </a:stretch>
+        </p:blipFill>
+        <p:spPr>
+          <a:xfrm>
+            <a:off x="11147908" y="91440"/>
+            <a:ext cx="457200" cy="731520"/>
+          </a:xfrm>
+          <a:prstGeom prst="rect">
+            <a:avLst/>
+          </a:prstGeom>
+        </p:spPr>
+      </p:pic>
+      <p:sp>
+        <p:nvSpPr>
+          <p:cNvPr id="26" name="bay line 2-1"/>
+          <p:cNvSpPr/>
+          <p:nvPr/>
+        </p:nvSpPr>
+        <p:spPr>
+          <a:xfrm>
+            <a:off x="335128" y="5943600"/>
+            <a:ext cx="0" cy="914400"/>
+          </a:xfrm>
+          <a:prstGeom prst="line">
+            <a:avLst/>
+          </a:prstGeom>
+          <a:noFill/>
+          <a:ln w="19050">
+            <a:solidFill>
+              <a:srgbClr val="FFFFFF">
+                <a:alpha val="18000"/>
+              </a:srgbClr>
+            </a:solidFill>
+            <a:prstDash val="solid"/>
+          </a:ln>
+        </p:spPr>
+      </p:sp>
+      <p:sp>
+        <p:nvSpPr>
+          <p:cNvPr id="27" name="bay line 2-2"/>
+          <p:cNvSpPr/>
+          <p:nvPr/>
+        </p:nvSpPr>
+        <p:spPr>
+          <a:xfrm>
+            <a:off x="1295248" y="5943600"/>
+            <a:ext cx="0" cy="914400"/>
+          </a:xfrm>
+          <a:prstGeom prst="line">
+            <a:avLst/>
+          </a:prstGeom>
+          <a:noFill/>
+          <a:ln w="19050">
+            <a:solidFill>
+              <a:srgbClr val="FFFFFF">
+                <a:alpha val="18000"/>
+              </a:srgbClr>
+            </a:solidFill>
+            <a:prstDash val="solid"/>
+          </a:ln>
+        </p:spPr>
+      </p:sp>
+      <p:sp>
+        <p:nvSpPr>
+          <p:cNvPr id="28" name="bay line 2-3"/>
+          <p:cNvSpPr/>
+          <p:nvPr/>
+        </p:nvSpPr>
+        <p:spPr>
+          <a:xfrm>
+            <a:off x="2255368" y="5943600"/>
+            <a:ext cx="0" cy="914400"/>
+          </a:xfrm>
+          <a:prstGeom prst="line">
+            <a:avLst/>
+          </a:prstGeom>
+          <a:noFill/>
+          <a:ln w="19050">
+            <a:solidFill>
+              <a:srgbClr val="FFFFFF">
+                <a:alpha val="18000"/>
+              </a:srgbClr>
+            </a:solidFill>
+            <a:prstDash val="solid"/>
+          </a:ln>
+        </p:spPr>
+      </p:sp>
+      <p:sp>
+        <p:nvSpPr>
+          <p:cNvPr id="29" name="bay line 2-4"/>
+          <p:cNvSpPr/>
+          <p:nvPr/>
+        </p:nvSpPr>
+        <p:spPr>
+          <a:xfrm>
+            <a:off x="3215488" y="5943600"/>
+            <a:ext cx="0" cy="914400"/>
+          </a:xfrm>
+          <a:prstGeom prst="line">
+            <a:avLst/>
+          </a:prstGeom>
+          <a:noFill/>
+          <a:ln w="19050">
+            <a:solidFill>
+              <a:srgbClr val="FFFFFF">
+                <a:alpha val="18000"/>
+              </a:srgbClr>
+            </a:solidFill>
+            <a:prstDash val="solid"/>
+          </a:ln>
+        </p:spPr>
+      </p:sp>
+      <p:sp>
+        <p:nvSpPr>
+          <p:cNvPr id="30" name="bay line 2-5"/>
+          <p:cNvSpPr/>
+          <p:nvPr/>
+        </p:nvSpPr>
+        <p:spPr>
+          <a:xfrm>
+            <a:off x="4175608" y="5943600"/>
+            <a:ext cx="0" cy="914400"/>
+          </a:xfrm>
+          <a:prstGeom prst="line">
+            <a:avLst/>
+          </a:prstGeom>
+          <a:noFill/>
+          <a:ln w="19050">
+            <a:solidFill>
+              <a:srgbClr val="FFFFFF">
+                <a:alpha val="18000"/>
+              </a:srgbClr>
+            </a:solidFill>
+            <a:prstDash val="solid"/>
+          </a:ln>
+        </p:spPr>
+      </p:sp>
+      <p:sp>
+        <p:nvSpPr>
+          <p:cNvPr id="31" name="bay line 2-6"/>
+          <p:cNvSpPr/>
+          <p:nvPr/>
+        </p:nvSpPr>
+        <p:spPr>
+          <a:xfrm>
+            <a:off x="5135728" y="5943600"/>
+            <a:ext cx="0" cy="914400"/>
+          </a:xfrm>
+          <a:prstGeom prst="line">
+            <a:avLst/>
+          </a:prstGeom>
+          <a:noFill/>
+          <a:ln w="19050">
+            <a:solidFill>
+              <a:srgbClr val="FFFFFF">
+                <a:alpha val="18000"/>
+              </a:srgbClr>
+            </a:solidFill>
+            <a:prstDash val="solid"/>
+          </a:ln>
+        </p:spPr>
+      </p:sp>
+      <p:sp>
+        <p:nvSpPr>
+          <p:cNvPr id="32" name="bay line 2-7"/>
+          <p:cNvSpPr/>
+          <p:nvPr/>
+        </p:nvSpPr>
+        <p:spPr>
+          <a:xfrm>
+            <a:off x="6095848" y="5943600"/>
+            <a:ext cx="0" cy="914400"/>
+          </a:xfrm>
+          <a:prstGeom prst="line">
+            <a:avLst/>
+          </a:prstGeom>
+          <a:noFill/>
+          <a:ln w="19050">
+            <a:solidFill>
+              <a:srgbClr val="FFFFFF">
+                <a:alpha val="18000"/>
+              </a:srgbClr>
+            </a:solidFill>
+            <a:prstDash val="solid"/>
+          </a:ln>
+        </p:spPr>
+      </p:sp>
+      <p:sp>
+        <p:nvSpPr>
+          <p:cNvPr id="33" name="bay line 2-8"/>
+          <p:cNvSpPr/>
+          <p:nvPr/>
+        </p:nvSpPr>
+        <p:spPr>
+          <a:xfrm>
+            <a:off x="7055968" y="5943600"/>
+            <a:ext cx="0" cy="914400"/>
+          </a:xfrm>
+          <a:prstGeom prst="line">
+            <a:avLst/>
+          </a:prstGeom>
+          <a:noFill/>
+          <a:ln w="19050">
+            <a:solidFill>
+              <a:srgbClr val="FFFFFF">
+                <a:alpha val="18000"/>
+              </a:srgbClr>
+            </a:solidFill>
+            <a:prstDash val="solid"/>
+          </a:ln>
+        </p:spPr>
+      </p:sp>
+      <p:sp>
+        <p:nvSpPr>
+          <p:cNvPr id="34" name="bay line 2-9"/>
+          <p:cNvSpPr/>
+          <p:nvPr/>
+        </p:nvSpPr>
+        <p:spPr>
+          <a:xfrm>
+            <a:off x="8016088" y="5943600"/>
+            <a:ext cx="0" cy="914400"/>
+          </a:xfrm>
+          <a:prstGeom prst="line">
+            <a:avLst/>
+          </a:prstGeom>
+          <a:noFill/>
+          <a:ln w="19050">
+            <a:solidFill>
+              <a:srgbClr val="FFFFFF">
+                <a:alpha val="18000"/>
+              </a:srgbClr>
+            </a:solidFill>
+            <a:prstDash val="solid"/>
+          </a:ln>
+        </p:spPr>
+      </p:sp>
+      <p:sp>
+        <p:nvSpPr>
+          <p:cNvPr id="35" name="bay line 2-10"/>
+          <p:cNvSpPr/>
+          <p:nvPr/>
+        </p:nvSpPr>
+        <p:spPr>
+          <a:xfrm>
+            <a:off x="8976208" y="5943600"/>
+            <a:ext cx="0" cy="914400"/>
+          </a:xfrm>
+          <a:prstGeom prst="line">
+            <a:avLst/>
+          </a:prstGeom>
+          <a:noFill/>
+          <a:ln w="19050">
+            <a:solidFill>
+              <a:srgbClr val="FFFFFF">
+                <a:alpha val="18000"/>
+              </a:srgbClr>
+            </a:solidFill>
+            <a:prstDash val="solid"/>
+          </a:ln>
+        </p:spPr>
+      </p:sp>
+      <p:sp>
+        <p:nvSpPr>
+          <p:cNvPr id="36" name="bay line 2-11"/>
+          <p:cNvSpPr/>
+          <p:nvPr/>
+        </p:nvSpPr>
+        <p:spPr>
+          <a:xfrm>
+            <a:off x="9936328" y="5943600"/>
+            <a:ext cx="0" cy="914400"/>
+          </a:xfrm>
+          <a:prstGeom prst="line">
+            <a:avLst/>
+          </a:prstGeom>
+          <a:noFill/>
+          <a:ln w="19050">
+            <a:solidFill>
+              <a:srgbClr val="FFFFFF">
+                <a:alpha val="18000"/>
+              </a:srgbClr>
+            </a:solidFill>
+            <a:prstDash val="solid"/>
+          </a:ln>
+        </p:spPr>
+      </p:sp>
+      <p:sp>
+        <p:nvSpPr>
+          <p:cNvPr id="37" name="bay line 2-12"/>
+          <p:cNvSpPr/>
+          <p:nvPr/>
+        </p:nvSpPr>
+        <p:spPr>
+          <a:xfrm>
+            <a:off x="10896448" y="5943600"/>
+            <a:ext cx="0" cy="914400"/>
+          </a:xfrm>
+          <a:prstGeom prst="line">
+            <a:avLst/>
+          </a:prstGeom>
+          <a:noFill/>
+          <a:ln w="19050">
+            <a:solidFill>
+              <a:srgbClr val="FFFFFF">
+                <a:alpha val="18000"/>
+              </a:srgbClr>
+            </a:solidFill>
+            <a:prstDash val="solid"/>
+          </a:ln>
+        </p:spPr>
+      </p:sp>
+      <p:sp>
+        <p:nvSpPr>
+          <p:cNvPr id="38" name="bay line 2-13"/>
+          <p:cNvSpPr/>
+          <p:nvPr/>
+        </p:nvSpPr>
+        <p:spPr>
+          <a:xfrm>
+            <a:off x="11856568" y="5943600"/>
+            <a:ext cx="0" cy="914400"/>
+          </a:xfrm>
+          <a:prstGeom prst="line">
+            <a:avLst/>
+          </a:prstGeom>
+          <a:noFill/>
+          <a:ln w="19050">
+            <a:solidFill>
+              <a:srgbClr val="FFFFFF">
+                <a:alpha val="18000"/>
+              </a:srgbClr>
+            </a:solidFill>
+            <a:prstDash val="solid"/>
+          </a:ln>
+        </p:spPr>
+      </p:sp>
+      <p:pic>
+        <p:nvPicPr>
+          <p:cNvPr id="39" name="parked car 2-1" descr="preencoded.png">    </p:cNvPr>
+          <p:cNvPicPr>
+            <a:picLocks noChangeAspect="1"/>
+          </p:cNvPicPr>
+          <p:nvPr/>
+        </p:nvPicPr>
+        <p:blipFill>
+          <a:blip r:embed="rId12">
+            <a:alphaModFix amt="12000"/>
+          </a:blip>
+          <a:stretch>
+            <a:fillRect/>
+          </a:stretch>
+        </p:blipFill>
+        <p:spPr>
+          <a:xfrm>
+            <a:off x="586588" y="6035040"/>
+            <a:ext cx="457200" cy="731520"/>
+          </a:xfrm>
+          <a:prstGeom prst="rect">
+            <a:avLst/>
+          </a:prstGeom>
+        </p:spPr>
+      </p:pic>
+      <p:pic>
+        <p:nvPicPr>
+          <p:cNvPr id="40" name="parked car 2-3" descr="preencoded.png">    </p:cNvPr>
+          <p:cNvPicPr>
+            <a:picLocks noChangeAspect="1"/>
+          </p:cNvPicPr>
+          <p:nvPr/>
+        </p:nvPicPr>
+        <p:blipFill>
+          <a:blip r:embed="rId13">
+            <a:alphaModFix amt="12000"/>
+          </a:blip>
+          <a:stretch>
+            <a:fillRect/>
+          </a:stretch>
+        </p:blipFill>
+        <p:spPr>
+          <a:xfrm>
+            <a:off x="2506828" y="6035040"/>
+            <a:ext cx="457200" cy="731520"/>
+          </a:xfrm>
+          <a:prstGeom prst="rect">
+            <a:avLst/>
+          </a:prstGeom>
+        </p:spPr>
+      </p:pic>
+      <p:pic>
+        <p:nvPicPr>
+          <p:cNvPr id="41" name="parked car 2-4" descr="preencoded.png">    </p:cNvPr>
+          <p:cNvPicPr>
+            <a:picLocks noChangeAspect="1"/>
+          </p:cNvPicPr>
+          <p:nvPr/>
+        </p:nvPicPr>
+        <p:blipFill>
+          <a:blip r:embed="rId14">
+            <a:alphaModFix amt="12000"/>
+          </a:blip>
+          <a:stretch>
+            <a:fillRect/>
+          </a:stretch>
+        </p:blipFill>
+        <p:spPr>
+          <a:xfrm>
+            <a:off x="3466948" y="6035040"/>
+            <a:ext cx="457200" cy="731520"/>
+          </a:xfrm>
+          <a:prstGeom prst="rect">
+            <a:avLst/>
+          </a:prstGeom>
+        </p:spPr>
+      </p:pic>
+      <p:pic>
+        <p:nvPicPr>
+          <p:cNvPr id="42" name="parked car 2-5" descr="preencoded.png">    </p:cNvPr>
+          <p:cNvPicPr>
+            <a:picLocks noChangeAspect="1"/>
+          </p:cNvPicPr>
+          <p:nvPr/>
+        </p:nvPicPr>
+        <p:blipFill>
+          <a:blip r:embed="rId15">
+            <a:alphaModFix amt="12000"/>
+          </a:blip>
+          <a:stretch>
+            <a:fillRect/>
+          </a:stretch>
+        </p:blipFill>
+        <p:spPr>
+          <a:xfrm>
+            <a:off x="4427068" y="6035040"/>
+            <a:ext cx="457200" cy="731520"/>
+          </a:xfrm>
+          <a:prstGeom prst="rect">
+            <a:avLst/>
+          </a:prstGeom>
+        </p:spPr>
+      </p:pic>
+      <p:pic>
+        <p:nvPicPr>
+          <p:cNvPr id="43" name="parked car 2-6" descr="preencoded.png">    </p:cNvPr>
+          <p:cNvPicPr>
+            <a:picLocks noChangeAspect="1"/>
+          </p:cNvPicPr>
+          <p:nvPr/>
+        </p:nvPicPr>
+        <p:blipFill>
+          <a:blip r:embed="rId16">
+            <a:alphaModFix amt="12000"/>
+          </a:blip>
+          <a:stretch>
+            <a:fillRect/>
+          </a:stretch>
+        </p:blipFill>
+        <p:spPr>
+          <a:xfrm>
+            <a:off x="5387188" y="6035040"/>
+            <a:ext cx="457200" cy="731520"/>
+          </a:xfrm>
+          <a:prstGeom prst="rect">
+            <a:avLst/>
+          </a:prstGeom>
+        </p:spPr>
+      </p:pic>
+      <p:pic>
+        <p:nvPicPr>
+          <p:cNvPr id="44" name="parked car 2-7" descr="preencoded.png">    </p:cNvPr>
+          <p:cNvPicPr>
+            <a:picLocks noChangeAspect="1"/>
+          </p:cNvPicPr>
+          <p:nvPr/>
+        </p:nvPicPr>
+        <p:blipFill>
+          <a:blip r:embed="rId17">
+            <a:alphaModFix amt="12000"/>
+          </a:blip>
+          <a:stretch>
+            <a:fillRect/>
+          </a:stretch>
+        </p:blipFill>
+        <p:spPr>
+          <a:xfrm>
+            <a:off x="6347308" y="6035040"/>
+            <a:ext cx="457200" cy="731520"/>
+          </a:xfrm>
+          <a:prstGeom prst="rect">
+            <a:avLst/>
+          </a:prstGeom>
+        </p:spPr>
+      </p:pic>
+      <p:sp>
+        <p:nvSpPr>
+          <p:cNvPr id="45" name="free spot ring"/>
+          <p:cNvSpPr/>
+          <p:nvPr/>
+        </p:nvSpPr>
+        <p:spPr>
+          <a:xfrm>
+            <a:off x="7234276" y="6099048"/>
+            <a:ext cx="603504" cy="603504"/>
+          </a:xfrm>
+          <a:prstGeom prst="ellipse">
+            <a:avLst/>
+          </a:prstGeom>
+          <a:solidFill>
+            <a:schemeClr val="accent2">
+              <a:alpha val="15000"/>
+            </a:schemeClr>
+          </a:solidFill>
+          <a:ln w="15875">
+            <a:solidFill>
+              <a:srgbClr val="F2A93B">
+                <a:alpha val="60000"/>
+              </a:srgbClr>
+            </a:solidFill>
+            <a:prstDash val="solid"/>
+          </a:ln>
+        </p:spPr>
+      </p:sp>
+      <p:sp>
+        <p:nvSpPr>
+          <p:cNvPr id="46" name="free spot dot"/>
+          <p:cNvSpPr/>
+          <p:nvPr/>
+        </p:nvSpPr>
+        <p:spPr>
+          <a:xfrm>
+            <a:off x="7417156" y="6281928"/>
+            <a:ext cx="237744" cy="237744"/>
+          </a:xfrm>
+          <a:prstGeom prst="ellipse">
+            <a:avLst/>
+          </a:prstGeom>
+          <a:solidFill>
+            <a:schemeClr val="accent2"/>
+          </a:solidFill>
+          <a:ln/>
+        </p:spPr>
+      </p:sp>
+      <p:pic>
+        <p:nvPicPr>
+          <p:cNvPr id="47" name="parked car 2-9" descr="preencoded.png">    </p:cNvPr>
+          <p:cNvPicPr>
+            <a:picLocks noChangeAspect="1"/>
+          </p:cNvPicPr>
+          <p:nvPr/>
+        </p:nvPicPr>
+        <p:blipFill>
+          <a:blip r:embed="rId18">
+            <a:alphaModFix amt="12000"/>
+          </a:blip>
+          <a:stretch>
+            <a:fillRect/>
+          </a:stretch>
+        </p:blipFill>
+        <p:spPr>
+          <a:xfrm>
+            <a:off x="8267548" y="6035040"/>
+            <a:ext cx="457200" cy="731520"/>
+          </a:xfrm>
+          <a:prstGeom prst="rect">
+            <a:avLst/>
+          </a:prstGeom>
+        </p:spPr>
+      </p:pic>
+      <p:pic>
+        <p:nvPicPr>
+          <p:cNvPr id="48" name="parked car 2-10" descr="preencoded.png">    </p:cNvPr>
+          <p:cNvPicPr>
+            <a:picLocks noChangeAspect="1"/>
+          </p:cNvPicPr>
+          <p:nvPr/>
+        </p:nvPicPr>
+        <p:blipFill>
+          <a:blip r:embed="rId19">
+            <a:alphaModFix amt="12000"/>
+          </a:blip>
+          <a:stretch>
+            <a:fillRect/>
+          </a:stretch>
+        </p:blipFill>
+        <p:spPr>
+          <a:xfrm>
+            <a:off x="9227668" y="6035040"/>
+            <a:ext cx="457200" cy="731520"/>
+          </a:xfrm>
+          <a:prstGeom prst="rect">
+            <a:avLst/>
+          </a:prstGeom>
+        </p:spPr>
+      </p:pic>
+      <p:pic>
+        <p:nvPicPr>
+          <p:cNvPr id="49" name="parked car 2-11" descr="preencoded.png">    </p:cNvPr>
+          <p:cNvPicPr>
+            <a:picLocks noChangeAspect="1"/>
+          </p:cNvPicPr>
+          <p:nvPr/>
+        </p:nvPicPr>
+        <p:blipFill>
+          <a:blip r:embed="rId20">
+            <a:alphaModFix amt="12000"/>
+          </a:blip>
+          <a:stretch>
+            <a:fillRect/>
+          </a:stretch>
+        </p:blipFill>
+        <p:spPr>
+          <a:xfrm>
+            <a:off x="10187788" y="6035040"/>
+            <a:ext cx="457200" cy="731520"/>
+          </a:xfrm>
+          <a:prstGeom prst="rect">
+            <a:avLst/>
+          </a:prstGeom>
+        </p:spPr>
+      </p:pic>
+      <p:pic>
+        <p:nvPicPr>
+          <p:cNvPr id="50" name="parked car 2-12" descr="preencoded.png">    </p:cNvPr>
+          <p:cNvPicPr>
+            <a:picLocks noChangeAspect="1"/>
+          </p:cNvPicPr>
+          <p:nvPr/>
+        </p:nvPicPr>
+        <p:blipFill>
+          <a:blip r:embed="rId21">
+            <a:alphaModFix amt="12000"/>
+          </a:blip>
+          <a:stretch>
+            <a:fillRect/>
+          </a:stretch>
+        </p:blipFill>
+        <p:spPr>
+          <a:xfrm>
+            <a:off x="11147908" y="6035040"/>
+            <a:ext cx="457200" cy="731520"/>
+          </a:xfrm>
+          <a:prstGeom prst="rect">
+            <a:avLst/>
+          </a:prstGeom>
+        </p:spPr>
+      </p:pic>
+      <p:pic>
+        <p:nvPicPr>
+          <p:cNvPr id="51" name="logo mark" descr="ParkDet logo">    </p:cNvPr>
+          <p:cNvPicPr>
+            <a:picLocks noChangeAspect="1"/>
+          </p:cNvPicPr>
+          <p:nvPr/>
+        </p:nvPicPr>
+        <p:blipFill>
+          <a:blip r:embed="rId22"/>
+          <a:stretch>
+            <a:fillRect/>
+          </a:stretch>
+        </p:blipFill>
+        <p:spPr>
+          <a:xfrm>
+            <a:off x="4513936" y="1920240"/>
+            <a:ext cx="868680" cy="868680"/>
+          </a:xfrm>
+          <a:prstGeom prst="rect">
+            <a:avLst/>
+          </a:prstGeom>
+        </p:spPr>
+      </p:pic>
+      <p:sp>
+        <p:nvSpPr>
+          <p:cNvPr id="52" name="logo wordmark"/>
           <p:cNvSpPr txBox="1"/>
           <p:nvPr/>
         </p:nvSpPr>
         <p:spPr>
           <a:xfrm>
-            <a:off x="548640" y="2651760"/>
-            <a:ext cx="11094415" cy="1371600"/>
+            <a:off x="5565496" y="1920240"/>
+            <a:ext cx="2478024" cy="868680"/>
           </a:xfrm>
           <a:prstGeom prst="rect">
             <a:avLst/>
@@ -10057,6 +11362,42 @@
           <a:bodyPr wrap="square" lIns="0" tIns="0" rIns="0" bIns="0" rtlCol="0" anchor="ctr"/>
           <a:lstStyle/>
           <a:p>
+            <a:pPr indent="0" marL="0">
+              <a:buNone/>
+            </a:pPr>
+            <a:r>
+              <a:rPr lang="en-US" sz="4400" b="1" dirty="0">
+                <a:solidFill>
+                  <a:schemeClr val="bg1"/>
+                </a:solidFill>
+              </a:rPr>
+              <a:t>ParkDet</a:t>
+            </a:r>
+            <a:endParaRPr lang="en-US" sz="4400" dirty="0"/>
+          </a:p>
+        </p:txBody>
+      </p:sp>
+      <p:sp>
+        <p:nvSpPr>
+          <p:cNvPr id="53" name="thanks"/>
+          <p:cNvSpPr txBox="1"/>
+          <p:nvPr/>
+        </p:nvSpPr>
+        <p:spPr>
+          <a:xfrm>
+            <a:off x="548640" y="3017520"/>
+            <a:ext cx="11094415" cy="1051560"/>
+          </a:xfrm>
+          <a:prstGeom prst="rect">
+            <a:avLst/>
+          </a:prstGeom>
+          <a:noFill/>
+          <a:ln/>
+        </p:spPr>
+        <p:txBody>
+          <a:bodyPr wrap="square" lIns="0" tIns="0" rIns="0" bIns="0" rtlCol="0" anchor="ctr"/>
+          <a:lstStyle/>
+          <a:p>
             <a:pPr algn="ctr" indent="0" marL="0">
               <a:buNone/>
             </a:pPr>
@@ -10069,6 +11410,109 @@
               <a:t>Thanks for watching</a:t>
             </a:r>
             <a:endParaRPr lang="en-US" sz="6000" dirty="0"/>
+          </a:p>
+        </p:txBody>
+      </p:sp>
+      <p:sp>
+        <p:nvSpPr>
+          <p:cNvPr id="54" name="divider"/>
+          <p:cNvSpPr/>
+          <p:nvPr/>
+        </p:nvSpPr>
+        <p:spPr>
+          <a:xfrm>
+            <a:off x="5684368" y="4270248"/>
+            <a:ext cx="822960" cy="0"/>
+          </a:xfrm>
+          <a:prstGeom prst="line">
+            <a:avLst/>
+          </a:prstGeom>
+          <a:noFill/>
+          <a:ln w="31750">
+            <a:solidFill>
+              <a:srgbClr val="F2A93B"/>
+            </a:solidFill>
+            <a:prstDash val="solid"/>
+          </a:ln>
+        </p:spPr>
+      </p:sp>
+      <p:sp>
+        <p:nvSpPr>
+          <p:cNvPr id="55" name="tagline"/>
+          <p:cNvSpPr txBox="1"/>
+          <p:nvPr/>
+        </p:nvSpPr>
+        <p:spPr>
+          <a:xfrm>
+            <a:off x="548640" y="4453128"/>
+            <a:ext cx="11094415" cy="457200"/>
+          </a:xfrm>
+          <a:prstGeom prst="rect">
+            <a:avLst/>
+          </a:prstGeom>
+          <a:noFill/>
+          <a:ln/>
+        </p:spPr>
+        <p:txBody>
+          <a:bodyPr wrap="square" lIns="0" tIns="0" rIns="0" bIns="0" rtlCol="0" anchor="ctr"/>
+          <a:lstStyle/>
+          <a:p>
+            <a:pPr algn="ctr" indent="0" marL="0">
+              <a:buNone/>
+            </a:pPr>
+            <a:r>
+              <a:rPr lang="en-US" sz="2200" b="1" dirty="0">
+                <a:solidFill>
+                  <a:schemeClr val="accent2"/>
+                </a:solidFill>
+              </a:rPr>
+              <a:t>Park</a:t>
+            </a:r>
+            <a:pPr algn="ctr" indent="0" marL="0">
+              <a:buNone/>
+            </a:pPr>
+            <a:r>
+              <a:rPr lang="en-US" sz="2200" dirty="0">
+                <a:solidFill>
+                  <a:schemeClr val="accent5"/>
+                </a:solidFill>
+              </a:rPr>
+              <a:t>ing </a:t>
+            </a:r>
+            <a:pPr algn="ctr" indent="0" marL="0">
+              <a:buNone/>
+            </a:pPr>
+            <a:r>
+              <a:rPr lang="en-US" sz="2200" b="1" dirty="0">
+                <a:solidFill>
+                  <a:schemeClr val="accent2"/>
+                </a:solidFill>
+              </a:rPr>
+              <a:t>Det</a:t>
+            </a:r>
+            <a:pPr algn="ctr" indent="0" marL="0">
+              <a:buNone/>
+            </a:pPr>
+            <a:r>
+              <a:rPr lang="en-US" sz="2200" dirty="0">
+                <a:solidFill>
+                  <a:schemeClr val="accent5"/>
+                </a:solidFill>
+              </a:rPr>
+              <a:t>ector</a:t>
+            </a:r>
+            <a:pPr algn="ctr" indent="0" marL="0">
+              <a:buNone/>
+            </a:pPr>
+            <a:r>
+              <a:rPr lang="en-US" sz="2200" dirty="0">
+                <a:solidFill>
+                  <a:schemeClr val="accent5"/>
+                </a:solidFill>
+              </a:rPr>
+              <a:t>  ·  Free parking spots, seen live</a:t>
+            </a:r>
+            <a:endParaRPr lang="en-US" sz="2200" dirty="0"/>
           </a:p>
         </p:txBody>
       </p:sp>

</xml_diff>

<commit_message>
Spot colours green/yellow/red, liquid-glass menu; deck pictures in the new colours
- Spot map: green = free, yellow = reserved (booked in advance), red = taken (a car is parked);
  legend and the lot / operator counts use the same words and colours
- Bottom menu: frosted glass bar with a glass bubble that stretches and slides to the tapped item;
  switching section slides the page in from that side (View Transitions, plain switch elsewhere)
- Deck: cover spot map and the Find me a spot screen re-taken from a test run in the new colours

Co-Authored-By: Claude Opus 5.5 <noreply@anthropic.com>
Claude-Session: https://claude.ai/code/session_012xGpHDRSu2Z8JV7eYDeD26
</commit_message>
<xml_diff>
--- a/docs/ParkDet-defence.pptx
+++ b/docs/ParkDet-defence.pptx
@@ -114,34 +114,34 @@
   <p:extLst>
     <p:ext uri="{521415D9-36F7-43E2-AB2F-B90AF26B5E84}">
       <p14:sectionLst xmlns:p14="http://schemas.microsoft.com/office/powerpoint/2010/main">
-        <p14:section name="Problem and solution (1:00)" id="{3df3bd15-68ea-8c9f-159d-5500fa953081}">
+        <p14:section name="Problem and solution (1:00)" id="{1c865da4-cd21-4c11-b602-749772fd3789}">
           <p14:sldIdLst>
             <p14:sldId id="256"/>
             <p14:sldId id="257"/>
           </p14:sldIdLst>
         </p14:section>
-        <p14:section name="Demo (2:20)" id="{4231b319-ee86-0582-9d06-63a094c5ba85}">
+        <p14:section name="Demo (2:20)" id="{7492c269-e5a5-92c4-a728-f178ccc9490d}">
           <p14:sldIdLst>
             <p14:sldId id="258"/>
             <p14:sldId id="259"/>
           </p14:sldIdLst>
         </p14:section>
-        <p14:section name="Technology (1:25)" id="{8fcc1300-b30a-7c6b-e2e9-2cdb8f8360ef}">
+        <p14:section name="Technology (1:25)" id="{e5616576-2c3c-36d9-6d9f-538e5af0f846}">
           <p14:sldIdLst>
             <p14:sldId id="260"/>
           </p14:sldIdLst>
         </p14:section>
-        <p14:section name="Competitors (0:45)" id="{f6673b8c-b509-9644-80c9-8f97ccc7e2f4}">
+        <p14:section name="Competitors (0:45)" id="{9e53bd0f-6fa1-c0e2-b5ed-e2612916ab2d}">
           <p14:sldIdLst>
             <p14:sldId id="261"/>
           </p14:sldIdLst>
         </p14:section>
-        <p14:section name="Business and pilot (1:20)" id="{ac7c6137-42cc-1285-3508-59690157f01f}">
+        <p14:section name="Business and pilot (1:20)" id="{b918ab68-4441-64d7-7f66-a5a8f9e9e2d5}">
           <p14:sldIdLst>
             <p14:sldId id="262"/>
           </p14:sldIdLst>
         </p14:section>
-        <p14:section name="Close (0:10)" id="{e318916c-8724-c0c3-8c01-2e89c583a783}">
+        <p14:section name="Close (0:10)" id="{8f32843f-f224-d088-510d-d58007c17b69}">
           <p14:sldIdLst>
             <p14:sldId id="263"/>
           </p14:sldIdLst>
@@ -552,7 +552,7 @@
               <a:rPr lang="en-US" dirty="0"/>
               <a:t>SPEAKER: Bahodurov Bahridin · 0:00–0:15
 "Good afternoon. We are team ALL-IN-ONE and this is ParkDet — short for Parking Detector — a Startup-mode product for the Computer Vision track. ParkDet shows free parking spots, live."
-(The phone shows our app's live spot map from a test run: green = free, orange = booked, grey = occupied — swap in a WIUT screenshot once your lot is live.)</a:t>
+(The phone shows our app's live spot map from a test run: green = free, yellow = reserved, red = taken (a car is parked) — swap in a WIUT screenshot once your lot is live.)</a:t>
             </a:r>
             <a:endParaRPr lang="en-US" dirty="0"/>
           </a:p>
@@ -2525,12 +2525,12 @@
         </p:nvSpPr>
         <p:spPr>
           <a:xfrm>
-            <a:off x="9361033" y="548640"/>
-            <a:ext cx="2297567" cy="5760720"/>
+            <a:off x="9369924" y="548640"/>
+            <a:ext cx="2288676" cy="5760720"/>
           </a:xfrm>
           <a:prstGeom prst="roundRect">
             <a:avLst>
-              <a:gd name="adj" fmla="val 9950"/>
+              <a:gd name="adj" fmla="val 9988"/>
             </a:avLst>
           </a:prstGeom>
           <a:solidFill>
@@ -2543,7 +2543,7 @@
       </p:sp>
       <p:pic>
         <p:nvPicPr>
-          <p:cNvPr id="17" name="app screenshot" descr="ParkDet driver app: a lot's live spot map with free (green), booked (orange) and occupied (grey) spots">    </p:cNvPr>
+          <p:cNvPr id="17" name="app screenshot" descr="ParkDet driver app: a lot's live spot map with free (green), reserved (yellow) and taken (red) spots">    </p:cNvPr>
           <p:cNvPicPr>
             <a:picLocks noChangeAspect="1"/>
           </p:cNvPicPr>
@@ -2557,8 +2557,8 @@
         </p:blipFill>
         <p:spPr>
           <a:xfrm>
-            <a:off x="9507337" y="694944"/>
-            <a:ext cx="2004959" cy="5029200"/>
+            <a:off x="9516228" y="694944"/>
+            <a:ext cx="1996068" cy="5029200"/>
           </a:xfrm>
           <a:prstGeom prst="rect">
             <a:avLst/>
@@ -2573,8 +2573,8 @@
         </p:nvSpPr>
         <p:spPr>
           <a:xfrm>
-            <a:off x="9361033" y="5788152"/>
-            <a:ext cx="2297567" cy="475488"/>
+            <a:off x="9369924" y="5788152"/>
+            <a:ext cx="2288676" cy="475488"/>
           </a:xfrm>
           <a:prstGeom prst="rect">
             <a:avLst/>
@@ -2606,10 +2606,65 @@
             <a:r>
               <a:rPr lang="en-US" sz="1100" dirty="0">
                 <a:solidFill>
+                  <a:srgbClr val="18A058"/>
+                </a:solidFill>
+              </a:rPr>
+              <a:t>● </a:t>
+            </a:r>
+            <a:pPr algn="ctr" indent="0" marL="0">
+              <a:buNone/>
+            </a:pPr>
+            <a:r>
+              <a:rPr lang="en-US" sz="1100" dirty="0">
+                <a:solidFill>
                   <a:schemeClr val="accent5"/>
                 </a:solidFill>
               </a:rPr>
-              <a:t>green = free · orange = booked</a:t>
+              <a:t>free   </a:t>
+            </a:r>
+            <a:pPr algn="ctr" indent="0" marL="0">
+              <a:buNone/>
+            </a:pPr>
+            <a:r>
+              <a:rPr lang="en-US" sz="1100" dirty="0">
+                <a:solidFill>
+                  <a:srgbClr val="EAB308"/>
+                </a:solidFill>
+              </a:rPr>
+              <a:t>● </a:t>
+            </a:r>
+            <a:pPr algn="ctr" indent="0" marL="0">
+              <a:buNone/>
+            </a:pPr>
+            <a:r>
+              <a:rPr lang="en-US" sz="1100" dirty="0">
+                <a:solidFill>
+                  <a:schemeClr val="accent5"/>
+                </a:solidFill>
+              </a:rPr>
+              <a:t>reserved   </a:t>
+            </a:r>
+            <a:pPr algn="ctr" indent="0" marL="0">
+              <a:buNone/>
+            </a:pPr>
+            <a:r>
+              <a:rPr lang="en-US" sz="1100" dirty="0">
+                <a:solidFill>
+                  <a:srgbClr val="E5484D"/>
+                </a:solidFill>
+              </a:rPr>
+              <a:t>● </a:t>
+            </a:r>
+            <a:pPr algn="ctr" indent="0" marL="0">
+              <a:buNone/>
+            </a:pPr>
+            <a:r>
+              <a:rPr lang="en-US" sz="1100" dirty="0">
+                <a:solidFill>
+                  <a:schemeClr val="accent5"/>
+                </a:solidFill>
+              </a:rPr>
+              <a:t>taken</a:t>
             </a:r>
             <a:endParaRPr lang="en-US" sz="1100" dirty="0"/>
           </a:p>
@@ -5139,7 +5194,7 @@
                   <a:schemeClr val="tx2"/>
                 </a:solidFill>
               </a:rPr>
-              <a:t>Screens from a test run of the app; payment is in test mode</a:t>
+              <a:t>Screens from test runs of the app; payment is in test mode</a:t>
             </a:r>
             <a:endParaRPr lang="en-US" sz="1000" dirty="0"/>
           </a:p>

</xml_diff>

<commit_message>
Docs and deck follow the new walk-in: QR scan, first hour paid automatically
- README and code guide: Spots tab, QR scanner (Scan.jsx, jsQR credited), walk-in flow, hold rule
- Deck: slide 2 'QR at the gate, paid automatically'; slide 4 walk-in screen and caption re-taken
  from a test run, Find me a spot cropped above the menu

Co-Authored-By: Claude Opus 5.5 <noreply@anthropic.com>
Claude-Session: https://claude.ai/code/session_012xGpHDRSu2Z8JV7eYDeD26
</commit_message>
<xml_diff>
--- a/docs/ParkDet-defence.pptx
+++ b/docs/ParkDet-defence.pptx
@@ -114,34 +114,34 @@
   <p:extLst>
     <p:ext uri="{521415D9-36F7-43E2-AB2F-B90AF26B5E84}">
       <p14:sectionLst xmlns:p14="http://schemas.microsoft.com/office/powerpoint/2010/main">
-        <p14:section name="Problem and solution (1:00)" id="{1c865da4-cd21-4c11-b602-749772fd3789}">
+        <p14:section name="Problem and solution (1:00)" id="{352f5dbe-d5ae-e188-7e50-f2ab9aaec0ef}">
           <p14:sldIdLst>
             <p14:sldId id="256"/>
             <p14:sldId id="257"/>
           </p14:sldIdLst>
         </p14:section>
-        <p14:section name="Demo (2:20)" id="{7492c269-e5a5-92c4-a728-f178ccc9490d}">
+        <p14:section name="Demo (2:20)" id="{8aa4f189-41ba-1dd2-34ba-ea5bab81427f}">
           <p14:sldIdLst>
             <p14:sldId id="258"/>
             <p14:sldId id="259"/>
           </p14:sldIdLst>
         </p14:section>
-        <p14:section name="Technology (1:25)" id="{e5616576-2c3c-36d9-6d9f-538e5af0f846}">
+        <p14:section name="Technology (1:25)" id="{9190ac55-e7ba-c580-3290-a6b74b2242c2}">
           <p14:sldIdLst>
             <p14:sldId id="260"/>
           </p14:sldIdLst>
         </p14:section>
-        <p14:section name="Competitors (0:45)" id="{9e53bd0f-6fa1-c0e2-b5ed-e2612916ab2d}">
+        <p14:section name="Competitors (0:45)" id="{7471345d-982f-3ba5-26c7-66f40d9e9b53}">
           <p14:sldIdLst>
             <p14:sldId id="261"/>
           </p14:sldIdLst>
         </p14:section>
-        <p14:section name="Business and pilot (1:20)" id="{b918ab68-4441-64d7-7f66-a5a8f9e9e2d5}">
+        <p14:section name="Business and pilot (1:20)" id="{a10778e7-cb90-0443-a488-46585a8aca76}">
           <p14:sldIdLst>
             <p14:sldId id="262"/>
           </p14:sldIdLst>
         </p14:section>
-        <p14:section name="Close (0:10)" id="{8f32843f-f224-d088-510d-d58007c17b69}">
+        <p14:section name="Close (0:10)" id="{779fbbbf-8d99-86dd-785b-b8d800726d0c}">
           <p14:sldIdLst>
             <p14:sldId id="263"/>
           </p14:sldIdLst>
@@ -642,7 +642,7 @@
               <a:rPr lang="en-US" dirty="0"/>
               <a:t>SPEAKER: Bahodurov Bahridin · 0:15–1:00
 "Everyone here has circled a parking lot. Drivers don't know where the free spot is and can't reserve one. Elderly drivers get lost in big lots with small signs. And the operator often already has cameras, but gets no data from them.
-ParkDet fixes this with one phone camera per lot: it sees every spot, with no sensors. Drivers see free spots live on a map and navigate to the entrance. They book ahead, or just walk in with a QR code at the gate and pay before they leave. And they get big, simple directions: 'B5, straight 25 metres, then right'."
+ParkDet fixes this with one phone camera per lot: it sees every spot, with no sensors. Drivers see free spots live on a map and navigate to the entrance. They book ahead, or just walk in: scan the QR code at the gate and the first hour is paid automatically. And they get big, simple directions: 'B5, straight 25 metres, then right'."
 If the team has real evidence (interviews, a timed drive around a lot), add ONE sentence here — never invent numbers.</a:t>
             </a:r>
             <a:endParaRPr lang="en-US" dirty="0"/>
@@ -828,7 +828,7 @@
             <a:r>
               <a:rPr lang="en-US" dirty="0"/>
               <a:t>SPEAKER: Gopurjonov Bobur · 3:00–3:20
-"Here are the app's main screens: nearby lots with live free spots and Navigate; Find me a spot, which picks the nearest free spot; the ticket with its QR code and a countdown of how long the spot is held; the walk-in page from the gate QR, where you pay before leaving; and the entrance screen." Hand over to Amirxon.</a:t>
+"Here are the app's main screens: nearby lots with live free spots and Navigate; Find me a spot, which picks the nearest free spot; the ticket with its QR code and a countdown of how long the spot is held; the walk-in page after scanning the gate QR with the round button in the menu: the first hour is already paid, and you choose a spot or just park; and the entrance screen." Hand over to Amirxon.</a:t>
             </a:r>
             <a:endParaRPr lang="en-US" dirty="0"/>
           </a:p>
@@ -3503,7 +3503,7 @@
                   <a:schemeClr val="tx2"/>
                 </a:solidFill>
               </a:rPr>
-              <a:t>QR at the gate, pay before exit</a:t>
+              <a:t>QR at the gate, paid automatically</a:t>
             </a:r>
             <a:endParaRPr lang="en-US" sz="1400" dirty="0"/>
           </a:p>
@@ -4730,8 +4730,8 @@
         </p:blipFill>
         <p:spPr>
           <a:xfrm>
-            <a:off x="3131956" y="1709928"/>
-            <a:ext cx="1398577" cy="3026664"/>
+            <a:off x="3046926" y="1709928"/>
+            <a:ext cx="1568636" cy="3026664"/>
           </a:xfrm>
           <a:prstGeom prst="rect">
             <a:avLst/>
@@ -4966,8 +4966,8 @@
         </p:blipFill>
         <p:spPr>
           <a:xfrm>
-            <a:off x="7567172" y="1709928"/>
-            <a:ext cx="1586558" cy="3026664"/>
+            <a:off x="7452177" y="1986611"/>
+            <a:ext cx="1816547" cy="2473299"/>
           </a:xfrm>
           <a:prstGeom prst="rect">
             <a:avLst/>
@@ -5040,7 +5040,7 @@
                   <a:schemeClr val="tx2"/>
                 </a:solidFill>
               </a:rPr>
-              <a:t>Scan the gate QR, get a spot, pay before leaving</a:t>
+              <a:t>Scan the gate QR: first hour paid automatically; choose a spot or just park</a:t>
             </a:r>
             <a:endParaRPr lang="en-US" sz="1200" dirty="0"/>
           </a:p>

</xml_diff>